<commit_message>
Ajout de slides explicatifs dans le deck LAM_slides
</commit_message>
<xml_diff>
--- a/_slides/remanies/13. LAM_slides.pptx
+++ b/_slides/remanies/13. LAM_slides.pptx
@@ -27,7 +27,8 @@
     <p:sldId id="579" r:id="rId15"/>
     <p:sldId id="580" r:id="rId16"/>
     <p:sldId id="581" r:id="rId17"/>
-    <p:sldId id="582" r:id="rId18"/>
+    <p:sldId id="588" r:id="rId28"/>
+    <p:sldId id="589" r:id="rId29"/>
     <p:sldId id="583" r:id="rId19"/>
     <p:sldId id="584" r:id="rId20"/>
     <p:sldId id="585" r:id="rId21"/>
@@ -906,6 +907,12 @@
               <a:t>Une lambda est donc un objet comme un autre : on la range dans une variable, on la passe en paramètre, on la met dans un tableau.</a:t>
             </a:r>
           </a:p>
+          <a:p>
+            <a:r>
+              <a:rPr lang="fr-BE" dirty="0"/>
+              <a:t>Le code complet, à exécuter : demos, classe demo.lam.slides.LesFormesDUneLambda.</a:t>
+            </a:r>
+          </a:p>
         </p:txBody>
       </p:sp>
       <p:sp>
@@ -1049,6 +1056,12 @@
               <a:t> redevient obligatoire, comme dans une méthode. Un corps en bloc est permis, mais s'il s'allonge, c'est le signe qu'il mérite un nom. La section suivante dit comment le lui donner.</a:t>
             </a:r>
           </a:p>
+          <a:p>
+            <a:r>
+              <a:rPr lang="fr-BE" dirty="0"/>
+              <a:t>Le code complet, à exécuter : demos, classe demo.lam.slides.LesFormesDUneLambda.</a:t>
+            </a:r>
+          </a:p>
         </p:txBody>
       </p:sp>
       <p:sp>
@@ -1527,6 +1540,12 @@
               <a:t> l'impose, comme au module COL : la lambda doit le nommer, même sans s'en servir.</a:t>
             </a:r>
           </a:p>
+          <a:p>
+            <a:r>
+              <a:rPr lang="fr-BE" dirty="0"/>
+              <a:t>Le code complet, à exécuter : demos, classe demo.lam.slides.LesMethodesDeCOLSansClasse.</a:t>
+            </a:r>
+          </a:p>
         </p:txBody>
       </p:sp>
       <p:sp>
@@ -1690,215 +1709,10 @@
               <a:t>.</a:t>
             </a:r>
           </a:p>
-        </p:txBody>
-      </p:sp>
-      <p:sp>
-        <p:nvSpPr>
-          <p:cNvPr id="4" name="Slide Number Placeholder 3"/>
-          <p:cNvSpPr>
-            <a:spLocks noGrp="1"/>
-          </p:cNvSpPr>
-          <p:nvPr>
-            <p:ph type="sldNum" sz="quarter" idx="5"/>
-          </p:nvPr>
-        </p:nvSpPr>
-        <p:spPr/>
-      </p:sp>
-    </p:spTree>
-  </p:cSld>
-  <p:clrMapOvr>
-    <a:masterClrMapping/>
-  </p:clrMapOvr>
-</p:notes>
-</file>
-
-<file path=ppt/notesSlides/notesSlide17.xml><?xml version="1.0" encoding="utf-8"?>
-<p:notes xmlns:a="http://schemas.openxmlformats.org/drawingml/2006/main" xmlns:r="http://schemas.openxmlformats.org/officeDocument/2006/relationships" xmlns:p="http://schemas.openxmlformats.org/presentationml/2006/main">
-  <p:cSld>
-    <p:spTree>
-      <p:nvGrpSpPr>
-        <p:cNvPr id="1" name=""/>
-        <p:cNvGrpSpPr/>
-        <p:nvPr/>
-      </p:nvGrpSpPr>
-      <p:grpSpPr>
-        <a:xfrm>
-          <a:off x="0" y="0"/>
-          <a:ext cx="0" cy="0"/>
-          <a:chOff x="0" y="0"/>
-          <a:chExt cx="0" cy="0"/>
-        </a:xfrm>
-      </p:grpSpPr>
-      <p:sp>
-        <p:nvSpPr>
-          <p:cNvPr id="2" name="Slide Image Placeholder 1"/>
-          <p:cNvSpPr>
-            <a:spLocks noGrp="1" noRot="1" noChangeAspect="1"/>
-          </p:cNvSpPr>
-          <p:nvPr>
-            <p:ph type="sldImg" idx="2"/>
-          </p:nvPr>
-        </p:nvSpPr>
-        <p:spPr/>
-      </p:sp>
-      <p:sp>
-        <p:nvSpPr>
-          <p:cNvPr id="3" name="Notes Placeholder 2"/>
-          <p:cNvSpPr>
-            <a:spLocks noGrp="1"/>
-          </p:cNvSpPr>
-          <p:nvPr>
-            <p:ph type="body" sz="quarter" idx="3"/>
-          </p:nvPr>
-        </p:nvSpPr>
-        <p:spPr/>
-        <p:txBody>
-          <a:bodyPr/>
-          <a:lstStyle/>
-          <a:p>
-            <a:r>
-              <a:t>Slide facultative, que l'on peut sauter en classe. Elle montre où mènent les lambdas quand on les enchaîne.</a:t>
-            </a:r>
-          </a:p>
-          <a:p>
-            <a:r>
-              <a:t>La méthode </a:t>
-            </a:r>
-            <a:r>
-              <a:rPr>
-                <a:latin typeface="Consolas"/>
-              </a:rPr>
-              <a:t>stream</a:t>
-            </a:r>
-            <a:r>
-              <a:t> ouvre un flux sur les éléments de la liste. La méthode </a:t>
-            </a:r>
-            <a:r>
-              <a:rPr>
-                <a:latin typeface="Consolas"/>
-              </a:rPr>
-              <a:t>filter</a:t>
-            </a:r>
-            <a:r>
-              <a:t> reçoit un </a:t>
-            </a:r>
-            <a:r>
-              <a:rPr>
-                <a:latin typeface="Consolas"/>
-              </a:rPr>
-              <a:t>Predicate</a:t>
-            </a:r>
-            <a:r>
-              <a:t> et ne laisse passer que les titres qu'il accepte. La méthode </a:t>
-            </a:r>
-            <a:r>
-              <a:rPr>
-                <a:latin typeface="Consolas"/>
-              </a:rPr>
-              <a:t>map</a:t>
-            </a:r>
-            <a:r>
-              <a:t> reçoit une </a:t>
-            </a:r>
-            <a:r>
-              <a:rPr>
-                <a:latin typeface="Consolas"/>
-              </a:rPr>
-              <a:t>Function</a:t>
-            </a:r>
-            <a:r>
-              <a:t> et transforme chaque titre. Enfin </a:t>
-            </a:r>
-            <a:r>
-              <a:rPr>
-                <a:latin typeface="Consolas"/>
-              </a:rPr>
-              <a:t>collect</a:t>
-            </a:r>
-            <a:r>
-              <a:t> rassemble ce qui reste ; </a:t>
-            </a:r>
-            <a:r>
-              <a:rPr>
-                <a:latin typeface="Consolas"/>
-              </a:rPr>
-              <a:t>Collectors.joining</a:t>
-            </a:r>
-            <a:r>
-              <a:t> en fait une seule chaîne, avec le séparateur donné.</a:t>
-            </a:r>
-          </a:p>
-          <a:p>
-            <a:r>
-              <a:t>Contrairement à </a:t>
-            </a:r>
-            <a:r>
-              <a:rPr>
-                <a:latin typeface="Consolas"/>
-              </a:rPr>
-              <a:t>removeIf</a:t>
-            </a:r>
-            <a:r>
-              <a:t>, rien n'est retiré de </a:t>
-            </a:r>
-            <a:r>
-              <a:rPr>
-                <a:latin typeface="Consolas"/>
-              </a:rPr>
-              <a:t>titres</a:t>
-            </a:r>
-            <a:r>
-              <a:t> : le stream produit un résultat neuf. Le code se lit comme une phrase, étape par étape, et dit ce qu'il fait plutôt que comment il le fait.</a:t>
-            </a:r>
-          </a:p>
-          <a:p>
-            <a:r>
-              <a:t>Pour un tableau d'entiers, </a:t>
-            </a:r>
-            <a:r>
-              <a:rPr>
-                <a:latin typeface="Consolas"/>
-              </a:rPr>
-              <a:t>Arrays.stream(tableau)</a:t>
-            </a:r>
-            <a:r>
-              <a:t> ouvre le même enchaînement. Comme les éléments sont des </a:t>
-            </a:r>
-            <a:r>
-              <a:rPr>
-                <a:latin typeface="Consolas"/>
-              </a:rPr>
-              <a:t>int</a:t>
-            </a:r>
-            <a:r>
-              <a:t>, </a:t>
-            </a:r>
-            <a:r>
-              <a:rPr>
-                <a:latin typeface="Consolas"/>
-              </a:rPr>
-              <a:t>mapToObj</a:t>
-            </a:r>
-            <a:r>
-              <a:t> les transforme alors en objets, par exemple en chaînes avec </a:t>
-            </a:r>
-            <a:r>
-              <a:rPr>
-                <a:latin typeface="Consolas"/>
-              </a:rPr>
-              <a:t>String::valueOf</a:t>
-            </a:r>
-            <a:r>
-              <a:t>, avant de les joindre. C'est de quoi répondre à la dernière question de </a:t>
-            </a:r>
-            <a:r>
-              <a:rPr>
-                <a:latin typeface="Consolas"/>
-              </a:rPr>
-              <a:t>LAM.3</a:t>
-            </a:r>
-            <a:r>
-              <a:t>.</a:t>
+          <a:p>
+            <a:r>
+              <a:rPr lang="fr-BE" dirty="0"/>
+              <a:t>Le code complet, à exécuter : demos, classe demo.lam.slides.DeLaClasseALaLambda.</a:t>
             </a:r>
           </a:p>
         </p:txBody>
@@ -2358,6 +2172,190 @@
 </p:notes>
 </file>
 
+<file path=ppt/notesSlides/notesSlide21.xml><?xml version="1.0" encoding="utf-8"?>
+<p:notes xmlns:a="http://schemas.openxmlformats.org/drawingml/2006/main" xmlns:p="http://schemas.openxmlformats.org/presentationml/2006/main" xmlns:r="http://schemas.openxmlformats.org/officeDocument/2006/relationships">
+  <p:cSld>
+    <p:spTree>
+      <p:nvGrpSpPr>
+        <p:cNvPr id="1" name=""/>
+        <p:cNvGrpSpPr/>
+        <p:nvPr/>
+      </p:nvGrpSpPr>
+      <p:grpSpPr>
+        <a:xfrm>
+          <a:off x="0" y="0"/>
+          <a:ext cx="0" cy="0"/>
+          <a:chOff x="0" y="0"/>
+          <a:chExt cx="0" cy="0"/>
+        </a:xfrm>
+      </p:grpSpPr>
+      <p:sp>
+        <p:nvSpPr>
+          <p:cNvPr id="2" name="Slide Image Placeholder 1"/>
+          <p:cNvSpPr>
+            <a:spLocks noGrp="1"/>
+          </p:cNvSpPr>
+          <p:nvPr>
+            <p:ph type="sldImg" idx="2"/>
+          </p:nvPr>
+        </p:nvSpPr>
+        <p:spPr/>
+      </p:sp>
+      <p:sp>
+        <p:nvSpPr>
+          <p:cNvPr id="3" name="Notes Placeholder 2"/>
+          <p:cNvSpPr>
+            <a:spLocks noGrp="1"/>
+          </p:cNvSpPr>
+          <p:nvPr>
+            <p:ph type="body" idx="3" sz="quarter"/>
+          </p:nvPr>
+        </p:nvSpPr>
+        <p:spPr/>
+        <p:txBody>
+          <a:bodyPr/>
+          <a:lstStyle/>
+          <a:p>
+            <a:r>
+              <a:t>Slide facultative, que l'on peut sauter en classe. Elle montre où mènent les lambdas quand on les enchaîne.</a:t>
+            </a:r>
+          </a:p>
+          <a:p>
+            <a:r>
+              <a:t>Un stream n'est pas une collection : c'est un passage. Les éléments de la liste y entrent l'un après l'autre et traversent des étapes, chacune décrite par une lambda. Le code se lit de haut en bas, comme une recette.</a:t>
+            </a:r>
+          </a:p>
+          <a:p>
+            <a:r>
+              <a:t>Première étape, stream ouvre le flux sur les titres de la liste. Deuxième, filter reçoit un Predicate, le même genre d'objet que removeIf, et ne laisse passer que les titres qu'il accepte : ici, les titres longs. Troisième, map reçoit une Function et transforme chaque titre qui passe : ici, en majuscules. Le nombre d'éléments ne change pas, seule leur forme change. Dernière étape, collect rassemble ce qui sort du flux en un résultat ; Collectors.joining en fait une seule chaîne, avec le séparateur donné.</a:t>
+            </a:r>
+          </a:p>
+          <a:p>
+            <a:r>
+              <a:t>La différence avec removeIf est essentielle : removeIf retire des éléments de la liste elle-même, alors que le stream laisse titres intacte et produit un résultat neuf, ici une String. La slide suivante suit quatre titres à travers les étapes.</a:t>
+            </a:r>
+          </a:p>
+          <a:p>
+            <a:r>
+              <a:t>Pour un tableau d'entiers, Arrays.stream(tableau) ouvre le même enchaînement. Comme les éléments sont des int, mapToObj les transforme alors en objets, par exemple en chaînes avec String::valueOf, avant de les joindre. C'est de quoi répondre à la dernière question de LAM.3.</a:t>
+            </a:r>
+          </a:p>
+          <a:p>
+            <a:r>
+              <a:t>Le code complet, à exécuter : demos, classe </a:t>
+            </a:r>
+            <a:r>
+              <a:rPr>
+                <a:latin typeface="Consolas"/>
+              </a:rPr>
+              <a:t>demo.lam.slides.LesMethodesDeCOLSansClasse</a:t>
+            </a:r>
+            <a:r>
+              <a:t>.</a:t>
+            </a:r>
+          </a:p>
+        </p:txBody>
+      </p:sp>
+      <p:sp>
+        <p:nvSpPr>
+          <p:cNvPr id="4" name="Slide Number Placeholder 3"/>
+          <p:cNvSpPr>
+            <a:spLocks noGrp="1"/>
+          </p:cNvSpPr>
+          <p:nvPr>
+            <p:ph type="sldNum" idx="5" sz="quarter"/>
+          </p:nvPr>
+        </p:nvSpPr>
+        <p:spPr/>
+      </p:sp>
+    </p:spTree>
+  </p:cSld>
+  <p:clrMapOvr>
+    <a:masterClrMapping/>
+  </p:clrMapOvr>
+</p:notes>
+</file>
+
+<file path=ppt/notesSlides/notesSlide22.xml><?xml version="1.0" encoding="utf-8"?>
+<p:notes xmlns:a="http://schemas.openxmlformats.org/drawingml/2006/main" xmlns:p="http://schemas.openxmlformats.org/presentationml/2006/main" xmlns:r="http://schemas.openxmlformats.org/officeDocument/2006/relationships">
+  <p:cSld>
+    <p:spTree>
+      <p:nvGrpSpPr>
+        <p:cNvPr id="1" name=""/>
+        <p:cNvGrpSpPr/>
+        <p:nvPr/>
+      </p:nvGrpSpPr>
+      <p:grpSpPr>
+        <a:xfrm>
+          <a:off x="0" y="0"/>
+          <a:ext cx="0" cy="0"/>
+          <a:chOff x="0" y="0"/>
+          <a:chExt cx="0" cy="0"/>
+        </a:xfrm>
+      </p:grpSpPr>
+      <p:sp>
+        <p:nvSpPr>
+          <p:cNvPr id="2" name="Slide Image Placeholder 1"/>
+          <p:cNvSpPr>
+            <a:spLocks noGrp="1"/>
+          </p:cNvSpPr>
+          <p:nvPr>
+            <p:ph type="sldImg" idx="2"/>
+          </p:nvPr>
+        </p:nvSpPr>
+        <p:spPr/>
+      </p:sp>
+      <p:sp>
+        <p:nvSpPr>
+          <p:cNvPr id="3" name="Notes Placeholder 2"/>
+          <p:cNvSpPr>
+            <a:spLocks noGrp="1"/>
+          </p:cNvSpPr>
+          <p:nvPr>
+            <p:ph type="body" idx="3" sz="quarter"/>
+          </p:nvPr>
+        </p:nvSpPr>
+        <p:spPr/>
+        <p:txBody>
+          <a:bodyPr/>
+          <a:lstStyle/>
+          <a:p>
+            <a:r>
+              <a:t>Les lignes apparaissent l'une après l'autre : faites deviner ce qui sort de chaque étape avant de cliquer.</a:t>
+            </a:r>
+          </a:p>
+          <a:p>
+            <a:r>
+              <a:t>Le flux part des quatre titres. filter ne laisse passer que ceux qui dépassent huit caractères : Nana et Germinal, qui en ont quatre et huit, s'arrêtent là. La limite est abaissée à 8 pour l'exemple : avec 20, il faudrait des titres trop longs pour tenir dans le tableau. map met chacun des deux survivants en majuscules : ils sont toujours deux, mais changés. collect, enfin, n'est plus une suite d'éléments : il les assemble en une seule String, séparés par une virgule et une espace.</a:t>
+            </a:r>
+          </a:p>
+          <a:p>
+            <a:r>
+              <a:t>Pendant tout ce trajet, la liste titres n'a pas bougé : elle contient toujours ses quatre titres, dans le même ordre. C'est la différence avec removeIf.</a:t>
+            </a:r>
+          </a:p>
+        </p:txBody>
+      </p:sp>
+      <p:sp>
+        <p:nvSpPr>
+          <p:cNvPr id="4" name="Slide Number Placeholder 3"/>
+          <p:cNvSpPr>
+            <a:spLocks noGrp="1"/>
+          </p:cNvSpPr>
+          <p:nvPr>
+            <p:ph type="sldNum" idx="5" sz="quarter"/>
+          </p:nvPr>
+        </p:nvSpPr>
+        <p:spPr/>
+      </p:sp>
+    </p:spTree>
+  </p:cSld>
+  <p:clrMapOvr>
+    <a:masterClrMapping/>
+  </p:clrMapOvr>
+</p:notes>
+</file>
+
 <file path=ppt/notesSlides/notesSlide3.xml><?xml version="1.0" encoding="utf-8"?>
 <p:notes xmlns:a="http://schemas.openxmlformats.org/drawingml/2006/main" xmlns:r="http://schemas.openxmlformats.org/officeDocument/2006/relationships" xmlns:p="http://schemas.openxmlformats.org/presentationml/2006/main">
   <p:cSld>
@@ -2502,6 +2500,12 @@
               <a:t>Quand il ne sert qu'une fois, le prix devient dissuasif. On finit par écrire une boucle à la place, et le critère se perd dans la boucle.</a:t>
             </a:r>
           </a:p>
+          <a:p>
+            <a:r>
+              <a:rPr lang="fr-BE" dirty="0"/>
+              <a:t>Le code complet, à exécuter : demos, classe demo.lam.slides.DeLaClasseALaLambda.</a:t>
+            </a:r>
+          </a:p>
         </p:txBody>
       </p:sp>
       <p:sp>
@@ -2614,6 +2618,12 @@
               <a:t>Le fichier a disparu, mais regardez ce qui reste autour de la ligne utile : cinq lignes de cérémonie. La démonstration va montrer ce qu'IntelliJ en fait.</a:t>
             </a:r>
           </a:p>
+          <a:p>
+            <a:r>
+              <a:rPr lang="fr-BE" dirty="0"/>
+              <a:t>Le code complet, à exécuter : demos, classe demo.lam.slides.DeLaClasseALaLambda.</a:t>
+            </a:r>
+          </a:p>
         </p:txBody>
       </p:sp>
       <p:sp>
@@ -2912,6 +2922,12 @@
             </a:r>
             <a:r>
               <a:t>. Seul le coût d'écriture a changé, et avec lui l'envie de le faire.</a:t>
+            </a:r>
+          </a:p>
+          <a:p>
+            <a:r>
+              <a:rPr lang="fr-BE" dirty="0"/>
+              <a:t>Le code complet, à exécuter : demos, classe demo.lam.slides.DeLaClasseALaLambda.</a:t>
             </a:r>
           </a:p>
         </p:txBody>
@@ -6359,6 +6375,7 @@
           </a:p>
           <a:p>
             <a:r>
+              <a:rPr/>
               <a:t>Lambdas et références de méthodes</a:t>
             </a:r>
           </a:p>
@@ -10665,8 +10682,8 @@
         </p:nvSpPr>
         <p:spPr>
           <a:xfrm>
-            <a:off x="640080" y="3512130"/>
-            <a:ext cx="10881360" cy="511200"/>
+            <a:off x="2032000" y="3512130"/>
+            <a:ext cx="8128000" cy="511200"/>
           </a:xfrm>
           <a:prstGeom prst="roundRect">
             <a:avLst>
@@ -11031,8 +11048,8 @@
         </p:nvSpPr>
         <p:spPr>
           <a:xfrm>
-            <a:off x="640080" y="5232565"/>
-            <a:ext cx="10881360" cy="511200"/>
+            <a:off x="2381250" y="5232565"/>
+            <a:ext cx="7429500" cy="511200"/>
           </a:xfrm>
           <a:prstGeom prst="roundRect">
             <a:avLst>
@@ -11414,7 +11431,7 @@
         <p:spPr>
           <a:xfrm>
             <a:off x="640080" y="1371600"/>
-            <a:ext cx="10881360" cy="1579879"/>
+            <a:ext cx="10881360" cy="1600200"/>
           </a:xfrm>
         </p:spPr>
         <p:txBody>
@@ -11428,43 +11445,43 @@
               <a:buNone/>
             </a:pPr>
             <a:r>
-              <a:rPr sz="2600" dirty="0"/>
+              <a:rPr sz="2400" dirty="0"/>
               <a:t>Si la lambda ne fait </a:t>
             </a:r>
             <a:r>
-              <a:rPr sz="2600" dirty="0" err="1"/>
+              <a:rPr sz="2400" dirty="0" err="1"/>
               <a:t>qu'appeler</a:t>
             </a:r>
             <a:r>
-              <a:rPr sz="2600" dirty="0"/>
+              <a:rPr sz="2400" dirty="0"/>
               <a:t> </a:t>
             </a:r>
             <a:r>
-              <a:rPr sz="2600" dirty="0" err="1"/>
+              <a:rPr sz="2400" dirty="0" err="1"/>
               <a:t>une</a:t>
             </a:r>
             <a:r>
-              <a:rPr sz="2600" dirty="0"/>
+              <a:rPr sz="2400" dirty="0"/>
               <a:t> </a:t>
             </a:r>
             <a:r>
-              <a:rPr sz="2600" dirty="0" err="1"/>
+              <a:rPr sz="2400" dirty="0" err="1"/>
               <a:t>méthode</a:t>
             </a:r>
             <a:r>
-              <a:rPr sz="2600" dirty="0"/>
+              <a:rPr sz="2400" dirty="0"/>
               <a:t>, on </a:t>
             </a:r>
             <a:r>
-              <a:rPr sz="2600" dirty="0" err="1"/>
+              <a:rPr sz="2400" dirty="0" err="1"/>
               <a:t>désigne</a:t>
             </a:r>
             <a:r>
-              <a:rPr sz="2600" dirty="0"/>
+              <a:rPr sz="2400" dirty="0"/>
               <a:t> la </a:t>
             </a:r>
             <a:r>
-              <a:rPr sz="2600" dirty="0" err="1"/>
+              <a:rPr sz="2400" dirty="0" err="1"/>
               <a:t>méthode</a:t>
             </a:r>
             <a:endParaRPr sz="2600" dirty="0"/>
@@ -11477,32 +11494,69 @@
               <a:buNone/>
             </a:pPr>
             <a:r>
-              <a:rPr sz="2600" dirty="0"/>
+              <a:rPr sz="2400" dirty="0"/>
               <a:t>La </a:t>
             </a:r>
             <a:r>
-              <a:rPr sz="2600" dirty="0" err="1"/>
+              <a:rPr sz="2400" dirty="0" err="1"/>
               <a:t>classe</a:t>
             </a:r>
             <a:r>
-              <a:rPr sz="2600" dirty="0"/>
+              <a:rPr sz="2400" dirty="0"/>
               <a:t>, deux deux-points, le nom </a:t>
             </a:r>
             <a:r>
-              <a:rPr lang="nl-BE" sz="2600" dirty="0"/>
+              <a:rPr lang="nl-BE" sz="2400" dirty="0"/>
               <a:t>(</a:t>
             </a:r>
             <a:r>
-              <a:rPr sz="2600" dirty="0"/>
+              <a:rPr sz="2400" dirty="0"/>
               <a:t>sans </a:t>
             </a:r>
             <a:r>
-              <a:rPr sz="2600" dirty="0" err="1"/>
+              <a:rPr sz="2400" dirty="0" err="1"/>
               <a:t>parenthèses</a:t>
             </a:r>
             <a:r>
-              <a:rPr lang="nl-BE" sz="2600" dirty="0"/>
+              <a:rPr lang="nl-BE" sz="2400" dirty="0"/>
               <a:t>)</a:t>
+            </a:r>
+            <a:endParaRPr sz="2600" dirty="0"/>
+          </a:p>
+          <a:p>
+            <a:pPr marL="0" indent="0">
+              <a:spcAft>
+                <a:spcPts val="1000"/>
+              </a:spcAft>
+              <a:buNone/>
+            </a:pPr>
+            <a:r>
+              <a:rPr sz="2400" dirty="0"/>
+              <a:t>Le paramètre vient de </a:t>
+            </a:r>
+            <a:r>
+              <a:rPr sz="2000" dirty="0">
+                <a:solidFill>
+                  <a:srgbClr val="FFC000"/>
+                </a:solidFill>
+                <a:latin typeface="Consolas"/>
+                <a:cs typeface="Consolas"/>
+              </a:rPr>
+              <a:t>removeIf</a:t>
+            </a:r>
+            <a:r>
+              <a:rPr sz="2400" dirty="0"/>
+              <a:t>, qui passe chaque titre à </a:t>
+            </a:r>
+            <a:r>
+              <a:rPr sz="2000" dirty="0">
+                <a:solidFill>
+                  <a:srgbClr val="FFC000"/>
+                </a:solidFill>
+                <a:latin typeface="Consolas"/>
+                <a:cs typeface="Consolas"/>
+              </a:rPr>
+              <a:t>estLong</a:t>
             </a:r>
             <a:endParaRPr sz="2600" dirty="0"/>
           </a:p>
@@ -11516,8 +11570,8 @@
         </p:nvSpPr>
         <p:spPr>
           <a:xfrm>
-            <a:off x="2711097" y="2589876"/>
-            <a:ext cx="6769805" cy="2397760"/>
+            <a:off x="2711097" y="3017520"/>
+            <a:ext cx="6769805" cy="1828800"/>
           </a:xfrm>
           <a:prstGeom prst="roundRect">
             <a:avLst>
@@ -11624,38 +11678,52 @@
                 </a:solidFill>
                 <a:latin typeface="Consolas"/>
               </a:rPr>
+              <a:t>    </a:t>
+            </a:r>
+            <a:r>
+              <a:rPr sz="1700" dirty="0">
+                <a:solidFill>
+                  <a:srgbClr val="CF8E6D"/>
+                </a:solidFill>
+                <a:latin typeface="Consolas"/>
+              </a:rPr>
+              <a:t>private</a:t>
+            </a:r>
+            <a:r>
+              <a:rPr sz="1700" dirty="0">
+                <a:solidFill>
+                  <a:srgbClr val="BCBEC4"/>
+                </a:solidFill>
+                <a:latin typeface="Consolas"/>
+              </a:rPr>
               <a:t> </a:t>
             </a:r>
-          </a:p>
-          <a:p>
-            <a:pPr>
-              <a:lnSpc>
-                <a:spcPct val="100000"/>
-              </a:lnSpc>
-              <a:spcBef>
-                <a:spcPts val="0"/>
-              </a:spcBef>
-              <a:spcAft>
-                <a:spcPts val="0"/>
-              </a:spcAft>
-            </a:pPr>
             <a:r>
               <a:rPr sz="1700" dirty="0">
                 <a:solidFill>
-                  <a:srgbClr val="BCBEC4"/>
-                </a:solidFill>
-                <a:latin typeface="Consolas"/>
-              </a:rPr>
-              <a:t>    </a:t>
+                  <a:srgbClr val="CF8E6D"/>
+                </a:solidFill>
+                <a:latin typeface="Consolas"/>
+              </a:rPr>
+              <a:t>static</a:t>
             </a:r>
             <a:r>
               <a:rPr sz="1700" dirty="0">
                 <a:solidFill>
+                  <a:srgbClr val="BCBEC4"/>
+                </a:solidFill>
+                <a:latin typeface="Consolas"/>
+              </a:rPr>
+              <a:t> </a:t>
+            </a:r>
+            <a:r>
+              <a:rPr sz="1700" dirty="0">
+                <a:solidFill>
                   <a:srgbClr val="CF8E6D"/>
                 </a:solidFill>
                 <a:latin typeface="Consolas"/>
               </a:rPr>
-              <a:t>private</a:t>
+              <a:t>final</a:t>
             </a:r>
             <a:r>
               <a:rPr sz="1700" dirty="0">
@@ -11673,7 +11741,7 @@
                 </a:solidFill>
                 <a:latin typeface="Consolas"/>
               </a:rPr>
-              <a:t>static</a:t>
+              <a:t>int</a:t>
             </a:r>
             <a:r>
               <a:rPr sz="1700" dirty="0">
@@ -11682,16 +11750,16 @@
                 </a:solidFill>
                 <a:latin typeface="Consolas"/>
               </a:rPr>
-              <a:t> </a:t>
+              <a:t> LONGUEUR_MAX = </a:t>
             </a:r>
             <a:r>
               <a:rPr sz="1700" dirty="0">
                 <a:solidFill>
-                  <a:srgbClr val="CF8E6D"/>
-                </a:solidFill>
-                <a:latin typeface="Consolas"/>
-              </a:rPr>
-              <a:t>final</a:t>
+                  <a:srgbClr val="2AACB8"/>
+                </a:solidFill>
+                <a:latin typeface="Consolas"/>
+              </a:rPr>
+              <a:t>20</a:t>
             </a:r>
             <a:r>
               <a:rPr sz="1700" dirty="0">
@@ -11700,65 +11768,7 @@
                 </a:solidFill>
                 <a:latin typeface="Consolas"/>
               </a:rPr>
-              <a:t> </a:t>
-            </a:r>
-            <a:r>
-              <a:rPr sz="1700" dirty="0">
-                <a:solidFill>
-                  <a:srgbClr val="CF8E6D"/>
-                </a:solidFill>
-                <a:latin typeface="Consolas"/>
-              </a:rPr>
-              <a:t>int</a:t>
-            </a:r>
-            <a:r>
-              <a:rPr sz="1700" dirty="0">
-                <a:solidFill>
-                  <a:srgbClr val="BCBEC4"/>
-                </a:solidFill>
-                <a:latin typeface="Consolas"/>
-              </a:rPr>
-              <a:t> LONGUEUR_MAX = </a:t>
-            </a:r>
-            <a:r>
-              <a:rPr sz="1700" dirty="0">
-                <a:solidFill>
-                  <a:srgbClr val="2AACB8"/>
-                </a:solidFill>
-                <a:latin typeface="Consolas"/>
-              </a:rPr>
-              <a:t>20</a:t>
-            </a:r>
-            <a:r>
-              <a:rPr sz="1700" dirty="0">
-                <a:solidFill>
-                  <a:srgbClr val="BCBEC4"/>
-                </a:solidFill>
-                <a:latin typeface="Consolas"/>
-              </a:rPr>
               <a:t>;</a:t>
-            </a:r>
-          </a:p>
-          <a:p>
-            <a:pPr>
-              <a:lnSpc>
-                <a:spcPct val="100000"/>
-              </a:lnSpc>
-              <a:spcBef>
-                <a:spcPts val="0"/>
-              </a:spcBef>
-              <a:spcAft>
-                <a:spcPts val="0"/>
-              </a:spcAft>
-            </a:pPr>
-            <a:r>
-              <a:rPr sz="1700" dirty="0">
-                <a:solidFill>
-                  <a:srgbClr val="BCBEC4"/>
-                </a:solidFill>
-                <a:latin typeface="Consolas"/>
-              </a:rPr>
-              <a:t> </a:t>
             </a:r>
           </a:p>
           <a:p>
@@ -12071,7 +12081,7 @@
         </p:nvSpPr>
         <p:spPr>
           <a:xfrm>
-            <a:off x="2711097" y="5160772"/>
+            <a:off x="2711097" y="4983480"/>
             <a:ext cx="6769805" cy="713555"/>
           </a:xfrm>
           <a:prstGeom prst="roundRect">
@@ -12423,7 +12433,7 @@
 </file>
 
 <file path=ppt/slides/slide17.xml><?xml version="1.0" encoding="utf-8"?>
-<p:sld xmlns:a="http://schemas.openxmlformats.org/drawingml/2006/main" xmlns:r="http://schemas.openxmlformats.org/officeDocument/2006/relationships" xmlns:p="http://schemas.openxmlformats.org/presentationml/2006/main">
+<p:sld xmlns:a="http://schemas.openxmlformats.org/drawingml/2006/main" xmlns:p="http://schemas.openxmlformats.org/presentationml/2006/main" xmlns:r="http://schemas.openxmlformats.org/officeDocument/2006/relationships">
   <p:cSld>
     <p:spTree>
       <p:nvGrpSpPr>
@@ -12431,14 +12441,7 @@
         <p:cNvGrpSpPr/>
         <p:nvPr/>
       </p:nvGrpSpPr>
-      <p:grpSpPr>
-        <a:xfrm>
-          <a:off x="0" y="0"/>
-          <a:ext cx="0" cy="0"/>
-          <a:chOff x="0" y="0"/>
-          <a:chExt cx="0" cy="0"/>
-        </a:xfrm>
-      </p:grpSpPr>
+      <p:grpSpPr/>
       <p:sp>
         <p:nvSpPr>
           <p:cNvPr id="2" name="Title 1"/>
@@ -12491,7 +12494,7 @@
             </a:pPr>
             <a:r>
               <a:rPr sz="2800"/>
-              <a:t>Un stream enchaîne des comportements sur une collection</a:t>
+              <a:t>Un stream fait passer les éléments d'une collection par une suite d'étapes</a:t>
             </a:r>
           </a:p>
           <a:p>
@@ -12502,8 +12505,43 @@
               <a:buNone/>
             </a:pPr>
             <a:r>
+              <a:rPr sz="2400">
+                <a:solidFill>
+                  <a:schemeClr val="accent4"/>
+                </a:solidFill>
+                <a:latin typeface="Consolas"/>
+              </a:rPr>
+              <a:t>filter</a:t>
+            </a:r>
+            <a:r>
               <a:rPr sz="2800"/>
-              <a:t>Chaque étape reçoit une lambda, ou une référence de méthode</a:t>
+              <a:t> garde certains éléments, </a:t>
+            </a:r>
+            <a:r>
+              <a:rPr sz="2400">
+                <a:solidFill>
+                  <a:schemeClr val="accent4"/>
+                </a:solidFill>
+                <a:latin typeface="Consolas"/>
+              </a:rPr>
+              <a:t>map</a:t>
+            </a:r>
+            <a:r>
+              <a:rPr sz="2800"/>
+              <a:t> les transforme, </a:t>
+            </a:r>
+            <a:r>
+              <a:rPr sz="2400">
+                <a:solidFill>
+                  <a:schemeClr val="accent4"/>
+                </a:solidFill>
+                <a:latin typeface="Consolas"/>
+              </a:rPr>
+              <a:t>collect</a:t>
+            </a:r>
+            <a:r>
+              <a:rPr sz="2800"/>
+              <a:t> rassemble le résultat</a:t>
             </a:r>
           </a:p>
           <a:p>
@@ -12528,12 +12566,12 @@
         </p:nvSpPr>
         <p:spPr>
           <a:xfrm>
-            <a:off x="2101850" y="4160520"/>
-            <a:ext cx="7988300" cy="1371600"/>
+            <a:off x="640080" y="4160520"/>
+            <a:ext cx="10881360" cy="1249680"/>
           </a:xfrm>
           <a:prstGeom prst="roundRect">
             <a:avLst>
-              <a:gd name="adj" fmla="val 6666"/>
+              <a:gd name="adj" fmla="val 7317"/>
             </a:avLst>
           </a:prstGeom>
           <a:solidFill>
@@ -12548,7 +12586,7 @@
           </a:effectLst>
         </p:spPr>
         <p:txBody>
-          <a:bodyPr wrap="none" lIns="137160" tIns="91440" rIns="137160" bIns="91440"/>
+          <a:bodyPr wrap="none" lIns="137160" rIns="137160" tIns="91440" bIns="91440"/>
           <a:lstStyle/>
           <a:p>
             <a:pPr>
@@ -12563,16 +12601,79 @@
               </a:spcAft>
             </a:pPr>
             <a:r>
-              <a:rPr sz="1800">
-                <a:solidFill>
-                  <a:srgbClr val="BCBEC4"/>
-                </a:solidFill>
-                <a:latin typeface="Consolas"/>
-              </a:rPr>
-              <a:t>String longs = titres.</a:t>
-            </a:r>
-            <a:r>
-              <a:rPr sz="1800">
+              <a:rPr sz="1600">
+                <a:solidFill>
+                  <a:srgbClr val="BCBEC4"/>
+                </a:solidFill>
+                <a:latin typeface="Consolas"/>
+              </a:rPr>
+              <a:t>String</a:t>
+            </a:r>
+            <a:r>
+              <a:rPr sz="1600">
+                <a:solidFill>
+                  <a:srgbClr val="BCBEC4"/>
+                </a:solidFill>
+                <a:latin typeface="Consolas"/>
+              </a:rPr>
+              <a:t> </a:t>
+            </a:r>
+            <a:r>
+              <a:rPr sz="1600">
+                <a:solidFill>
+                  <a:srgbClr val="BCBEC4"/>
+                </a:solidFill>
+                <a:latin typeface="Consolas"/>
+              </a:rPr>
+              <a:t>longs</a:t>
+            </a:r>
+            <a:r>
+              <a:rPr sz="1600">
+                <a:solidFill>
+                  <a:srgbClr val="BCBEC4"/>
+                </a:solidFill>
+                <a:latin typeface="Consolas"/>
+              </a:rPr>
+              <a:t> </a:t>
+            </a:r>
+            <a:r>
+              <a:rPr sz="1600">
+                <a:solidFill>
+                  <a:srgbClr val="BCBEC4"/>
+                </a:solidFill>
+                <a:latin typeface="Consolas"/>
+              </a:rPr>
+              <a:t>=</a:t>
+            </a:r>
+            <a:r>
+              <a:rPr sz="1600">
+                <a:solidFill>
+                  <a:srgbClr val="BCBEC4"/>
+                </a:solidFill>
+                <a:latin typeface="Consolas"/>
+              </a:rPr>
+              <a:t> </a:t>
+            </a:r>
+            <a:r>
+              <a:rPr sz="1600">
+                <a:solidFill>
+                  <a:srgbClr val="BCBEC4"/>
+                </a:solidFill>
+                <a:latin typeface="Consolas"/>
+              </a:rPr>
+              <a:t>titres</a:t>
+            </a:r>
+            <a:r>
+              <a:rPr sz="1600">
+                <a:solidFill>
+                  <a:srgbClr val="BCBEC4"/>
+                </a:solidFill>
+                <a:latin typeface="Consolas"/>
+              </a:rPr>
+              <a:t>.</a:t>
+            </a:r>
+            <a:r>
+              <a:rPr sz="1600">
                 <a:solidFill>
                   <a:srgbClr val="56A8F5"/>
                 </a:solidFill>
@@ -12581,13 +12682,265 @@
               <a:t>stream</a:t>
             </a:r>
             <a:r>
-              <a:rPr sz="1800">
-                <a:solidFill>
-                  <a:srgbClr val="BCBEC4"/>
-                </a:solidFill>
-                <a:latin typeface="Consolas"/>
-              </a:rPr>
-              <a:t>()</a:t>
+              <a:rPr sz="1600">
+                <a:solidFill>
+                  <a:srgbClr val="BCBEC4"/>
+                </a:solidFill>
+                <a:latin typeface="Consolas"/>
+              </a:rPr>
+              <a:t>(</a:t>
+            </a:r>
+            <a:r>
+              <a:rPr sz="1600">
+                <a:solidFill>
+                  <a:srgbClr val="BCBEC4"/>
+                </a:solidFill>
+                <a:latin typeface="Consolas"/>
+              </a:rPr>
+              <a:t>)</a:t>
+            </a:r>
+            <a:r>
+              <a:rPr sz="1600">
+                <a:solidFill>
+                  <a:srgbClr val="BCBEC4"/>
+                </a:solidFill>
+                <a:latin typeface="Consolas"/>
+              </a:rPr>
+              <a:t> </a:t>
+            </a:r>
+            <a:r>
+              <a:rPr sz="1600">
+                <a:solidFill>
+                  <a:srgbClr val="BCBEC4"/>
+                </a:solidFill>
+                <a:latin typeface="Consolas"/>
+              </a:rPr>
+              <a:t> </a:t>
+            </a:r>
+            <a:r>
+              <a:rPr sz="1600">
+                <a:solidFill>
+                  <a:srgbClr val="BCBEC4"/>
+                </a:solidFill>
+                <a:latin typeface="Consolas"/>
+              </a:rPr>
+              <a:t> </a:t>
+            </a:r>
+            <a:r>
+              <a:rPr sz="1600">
+                <a:solidFill>
+                  <a:srgbClr val="BCBEC4"/>
+                </a:solidFill>
+                <a:latin typeface="Consolas"/>
+              </a:rPr>
+              <a:t> </a:t>
+            </a:r>
+            <a:r>
+              <a:rPr sz="1600">
+                <a:solidFill>
+                  <a:srgbClr val="BCBEC4"/>
+                </a:solidFill>
+                <a:latin typeface="Consolas"/>
+              </a:rPr>
+              <a:t> </a:t>
+            </a:r>
+            <a:r>
+              <a:rPr sz="1600">
+                <a:solidFill>
+                  <a:srgbClr val="BCBEC4"/>
+                </a:solidFill>
+                <a:latin typeface="Consolas"/>
+              </a:rPr>
+              <a:t> </a:t>
+            </a:r>
+            <a:r>
+              <a:rPr sz="1600">
+                <a:solidFill>
+                  <a:srgbClr val="BCBEC4"/>
+                </a:solidFill>
+                <a:latin typeface="Consolas"/>
+              </a:rPr>
+              <a:t> </a:t>
+            </a:r>
+            <a:r>
+              <a:rPr sz="1600">
+                <a:solidFill>
+                  <a:srgbClr val="BCBEC4"/>
+                </a:solidFill>
+                <a:latin typeface="Consolas"/>
+              </a:rPr>
+              <a:t> </a:t>
+            </a:r>
+            <a:r>
+              <a:rPr sz="1600">
+                <a:solidFill>
+                  <a:srgbClr val="BCBEC4"/>
+                </a:solidFill>
+                <a:latin typeface="Consolas"/>
+              </a:rPr>
+              <a:t> </a:t>
+            </a:r>
+            <a:r>
+              <a:rPr sz="1600">
+                <a:solidFill>
+                  <a:srgbClr val="BCBEC4"/>
+                </a:solidFill>
+                <a:latin typeface="Consolas"/>
+              </a:rPr>
+              <a:t> </a:t>
+            </a:r>
+            <a:r>
+              <a:rPr sz="1600">
+                <a:solidFill>
+                  <a:srgbClr val="BCBEC4"/>
+                </a:solidFill>
+                <a:latin typeface="Consolas"/>
+              </a:rPr>
+              <a:t> </a:t>
+            </a:r>
+            <a:r>
+              <a:rPr sz="1600">
+                <a:solidFill>
+                  <a:srgbClr val="BCBEC4"/>
+                </a:solidFill>
+                <a:latin typeface="Consolas"/>
+              </a:rPr>
+              <a:t> </a:t>
+            </a:r>
+            <a:r>
+              <a:rPr sz="1600">
+                <a:solidFill>
+                  <a:srgbClr val="BCBEC4"/>
+                </a:solidFill>
+                <a:latin typeface="Consolas"/>
+              </a:rPr>
+              <a:t> </a:t>
+            </a:r>
+            <a:r>
+              <a:rPr sz="1600">
+                <a:solidFill>
+                  <a:srgbClr val="BCBEC4"/>
+                </a:solidFill>
+                <a:latin typeface="Consolas"/>
+              </a:rPr>
+              <a:t> </a:t>
+            </a:r>
+            <a:r>
+              <a:rPr sz="1600">
+                <a:solidFill>
+                  <a:srgbClr val="BCBEC4"/>
+                </a:solidFill>
+                <a:latin typeface="Consolas"/>
+              </a:rPr>
+              <a:t> </a:t>
+            </a:r>
+            <a:r>
+              <a:rPr sz="1600">
+                <a:solidFill>
+                  <a:srgbClr val="BCBEC4"/>
+                </a:solidFill>
+                <a:latin typeface="Consolas"/>
+              </a:rPr>
+              <a:t> </a:t>
+            </a:r>
+            <a:r>
+              <a:rPr sz="1600">
+                <a:solidFill>
+                  <a:srgbClr val="BCBEC4"/>
+                </a:solidFill>
+                <a:latin typeface="Consolas"/>
+              </a:rPr>
+              <a:t> </a:t>
+            </a:r>
+            <a:r>
+              <a:rPr sz="1600">
+                <a:solidFill>
+                  <a:srgbClr val="BCBEC4"/>
+                </a:solidFill>
+                <a:latin typeface="Consolas"/>
+              </a:rPr>
+              <a:t> </a:t>
+            </a:r>
+            <a:r>
+              <a:rPr sz="1600">
+                <a:solidFill>
+                  <a:srgbClr val="BCBEC4"/>
+                </a:solidFill>
+                <a:latin typeface="Consolas"/>
+              </a:rPr>
+              <a:t> </a:t>
+            </a:r>
+            <a:r>
+              <a:rPr sz="1600">
+                <a:solidFill>
+                  <a:srgbClr val="BCBEC4"/>
+                </a:solidFill>
+                <a:latin typeface="Consolas"/>
+              </a:rPr>
+              <a:t> </a:t>
+            </a:r>
+            <a:r>
+              <a:rPr sz="1600">
+                <a:solidFill>
+                  <a:srgbClr val="BCBEC4"/>
+                </a:solidFill>
+                <a:latin typeface="Consolas"/>
+              </a:rPr>
+              <a:t> </a:t>
+            </a:r>
+            <a:r>
+              <a:rPr sz="1600">
+                <a:solidFill>
+                  <a:srgbClr val="BCBEC4"/>
+                </a:solidFill>
+                <a:latin typeface="Consolas"/>
+              </a:rPr>
+              <a:t> </a:t>
+            </a:r>
+            <a:r>
+              <a:rPr sz="1600">
+                <a:solidFill>
+                  <a:srgbClr val="BCBEC4"/>
+                </a:solidFill>
+                <a:latin typeface="Consolas"/>
+              </a:rPr>
+              <a:t> </a:t>
+            </a:r>
+            <a:r>
+              <a:rPr sz="1600">
+                <a:solidFill>
+                  <a:srgbClr val="BCBEC4"/>
+                </a:solidFill>
+                <a:latin typeface="Consolas"/>
+              </a:rPr>
+              <a:t> </a:t>
+            </a:r>
+            <a:r>
+              <a:rPr sz="1600">
+                <a:solidFill>
+                  <a:srgbClr val="BCBEC4"/>
+                </a:solidFill>
+                <a:latin typeface="Consolas"/>
+              </a:rPr>
+              <a:t> </a:t>
+            </a:r>
+            <a:r>
+              <a:rPr sz="1600">
+                <a:solidFill>
+                  <a:srgbClr val="BCBEC4"/>
+                </a:solidFill>
+                <a:latin typeface="Consolas"/>
+              </a:rPr>
+              <a:t> </a:t>
+            </a:r>
+            <a:r>
+              <a:rPr sz="1600">
+                <a:solidFill>
+                  <a:srgbClr val="7A7E85"/>
+                </a:solidFill>
+                <a:latin typeface="Consolas"/>
+              </a:rPr>
+              <a:t>// 1. ouvrir le flux</a:t>
             </a:r>
           </a:p>
           <a:p>
@@ -12603,16 +12956,88 @@
               </a:spcAft>
             </a:pPr>
             <a:r>
-              <a:rPr sz="1800">
-                <a:solidFill>
-                  <a:srgbClr val="BCBEC4"/>
-                </a:solidFill>
-                <a:latin typeface="Consolas"/>
-              </a:rPr>
-              <a:t>        .</a:t>
-            </a:r>
-            <a:r>
-              <a:rPr sz="1800">
+              <a:rPr sz="1600">
+                <a:solidFill>
+                  <a:srgbClr val="BCBEC4"/>
+                </a:solidFill>
+                <a:latin typeface="Consolas"/>
+              </a:rPr>
+              <a:t> </a:t>
+            </a:r>
+            <a:r>
+              <a:rPr sz="1600">
+                <a:solidFill>
+                  <a:srgbClr val="BCBEC4"/>
+                </a:solidFill>
+                <a:latin typeface="Consolas"/>
+              </a:rPr>
+              <a:t> </a:t>
+            </a:r>
+            <a:r>
+              <a:rPr sz="1600">
+                <a:solidFill>
+                  <a:srgbClr val="BCBEC4"/>
+                </a:solidFill>
+                <a:latin typeface="Consolas"/>
+              </a:rPr>
+              <a:t> </a:t>
+            </a:r>
+            <a:r>
+              <a:rPr sz="1600">
+                <a:solidFill>
+                  <a:srgbClr val="BCBEC4"/>
+                </a:solidFill>
+                <a:latin typeface="Consolas"/>
+              </a:rPr>
+              <a:t> </a:t>
+            </a:r>
+            <a:r>
+              <a:rPr sz="1600">
+                <a:solidFill>
+                  <a:srgbClr val="BCBEC4"/>
+                </a:solidFill>
+                <a:latin typeface="Consolas"/>
+              </a:rPr>
+              <a:t> </a:t>
+            </a:r>
+            <a:r>
+              <a:rPr sz="1600">
+                <a:solidFill>
+                  <a:srgbClr val="BCBEC4"/>
+                </a:solidFill>
+                <a:latin typeface="Consolas"/>
+              </a:rPr>
+              <a:t> </a:t>
+            </a:r>
+            <a:r>
+              <a:rPr sz="1600">
+                <a:solidFill>
+                  <a:srgbClr val="BCBEC4"/>
+                </a:solidFill>
+                <a:latin typeface="Consolas"/>
+              </a:rPr>
+              <a:t> </a:t>
+            </a:r>
+            <a:r>
+              <a:rPr sz="1600">
+                <a:solidFill>
+                  <a:srgbClr val="BCBEC4"/>
+                </a:solidFill>
+                <a:latin typeface="Consolas"/>
+              </a:rPr>
+              <a:t> </a:t>
+            </a:r>
+            <a:r>
+              <a:rPr sz="1600">
+                <a:solidFill>
+                  <a:srgbClr val="BCBEC4"/>
+                </a:solidFill>
+                <a:latin typeface="Consolas"/>
+              </a:rPr>
+              <a:t>.</a:t>
+            </a:r>
+            <a:r>
+              <a:rPr sz="1600">
                 <a:solidFill>
                   <a:srgbClr val="56A8F5"/>
                 </a:solidFill>
@@ -12621,16 +13046,79 @@
               <a:t>filter</a:t>
             </a:r>
             <a:r>
-              <a:rPr sz="1800">
-                <a:solidFill>
-                  <a:srgbClr val="BCBEC4"/>
-                </a:solidFill>
-                <a:latin typeface="Consolas"/>
-              </a:rPr>
-              <a:t>(titre -&gt; titre.</a:t>
-            </a:r>
-            <a:r>
-              <a:rPr sz="1800">
+              <a:rPr sz="1600">
+                <a:solidFill>
+                  <a:srgbClr val="BCBEC4"/>
+                </a:solidFill>
+                <a:latin typeface="Consolas"/>
+              </a:rPr>
+              <a:t>(</a:t>
+            </a:r>
+            <a:r>
+              <a:rPr sz="1600">
+                <a:solidFill>
+                  <a:srgbClr val="BCBEC4"/>
+                </a:solidFill>
+                <a:latin typeface="Consolas"/>
+              </a:rPr>
+              <a:t>titre</a:t>
+            </a:r>
+            <a:r>
+              <a:rPr sz="1600">
+                <a:solidFill>
+                  <a:srgbClr val="BCBEC4"/>
+                </a:solidFill>
+                <a:latin typeface="Consolas"/>
+              </a:rPr>
+              <a:t> </a:t>
+            </a:r>
+            <a:r>
+              <a:rPr sz="1600">
+                <a:solidFill>
+                  <a:srgbClr val="BCBEC4"/>
+                </a:solidFill>
+                <a:latin typeface="Consolas"/>
+              </a:rPr>
+              <a:t>-</a:t>
+            </a:r>
+            <a:r>
+              <a:rPr sz="1600">
+                <a:solidFill>
+                  <a:srgbClr val="BCBEC4"/>
+                </a:solidFill>
+                <a:latin typeface="Consolas"/>
+              </a:rPr>
+              <a:t>&gt;</a:t>
+            </a:r>
+            <a:r>
+              <a:rPr sz="1600">
+                <a:solidFill>
+                  <a:srgbClr val="BCBEC4"/>
+                </a:solidFill>
+                <a:latin typeface="Consolas"/>
+              </a:rPr>
+              <a:t> </a:t>
+            </a:r>
+            <a:r>
+              <a:rPr sz="1600">
+                <a:solidFill>
+                  <a:srgbClr val="BCBEC4"/>
+                </a:solidFill>
+                <a:latin typeface="Consolas"/>
+              </a:rPr>
+              <a:t>titre</a:t>
+            </a:r>
+            <a:r>
+              <a:rPr sz="1600">
+                <a:solidFill>
+                  <a:srgbClr val="BCBEC4"/>
+                </a:solidFill>
+                <a:latin typeface="Consolas"/>
+              </a:rPr>
+              <a:t>.</a:t>
+            </a:r>
+            <a:r>
+              <a:rPr sz="1600">
                 <a:solidFill>
                   <a:srgbClr val="56A8F5"/>
                 </a:solidFill>
@@ -12639,13 +13127,94 @@
               <a:t>length</a:t>
             </a:r>
             <a:r>
-              <a:rPr sz="1800">
-                <a:solidFill>
-                  <a:srgbClr val="BCBEC4"/>
-                </a:solidFill>
-                <a:latin typeface="Consolas"/>
-              </a:rPr>
-              <a:t>() &gt; LONGUEUR_MAX)</a:t>
+              <a:rPr sz="1600">
+                <a:solidFill>
+                  <a:srgbClr val="BCBEC4"/>
+                </a:solidFill>
+                <a:latin typeface="Consolas"/>
+              </a:rPr>
+              <a:t>(</a:t>
+            </a:r>
+            <a:r>
+              <a:rPr sz="1600">
+                <a:solidFill>
+                  <a:srgbClr val="BCBEC4"/>
+                </a:solidFill>
+                <a:latin typeface="Consolas"/>
+              </a:rPr>
+              <a:t>)</a:t>
+            </a:r>
+            <a:r>
+              <a:rPr sz="1600">
+                <a:solidFill>
+                  <a:srgbClr val="BCBEC4"/>
+                </a:solidFill>
+                <a:latin typeface="Consolas"/>
+              </a:rPr>
+              <a:t> </a:t>
+            </a:r>
+            <a:r>
+              <a:rPr sz="1600">
+                <a:solidFill>
+                  <a:srgbClr val="BCBEC4"/>
+                </a:solidFill>
+                <a:latin typeface="Consolas"/>
+              </a:rPr>
+              <a:t>&gt;</a:t>
+            </a:r>
+            <a:r>
+              <a:rPr sz="1600">
+                <a:solidFill>
+                  <a:srgbClr val="BCBEC4"/>
+                </a:solidFill>
+                <a:latin typeface="Consolas"/>
+              </a:rPr>
+              <a:t> </a:t>
+            </a:r>
+            <a:r>
+              <a:rPr sz="1600">
+                <a:solidFill>
+                  <a:srgbClr val="BCBEC4"/>
+                </a:solidFill>
+                <a:latin typeface="Consolas"/>
+              </a:rPr>
+              <a:t>LONGUEUR_MAX</a:t>
+            </a:r>
+            <a:r>
+              <a:rPr sz="1600">
+                <a:solidFill>
+                  <a:srgbClr val="BCBEC4"/>
+                </a:solidFill>
+                <a:latin typeface="Consolas"/>
+              </a:rPr>
+              <a:t>)</a:t>
+            </a:r>
+            <a:r>
+              <a:rPr sz="1600">
+                <a:solidFill>
+                  <a:srgbClr val="BCBEC4"/>
+                </a:solidFill>
+                <a:latin typeface="Consolas"/>
+              </a:rPr>
+              <a:t> </a:t>
+            </a:r>
+            <a:r>
+              <a:rPr sz="1600">
+                <a:solidFill>
+                  <a:srgbClr val="BCBEC4"/>
+                </a:solidFill>
+                <a:latin typeface="Consolas"/>
+              </a:rPr>
+              <a:t> </a:t>
+            </a:r>
+            <a:r>
+              <a:rPr sz="1600">
+                <a:solidFill>
+                  <a:srgbClr val="7A7E85"/>
+                </a:solidFill>
+                <a:latin typeface="Consolas"/>
+              </a:rPr>
+              <a:t>// 2. garder les longs</a:t>
             </a:r>
           </a:p>
           <a:p>
@@ -12661,16 +13230,88 @@
               </a:spcAft>
             </a:pPr>
             <a:r>
-              <a:rPr sz="1800">
-                <a:solidFill>
-                  <a:srgbClr val="BCBEC4"/>
-                </a:solidFill>
-                <a:latin typeface="Consolas"/>
-              </a:rPr>
-              <a:t>        .</a:t>
-            </a:r>
-            <a:r>
-              <a:rPr sz="1800">
+              <a:rPr sz="1600">
+                <a:solidFill>
+                  <a:srgbClr val="BCBEC4"/>
+                </a:solidFill>
+                <a:latin typeface="Consolas"/>
+              </a:rPr>
+              <a:t> </a:t>
+            </a:r>
+            <a:r>
+              <a:rPr sz="1600">
+                <a:solidFill>
+                  <a:srgbClr val="BCBEC4"/>
+                </a:solidFill>
+                <a:latin typeface="Consolas"/>
+              </a:rPr>
+              <a:t> </a:t>
+            </a:r>
+            <a:r>
+              <a:rPr sz="1600">
+                <a:solidFill>
+                  <a:srgbClr val="BCBEC4"/>
+                </a:solidFill>
+                <a:latin typeface="Consolas"/>
+              </a:rPr>
+              <a:t> </a:t>
+            </a:r>
+            <a:r>
+              <a:rPr sz="1600">
+                <a:solidFill>
+                  <a:srgbClr val="BCBEC4"/>
+                </a:solidFill>
+                <a:latin typeface="Consolas"/>
+              </a:rPr>
+              <a:t> </a:t>
+            </a:r>
+            <a:r>
+              <a:rPr sz="1600">
+                <a:solidFill>
+                  <a:srgbClr val="BCBEC4"/>
+                </a:solidFill>
+                <a:latin typeface="Consolas"/>
+              </a:rPr>
+              <a:t> </a:t>
+            </a:r>
+            <a:r>
+              <a:rPr sz="1600">
+                <a:solidFill>
+                  <a:srgbClr val="BCBEC4"/>
+                </a:solidFill>
+                <a:latin typeface="Consolas"/>
+              </a:rPr>
+              <a:t> </a:t>
+            </a:r>
+            <a:r>
+              <a:rPr sz="1600">
+                <a:solidFill>
+                  <a:srgbClr val="BCBEC4"/>
+                </a:solidFill>
+                <a:latin typeface="Consolas"/>
+              </a:rPr>
+              <a:t> </a:t>
+            </a:r>
+            <a:r>
+              <a:rPr sz="1600">
+                <a:solidFill>
+                  <a:srgbClr val="BCBEC4"/>
+                </a:solidFill>
+                <a:latin typeface="Consolas"/>
+              </a:rPr>
+              <a:t> </a:t>
+            </a:r>
+            <a:r>
+              <a:rPr sz="1600">
+                <a:solidFill>
+                  <a:srgbClr val="BCBEC4"/>
+                </a:solidFill>
+                <a:latin typeface="Consolas"/>
+              </a:rPr>
+              <a:t>.</a:t>
+            </a:r>
+            <a:r>
+              <a:rPr sz="1600">
                 <a:solidFill>
                   <a:srgbClr val="56A8F5"/>
                 </a:solidFill>
@@ -12679,16 +13320,79 @@
               <a:t>map</a:t>
             </a:r>
             <a:r>
-              <a:rPr sz="1800">
-                <a:solidFill>
-                  <a:srgbClr val="BCBEC4"/>
-                </a:solidFill>
-                <a:latin typeface="Consolas"/>
-              </a:rPr>
-              <a:t>(titre -&gt; titre.</a:t>
-            </a:r>
-            <a:r>
-              <a:rPr sz="1800">
+              <a:rPr sz="1600">
+                <a:solidFill>
+                  <a:srgbClr val="BCBEC4"/>
+                </a:solidFill>
+                <a:latin typeface="Consolas"/>
+              </a:rPr>
+              <a:t>(</a:t>
+            </a:r>
+            <a:r>
+              <a:rPr sz="1600">
+                <a:solidFill>
+                  <a:srgbClr val="BCBEC4"/>
+                </a:solidFill>
+                <a:latin typeface="Consolas"/>
+              </a:rPr>
+              <a:t>titre</a:t>
+            </a:r>
+            <a:r>
+              <a:rPr sz="1600">
+                <a:solidFill>
+                  <a:srgbClr val="BCBEC4"/>
+                </a:solidFill>
+                <a:latin typeface="Consolas"/>
+              </a:rPr>
+              <a:t> </a:t>
+            </a:r>
+            <a:r>
+              <a:rPr sz="1600">
+                <a:solidFill>
+                  <a:srgbClr val="BCBEC4"/>
+                </a:solidFill>
+                <a:latin typeface="Consolas"/>
+              </a:rPr>
+              <a:t>-</a:t>
+            </a:r>
+            <a:r>
+              <a:rPr sz="1600">
+                <a:solidFill>
+                  <a:srgbClr val="BCBEC4"/>
+                </a:solidFill>
+                <a:latin typeface="Consolas"/>
+              </a:rPr>
+              <a:t>&gt;</a:t>
+            </a:r>
+            <a:r>
+              <a:rPr sz="1600">
+                <a:solidFill>
+                  <a:srgbClr val="BCBEC4"/>
+                </a:solidFill>
+                <a:latin typeface="Consolas"/>
+              </a:rPr>
+              <a:t> </a:t>
+            </a:r>
+            <a:r>
+              <a:rPr sz="1600">
+                <a:solidFill>
+                  <a:srgbClr val="BCBEC4"/>
+                </a:solidFill>
+                <a:latin typeface="Consolas"/>
+              </a:rPr>
+              <a:t>titre</a:t>
+            </a:r>
+            <a:r>
+              <a:rPr sz="1600">
+                <a:solidFill>
+                  <a:srgbClr val="BCBEC4"/>
+                </a:solidFill>
+                <a:latin typeface="Consolas"/>
+              </a:rPr>
+              <a:t>.</a:t>
+            </a:r>
+            <a:r>
+              <a:rPr sz="1600">
                 <a:solidFill>
                   <a:srgbClr val="56A8F5"/>
                 </a:solidFill>
@@ -12697,13 +13401,175 @@
               <a:t>toUpperCase</a:t>
             </a:r>
             <a:r>
-              <a:rPr sz="1800">
-                <a:solidFill>
-                  <a:srgbClr val="BCBEC4"/>
-                </a:solidFill>
-                <a:latin typeface="Consolas"/>
-              </a:rPr>
-              <a:t>())</a:t>
+              <a:rPr sz="1600">
+                <a:solidFill>
+                  <a:srgbClr val="BCBEC4"/>
+                </a:solidFill>
+                <a:latin typeface="Consolas"/>
+              </a:rPr>
+              <a:t>(</a:t>
+            </a:r>
+            <a:r>
+              <a:rPr sz="1600">
+                <a:solidFill>
+                  <a:srgbClr val="BCBEC4"/>
+                </a:solidFill>
+                <a:latin typeface="Consolas"/>
+              </a:rPr>
+              <a:t>)</a:t>
+            </a:r>
+            <a:r>
+              <a:rPr sz="1600">
+                <a:solidFill>
+                  <a:srgbClr val="BCBEC4"/>
+                </a:solidFill>
+                <a:latin typeface="Consolas"/>
+              </a:rPr>
+              <a:t>)</a:t>
+            </a:r>
+            <a:r>
+              <a:rPr sz="1600">
+                <a:solidFill>
+                  <a:srgbClr val="BCBEC4"/>
+                </a:solidFill>
+                <a:latin typeface="Consolas"/>
+              </a:rPr>
+              <a:t> </a:t>
+            </a:r>
+            <a:r>
+              <a:rPr sz="1600">
+                <a:solidFill>
+                  <a:srgbClr val="BCBEC4"/>
+                </a:solidFill>
+                <a:latin typeface="Consolas"/>
+              </a:rPr>
+              <a:t> </a:t>
+            </a:r>
+            <a:r>
+              <a:rPr sz="1600">
+                <a:solidFill>
+                  <a:srgbClr val="BCBEC4"/>
+                </a:solidFill>
+                <a:latin typeface="Consolas"/>
+              </a:rPr>
+              <a:t> </a:t>
+            </a:r>
+            <a:r>
+              <a:rPr sz="1600">
+                <a:solidFill>
+                  <a:srgbClr val="BCBEC4"/>
+                </a:solidFill>
+                <a:latin typeface="Consolas"/>
+              </a:rPr>
+              <a:t> </a:t>
+            </a:r>
+            <a:r>
+              <a:rPr sz="1600">
+                <a:solidFill>
+                  <a:srgbClr val="BCBEC4"/>
+                </a:solidFill>
+                <a:latin typeface="Consolas"/>
+              </a:rPr>
+              <a:t> </a:t>
+            </a:r>
+            <a:r>
+              <a:rPr sz="1600">
+                <a:solidFill>
+                  <a:srgbClr val="BCBEC4"/>
+                </a:solidFill>
+                <a:latin typeface="Consolas"/>
+              </a:rPr>
+              <a:t> </a:t>
+            </a:r>
+            <a:r>
+              <a:rPr sz="1600">
+                <a:solidFill>
+                  <a:srgbClr val="BCBEC4"/>
+                </a:solidFill>
+                <a:latin typeface="Consolas"/>
+              </a:rPr>
+              <a:t> </a:t>
+            </a:r>
+            <a:r>
+              <a:rPr sz="1600">
+                <a:solidFill>
+                  <a:srgbClr val="BCBEC4"/>
+                </a:solidFill>
+                <a:latin typeface="Consolas"/>
+              </a:rPr>
+              <a:t> </a:t>
+            </a:r>
+            <a:r>
+              <a:rPr sz="1600">
+                <a:solidFill>
+                  <a:srgbClr val="BCBEC4"/>
+                </a:solidFill>
+                <a:latin typeface="Consolas"/>
+              </a:rPr>
+              <a:t> </a:t>
+            </a:r>
+            <a:r>
+              <a:rPr sz="1600">
+                <a:solidFill>
+                  <a:srgbClr val="BCBEC4"/>
+                </a:solidFill>
+                <a:latin typeface="Consolas"/>
+              </a:rPr>
+              <a:t> </a:t>
+            </a:r>
+            <a:r>
+              <a:rPr sz="1600">
+                <a:solidFill>
+                  <a:srgbClr val="BCBEC4"/>
+                </a:solidFill>
+                <a:latin typeface="Consolas"/>
+              </a:rPr>
+              <a:t> </a:t>
+            </a:r>
+            <a:r>
+              <a:rPr sz="1600">
+                <a:solidFill>
+                  <a:srgbClr val="BCBEC4"/>
+                </a:solidFill>
+                <a:latin typeface="Consolas"/>
+              </a:rPr>
+              <a:t> </a:t>
+            </a:r>
+            <a:r>
+              <a:rPr sz="1600">
+                <a:solidFill>
+                  <a:srgbClr val="BCBEC4"/>
+                </a:solidFill>
+                <a:latin typeface="Consolas"/>
+              </a:rPr>
+              <a:t> </a:t>
+            </a:r>
+            <a:r>
+              <a:rPr sz="1600">
+                <a:solidFill>
+                  <a:srgbClr val="BCBEC4"/>
+                </a:solidFill>
+                <a:latin typeface="Consolas"/>
+              </a:rPr>
+              <a:t> </a:t>
+            </a:r>
+            <a:r>
+              <a:rPr sz="1600">
+                <a:solidFill>
+                  <a:srgbClr val="BCBEC4"/>
+                </a:solidFill>
+                <a:latin typeface="Consolas"/>
+              </a:rPr>
+              <a:t> </a:t>
+            </a:r>
+            <a:r>
+              <a:rPr sz="1600">
+                <a:solidFill>
+                  <a:srgbClr val="7A7E85"/>
+                </a:solidFill>
+                <a:latin typeface="Consolas"/>
+              </a:rPr>
+              <a:t>// 3. mettre en majuscules</a:t>
             </a:r>
           </a:p>
           <a:p>
@@ -12719,16 +13585,88 @@
               </a:spcAft>
             </a:pPr>
             <a:r>
-              <a:rPr sz="1800">
-                <a:solidFill>
-                  <a:srgbClr val="BCBEC4"/>
-                </a:solidFill>
-                <a:latin typeface="Consolas"/>
-              </a:rPr>
-              <a:t>        .</a:t>
-            </a:r>
-            <a:r>
-              <a:rPr sz="1800">
+              <a:rPr sz="1600">
+                <a:solidFill>
+                  <a:srgbClr val="BCBEC4"/>
+                </a:solidFill>
+                <a:latin typeface="Consolas"/>
+              </a:rPr>
+              <a:t> </a:t>
+            </a:r>
+            <a:r>
+              <a:rPr sz="1600">
+                <a:solidFill>
+                  <a:srgbClr val="BCBEC4"/>
+                </a:solidFill>
+                <a:latin typeface="Consolas"/>
+              </a:rPr>
+              <a:t> </a:t>
+            </a:r>
+            <a:r>
+              <a:rPr sz="1600">
+                <a:solidFill>
+                  <a:srgbClr val="BCBEC4"/>
+                </a:solidFill>
+                <a:latin typeface="Consolas"/>
+              </a:rPr>
+              <a:t> </a:t>
+            </a:r>
+            <a:r>
+              <a:rPr sz="1600">
+                <a:solidFill>
+                  <a:srgbClr val="BCBEC4"/>
+                </a:solidFill>
+                <a:latin typeface="Consolas"/>
+              </a:rPr>
+              <a:t> </a:t>
+            </a:r>
+            <a:r>
+              <a:rPr sz="1600">
+                <a:solidFill>
+                  <a:srgbClr val="BCBEC4"/>
+                </a:solidFill>
+                <a:latin typeface="Consolas"/>
+              </a:rPr>
+              <a:t> </a:t>
+            </a:r>
+            <a:r>
+              <a:rPr sz="1600">
+                <a:solidFill>
+                  <a:srgbClr val="BCBEC4"/>
+                </a:solidFill>
+                <a:latin typeface="Consolas"/>
+              </a:rPr>
+              <a:t> </a:t>
+            </a:r>
+            <a:r>
+              <a:rPr sz="1600">
+                <a:solidFill>
+                  <a:srgbClr val="BCBEC4"/>
+                </a:solidFill>
+                <a:latin typeface="Consolas"/>
+              </a:rPr>
+              <a:t> </a:t>
+            </a:r>
+            <a:r>
+              <a:rPr sz="1600">
+                <a:solidFill>
+                  <a:srgbClr val="BCBEC4"/>
+                </a:solidFill>
+                <a:latin typeface="Consolas"/>
+              </a:rPr>
+              <a:t> </a:t>
+            </a:r>
+            <a:r>
+              <a:rPr sz="1600">
+                <a:solidFill>
+                  <a:srgbClr val="BCBEC4"/>
+                </a:solidFill>
+                <a:latin typeface="Consolas"/>
+              </a:rPr>
+              <a:t>.</a:t>
+            </a:r>
+            <a:r>
+              <a:rPr sz="1600">
                 <a:solidFill>
                   <a:srgbClr val="56A8F5"/>
                 </a:solidFill>
@@ -12737,16 +13675,34 @@
               <a:t>collect</a:t>
             </a:r>
             <a:r>
-              <a:rPr sz="1800">
-                <a:solidFill>
-                  <a:srgbClr val="BCBEC4"/>
-                </a:solidFill>
-                <a:latin typeface="Consolas"/>
-              </a:rPr>
-              <a:t>(Collectors.</a:t>
-            </a:r>
-            <a:r>
-              <a:rPr sz="1800">
+              <a:rPr sz="1600">
+                <a:solidFill>
+                  <a:srgbClr val="BCBEC4"/>
+                </a:solidFill>
+                <a:latin typeface="Consolas"/>
+              </a:rPr>
+              <a:t>(</a:t>
+            </a:r>
+            <a:r>
+              <a:rPr sz="1600">
+                <a:solidFill>
+                  <a:srgbClr val="BCBEC4"/>
+                </a:solidFill>
+                <a:latin typeface="Consolas"/>
+              </a:rPr>
+              <a:t>Collectors</a:t>
+            </a:r>
+            <a:r>
+              <a:rPr sz="1600">
+                <a:solidFill>
+                  <a:srgbClr val="BCBEC4"/>
+                </a:solidFill>
+                <a:latin typeface="Consolas"/>
+              </a:rPr>
+              <a:t>.</a:t>
+            </a:r>
+            <a:r>
+              <a:rPr sz="1600">
                 <a:solidFill>
                   <a:srgbClr val="56A8F5"/>
                 </a:solidFill>
@@ -12755,7 +13711,7 @@
               <a:t>joining</a:t>
             </a:r>
             <a:r>
-              <a:rPr sz="1800">
+              <a:rPr sz="1600">
                 <a:solidFill>
                   <a:srgbClr val="BCBEC4"/>
                 </a:solidFill>
@@ -12764,7 +13720,7 @@
               <a:t>(</a:t>
             </a:r>
             <a:r>
-              <a:rPr sz="1800">
+              <a:rPr sz="1600">
                 <a:solidFill>
                   <a:srgbClr val="6AAB73"/>
                 </a:solidFill>
@@ -12773,20 +13729,173 @@
               <a:t>", "</a:t>
             </a:r>
             <a:r>
-              <a:rPr sz="1800">
-                <a:solidFill>
-                  <a:srgbClr val="BCBEC4"/>
-                </a:solidFill>
-                <a:latin typeface="Consolas"/>
-              </a:rPr>
-              <a:t>));</a:t>
+              <a:rPr sz="1600">
+                <a:solidFill>
+                  <a:srgbClr val="BCBEC4"/>
+                </a:solidFill>
+                <a:latin typeface="Consolas"/>
+              </a:rPr>
+              <a:t>)</a:t>
+            </a:r>
+            <a:r>
+              <a:rPr sz="1600">
+                <a:solidFill>
+                  <a:srgbClr val="BCBEC4"/>
+                </a:solidFill>
+                <a:latin typeface="Consolas"/>
+              </a:rPr>
+              <a:t>)</a:t>
+            </a:r>
+            <a:r>
+              <a:rPr sz="1600">
+                <a:solidFill>
+                  <a:srgbClr val="BCBEC4"/>
+                </a:solidFill>
+                <a:latin typeface="Consolas"/>
+              </a:rPr>
+              <a:t>;</a:t>
+            </a:r>
+            <a:r>
+              <a:rPr sz="1600">
+                <a:solidFill>
+                  <a:srgbClr val="BCBEC4"/>
+                </a:solidFill>
+                <a:latin typeface="Consolas"/>
+              </a:rPr>
+              <a:t> </a:t>
+            </a:r>
+            <a:r>
+              <a:rPr sz="1600">
+                <a:solidFill>
+                  <a:srgbClr val="BCBEC4"/>
+                </a:solidFill>
+                <a:latin typeface="Consolas"/>
+              </a:rPr>
+              <a:t> </a:t>
+            </a:r>
+            <a:r>
+              <a:rPr sz="1600">
+                <a:solidFill>
+                  <a:srgbClr val="BCBEC4"/>
+                </a:solidFill>
+                <a:latin typeface="Consolas"/>
+              </a:rPr>
+              <a:t> </a:t>
+            </a:r>
+            <a:r>
+              <a:rPr sz="1600">
+                <a:solidFill>
+                  <a:srgbClr val="BCBEC4"/>
+                </a:solidFill>
+                <a:latin typeface="Consolas"/>
+              </a:rPr>
+              <a:t> </a:t>
+            </a:r>
+            <a:r>
+              <a:rPr sz="1600">
+                <a:solidFill>
+                  <a:srgbClr val="BCBEC4"/>
+                </a:solidFill>
+                <a:latin typeface="Consolas"/>
+              </a:rPr>
+              <a:t> </a:t>
+            </a:r>
+            <a:r>
+              <a:rPr sz="1600">
+                <a:solidFill>
+                  <a:srgbClr val="BCBEC4"/>
+                </a:solidFill>
+                <a:latin typeface="Consolas"/>
+              </a:rPr>
+              <a:t> </a:t>
+            </a:r>
+            <a:r>
+              <a:rPr sz="1600">
+                <a:solidFill>
+                  <a:srgbClr val="BCBEC4"/>
+                </a:solidFill>
+                <a:latin typeface="Consolas"/>
+              </a:rPr>
+              <a:t> </a:t>
+            </a:r>
+            <a:r>
+              <a:rPr sz="1600">
+                <a:solidFill>
+                  <a:srgbClr val="BCBEC4"/>
+                </a:solidFill>
+                <a:latin typeface="Consolas"/>
+              </a:rPr>
+              <a:t> </a:t>
+            </a:r>
+            <a:r>
+              <a:rPr sz="1600">
+                <a:solidFill>
+                  <a:srgbClr val="BCBEC4"/>
+                </a:solidFill>
+                <a:latin typeface="Consolas"/>
+              </a:rPr>
+              <a:t> </a:t>
+            </a:r>
+            <a:r>
+              <a:rPr sz="1600">
+                <a:solidFill>
+                  <a:srgbClr val="BCBEC4"/>
+                </a:solidFill>
+                <a:latin typeface="Consolas"/>
+              </a:rPr>
+              <a:t> </a:t>
+            </a:r>
+            <a:r>
+              <a:rPr sz="1600">
+                <a:solidFill>
+                  <a:srgbClr val="BCBEC4"/>
+                </a:solidFill>
+                <a:latin typeface="Consolas"/>
+              </a:rPr>
+              <a:t> </a:t>
+            </a:r>
+            <a:r>
+              <a:rPr sz="1600">
+                <a:solidFill>
+                  <a:srgbClr val="BCBEC4"/>
+                </a:solidFill>
+                <a:latin typeface="Consolas"/>
+              </a:rPr>
+              <a:t> </a:t>
+            </a:r>
+            <a:r>
+              <a:rPr sz="1600">
+                <a:solidFill>
+                  <a:srgbClr val="BCBEC4"/>
+                </a:solidFill>
+                <a:latin typeface="Consolas"/>
+              </a:rPr>
+              <a:t> </a:t>
+            </a:r>
+            <a:r>
+              <a:rPr sz="1600">
+                <a:solidFill>
+                  <a:srgbClr val="BCBEC4"/>
+                </a:solidFill>
+                <a:latin typeface="Consolas"/>
+              </a:rPr>
+              <a:t> </a:t>
+            </a:r>
+            <a:r>
+              <a:rPr sz="1600">
+                <a:solidFill>
+                  <a:srgbClr val="7A7E85"/>
+                </a:solidFill>
+                <a:latin typeface="Consolas"/>
+              </a:rPr>
+              <a:t>// 4. joindre en un texte</a:t>
             </a:r>
           </a:p>
         </p:txBody>
       </p:sp>
       <p:sp>
         <p:nvSpPr>
-          <p:cNvPr id="6" name="Espace réservé du numéro de diapositive 2">
+          <p:cNvPr id="3" name="Espace réservé du numéro de diapositive 2">
             <a:extLst>
               <a:ext uri="{FF2B5EF4-FFF2-40B4-BE49-F238E27FC236}">
                 <a16:creationId xmlns:a16="http://schemas.microsoft.com/office/drawing/2014/main" id="{ECBEBDD9-D9CC-2B70-9E8C-523CC2893F62}"/>
@@ -12807,7 +13916,7 @@
           <a:p>
             <a:fld id="{33C783E2-4793-4F48-A271-51A73CC37D74}" type="slidenum">
               <a:rPr lang="fr-FR" smtClean="0"/>
-              <a:t>17</a:t>
+              <a:t>2</a:t>
             </a:fld>
             <a:endParaRPr lang="fr-FR"/>
           </a:p>
@@ -12950,6 +14059,1045 @@
 </file>
 
 <file path=ppt/slides/slide18.xml><?xml version="1.0" encoding="utf-8"?>
+<p:sld xmlns:a="http://schemas.openxmlformats.org/drawingml/2006/main" xmlns:p="http://schemas.openxmlformats.org/presentationml/2006/main" xmlns:r="http://schemas.openxmlformats.org/officeDocument/2006/relationships">
+  <p:cSld>
+    <p:spTree>
+      <p:nvGrpSpPr>
+        <p:cNvPr id="1" name=""/>
+        <p:cNvGrpSpPr/>
+        <p:nvPr/>
+      </p:nvGrpSpPr>
+      <p:grpSpPr/>
+      <p:sp>
+        <p:nvSpPr>
+          <p:cNvPr id="2" name="Title 1"/>
+          <p:cNvSpPr>
+            <a:spLocks noGrp="1"/>
+          </p:cNvSpPr>
+          <p:nvPr>
+            <p:ph type="title"/>
+          </p:nvPr>
+        </p:nvSpPr>
+        <p:spPr/>
+        <p:txBody>
+          <a:bodyPr>
+            <a:noAutofit/>
+          </a:bodyPr>
+          <a:lstStyle/>
+          <a:p>
+            <a:r>
+              <a:rPr sz="4000"/>
+              <a:t>Le stream, étape par étape</a:t>
+            </a:r>
+          </a:p>
+        </p:txBody>
+      </p:sp>
+      <p:sp>
+        <p:nvSpPr>
+          <p:cNvPr id="3" name="Introduction"/>
+          <p:cNvSpPr txBox="1"/>
+          <p:nvPr/>
+        </p:nvSpPr>
+        <p:spPr>
+          <a:xfrm>
+            <a:off x="777240" y="1234440"/>
+            <a:ext cx="10607040" cy="731520"/>
+          </a:xfrm>
+          <a:prstGeom prst="rect">
+            <a:avLst/>
+          </a:prstGeom>
+          <a:noFill/>
+        </p:spPr>
+        <p:txBody>
+          <a:bodyPr wrap="square">
+            <a:spAutoFit/>
+          </a:bodyPr>
+          <a:lstStyle/>
+          <a:p>
+            <a:r>
+              <a:rPr sz="2200">
+                <a:solidFill>
+                  <a:srgbClr val="FFFFFF"/>
+                </a:solidFill>
+              </a:rPr>
+              <a:t>Suivons quatre titres à travers les étapes, avec </a:t>
+            </a:r>
+            <a:r>
+              <a:rPr sz="2000">
+                <a:solidFill>
+                  <a:schemeClr val="accent4"/>
+                </a:solidFill>
+                <a:latin typeface="Consolas"/>
+              </a:rPr>
+              <a:t>LONGUEUR_MAX</a:t>
+            </a:r>
+            <a:r>
+              <a:rPr sz="2200">
+                <a:solidFill>
+                  <a:srgbClr val="FFFFFF"/>
+                </a:solidFill>
+              </a:rPr>
+              <a:t> = 8.</a:t>
+            </a:r>
+          </a:p>
+        </p:txBody>
+      </p:sp>
+      <p:sp>
+        <p:nvSpPr>
+          <p:cNvPr id="4" name="TextBox 3"/>
+          <p:cNvSpPr txBox="1"/>
+          <p:nvPr/>
+        </p:nvSpPr>
+        <p:spPr>
+          <a:xfrm>
+            <a:off x="777240" y="2011680"/>
+            <a:ext cx="2331720" cy="585216"/>
+          </a:xfrm>
+          <a:prstGeom prst="rect">
+            <a:avLst/>
+          </a:prstGeom>
+          <a:noFill/>
+        </p:spPr>
+        <p:txBody>
+          <a:bodyPr wrap="square" anchor="ctr">
+            <a:spAutoFit/>
+          </a:bodyPr>
+          <a:lstStyle/>
+          <a:p>
+            <a:r>
+              <a:rPr sz="2000" b="1">
+                <a:solidFill>
+                  <a:schemeClr val="accent4"/>
+                </a:solidFill>
+              </a:rPr>
+              <a:t>Étape</a:t>
+            </a:r>
+          </a:p>
+        </p:txBody>
+      </p:sp>
+      <p:sp>
+        <p:nvSpPr>
+          <p:cNvPr id="5" name="TextBox 4"/>
+          <p:cNvSpPr txBox="1"/>
+          <p:nvPr/>
+        </p:nvSpPr>
+        <p:spPr>
+          <a:xfrm>
+            <a:off x="3200400" y="2011680"/>
+            <a:ext cx="8183879" cy="585216"/>
+          </a:xfrm>
+          <a:prstGeom prst="rect">
+            <a:avLst/>
+          </a:prstGeom>
+          <a:noFill/>
+        </p:spPr>
+        <p:txBody>
+          <a:bodyPr wrap="square" anchor="ctr">
+            <a:spAutoFit/>
+          </a:bodyPr>
+          <a:lstStyle/>
+          <a:p>
+            <a:r>
+              <a:rPr sz="2000" b="1">
+                <a:solidFill>
+                  <a:schemeClr val="accent4"/>
+                </a:solidFill>
+              </a:rPr>
+              <a:t>Ce qui en sort</a:t>
+            </a:r>
+          </a:p>
+        </p:txBody>
+      </p:sp>
+      <p:sp>
+        <p:nvSpPr>
+          <p:cNvPr id="3" name="Espace réservé du numéro de diapositive 2">
+            <a:extLst>
+              <a:ext uri="{FF2B5EF4-FFF2-40B4-BE49-F238E27FC236}">
+                <a16:creationId xmlns:a16="http://schemas.microsoft.com/office/drawing/2014/main" id="{ECBEBDD9-D9CC-2B70-9E8C-523CC2893F62}"/>
+              </a:ext>
+            </a:extLst>
+          </p:cNvPr>
+          <p:cNvSpPr>
+            <a:spLocks noGrp="1"/>
+          </p:cNvSpPr>
+          <p:nvPr>
+            <p:ph type="sldNum" sz="quarter" idx="4"/>
+          </p:nvPr>
+        </p:nvSpPr>
+        <p:spPr/>
+        <p:txBody>
+          <a:bodyPr/>
+          <a:lstStyle/>
+          <a:p>
+            <a:fld id="{33C783E2-4793-4F48-A271-51A73CC37D74}" type="slidenum">
+              <a:rPr lang="fr-FR" smtClean="0"/>
+              <a:t>2</a:t>
+            </a:fld>
+            <a:endParaRPr lang="fr-FR"/>
+          </a:p>
+        </p:txBody>
+      </p:sp>
+      <p:sp>
+        <p:nvSpPr>
+          <p:cNvPr id="18" name="Repere de section"/>
+          <p:cNvSpPr txBox="1"/>
+          <p:nvPr/>
+        </p:nvSpPr>
+        <p:spPr>
+          <a:xfrm>
+            <a:off x="6583680" y="6382512"/>
+            <a:ext cx="4480560" cy="320040"/>
+          </a:xfrm>
+          <a:prstGeom prst="rect">
+            <a:avLst/>
+          </a:prstGeom>
+          <a:noFill/>
+        </p:spPr>
+        <p:txBody>
+          <a:bodyPr wrap="none" tIns="0" bIns="0">
+            <a:spAutoFit/>
+          </a:bodyPr>
+          <a:lstStyle/>
+          <a:p>
+            <a:pPr algn="r"/>
+            <a:r>
+              <a:rPr sz="1100">
+                <a:solidFill>
+                  <a:srgbClr val="BCBEC4"/>
+                </a:solidFill>
+              </a:rPr>
+              <a:t>LAM · </a:t>
+            </a:r>
+            <a:r>
+              <a:rPr sz="1100" b="1">
+                <a:solidFill>
+                  <a:schemeClr val="accent4"/>
+                </a:solidFill>
+              </a:rPr>
+              <a:t>3. JDK et références</a:t>
+            </a:r>
+          </a:p>
+        </p:txBody>
+      </p:sp>
+      <p:grpSp>
+        <p:nvGrpSpPr>
+          <p:cNvPr id="19" name="Ligne 1"/>
+          <p:cNvGrpSpPr/>
+          <p:nvPr/>
+        </p:nvGrpSpPr>
+        <p:grpSpPr>
+          <a:xfrm>
+            <a:off x="640080" y="2670048"/>
+            <a:ext cx="10881360" cy="585216"/>
+            <a:chOff x="640080" y="2670048"/>
+            <a:chExt cx="10881360" cy="585216"/>
+          </a:xfrm>
+        </p:grpSpPr>
+        <p:sp>
+          <p:nvSpPr>
+            <p:cNvPr id="6" name="Rounded Rectangle 5"/>
+            <p:cNvSpPr/>
+            <p:nvPr/>
+          </p:nvSpPr>
+          <p:spPr>
+            <a:xfrm>
+              <a:off x="640080" y="2670048"/>
+              <a:ext cx="10881360" cy="585216"/>
+            </a:xfrm>
+            <a:prstGeom prst="roundRect">
+              <a:avLst>
+                <a:gd name="adj" fmla="val 15625"/>
+              </a:avLst>
+            </a:prstGeom>
+            <a:solidFill>
+              <a:srgbClr val="1D1F22"/>
+            </a:solidFill>
+            <a:ln>
+              <a:noFill/>
+            </a:ln>
+            <a:effectLst>
+              <a:outerShdw blurRad="50800" dist="38100" dir="2700000" algn="tl" rotWithShape="0">
+                <a:prstClr val="black">
+                  <a:alpha val="40000"/>
+                </a:prstClr>
+              </a:outerShdw>
+            </a:effectLst>
+          </p:spPr>
+          <p:style>
+            <a:lnRef idx="1">
+              <a:schemeClr val="accent1"/>
+            </a:lnRef>
+            <a:fillRef idx="3">
+              <a:schemeClr val="accent1"/>
+            </a:fillRef>
+            <a:effectRef idx="2">
+              <a:schemeClr val="accent1"/>
+            </a:effectRef>
+            <a:fontRef idx="minor">
+              <a:schemeClr val="lt1"/>
+            </a:fontRef>
+          </p:style>
+          <p:txBody>
+            <a:bodyPr rtlCol="0" anchor="ctr"/>
+            <a:lstStyle/>
+            <a:p>
+              <a:pPr algn="ctr"/>
+            </a:p>
+          </p:txBody>
+        </p:sp>
+        <p:sp>
+          <p:nvSpPr>
+            <p:cNvPr id="7" name="TextBox 6"/>
+            <p:cNvSpPr txBox="1"/>
+            <p:nvPr/>
+          </p:nvSpPr>
+          <p:spPr>
+            <a:xfrm>
+              <a:off x="777240" y="2670048"/>
+              <a:ext cx="2331720" cy="585216"/>
+            </a:xfrm>
+            <a:prstGeom prst="rect">
+              <a:avLst/>
+            </a:prstGeom>
+            <a:noFill/>
+          </p:spPr>
+          <p:txBody>
+            <a:bodyPr wrap="square" anchor="ctr">
+              <a:spAutoFit/>
+            </a:bodyPr>
+            <a:lstStyle/>
+            <a:p>
+              <a:r>
+                <a:rPr sz="2200">
+                  <a:solidFill>
+                    <a:srgbClr val="FFFFFF"/>
+                  </a:solidFill>
+                </a:rPr>
+                <a:t>1. </a:t>
+              </a:r>
+              <a:r>
+                <a:rPr sz="2000">
+                  <a:solidFill>
+                    <a:schemeClr val="accent4"/>
+                  </a:solidFill>
+                  <a:latin typeface="Consolas"/>
+                </a:rPr>
+                <a:t>stream</a:t>
+              </a:r>
+            </a:p>
+          </p:txBody>
+        </p:sp>
+        <p:sp>
+          <p:nvSpPr>
+            <p:cNvPr id="8" name="TextBox 7"/>
+            <p:cNvSpPr txBox="1"/>
+            <p:nvPr/>
+          </p:nvSpPr>
+          <p:spPr>
+            <a:xfrm>
+              <a:off x="3200400" y="2670048"/>
+              <a:ext cx="8183879" cy="585216"/>
+            </a:xfrm>
+            <a:prstGeom prst="rect">
+              <a:avLst/>
+            </a:prstGeom>
+            <a:noFill/>
+          </p:spPr>
+          <p:txBody>
+            <a:bodyPr wrap="square" anchor="ctr">
+              <a:spAutoFit/>
+            </a:bodyPr>
+            <a:lstStyle/>
+            <a:p>
+              <a:r>
+                <a:rPr sz="2200">
+                  <a:solidFill>
+                    <a:srgbClr val="FFFFFF"/>
+                  </a:solidFill>
+                </a:rPr>
+                <a:t>Nana · La Débâcle · Germinal · Le Docteur Pascal</a:t>
+              </a:r>
+            </a:p>
+          </p:txBody>
+        </p:sp>
+      </p:grpSp>
+      <p:grpSp>
+        <p:nvGrpSpPr>
+          <p:cNvPr id="20" name="Ligne 2"/>
+          <p:cNvGrpSpPr/>
+          <p:nvPr/>
+        </p:nvGrpSpPr>
+        <p:grpSpPr>
+          <a:xfrm>
+            <a:off x="640080" y="3328415"/>
+            <a:ext cx="10881360" cy="585216"/>
+            <a:chOff x="640080" y="3328415"/>
+            <a:chExt cx="10881360" cy="585216"/>
+          </a:xfrm>
+        </p:grpSpPr>
+        <p:sp>
+          <p:nvSpPr>
+            <p:cNvPr id="9" name="Rounded Rectangle 8"/>
+            <p:cNvSpPr/>
+            <p:nvPr/>
+          </p:nvSpPr>
+          <p:spPr>
+            <a:xfrm>
+              <a:off x="640080" y="3328415"/>
+              <a:ext cx="10881360" cy="585216"/>
+            </a:xfrm>
+            <a:prstGeom prst="roundRect">
+              <a:avLst>
+                <a:gd name="adj" fmla="val 15625"/>
+              </a:avLst>
+            </a:prstGeom>
+            <a:solidFill>
+              <a:srgbClr val="1D1F22"/>
+            </a:solidFill>
+            <a:ln>
+              <a:noFill/>
+            </a:ln>
+            <a:effectLst>
+              <a:outerShdw blurRad="50800" dist="38100" dir="2700000" algn="tl" rotWithShape="0">
+                <a:prstClr val="black">
+                  <a:alpha val="40000"/>
+                </a:prstClr>
+              </a:outerShdw>
+            </a:effectLst>
+          </p:spPr>
+          <p:style>
+            <a:lnRef idx="1">
+              <a:schemeClr val="accent1"/>
+            </a:lnRef>
+            <a:fillRef idx="3">
+              <a:schemeClr val="accent1"/>
+            </a:fillRef>
+            <a:effectRef idx="2">
+              <a:schemeClr val="accent1"/>
+            </a:effectRef>
+            <a:fontRef idx="minor">
+              <a:schemeClr val="lt1"/>
+            </a:fontRef>
+          </p:style>
+          <p:txBody>
+            <a:bodyPr rtlCol="0" anchor="ctr"/>
+            <a:lstStyle/>
+            <a:p>
+              <a:pPr algn="ctr"/>
+            </a:p>
+          </p:txBody>
+        </p:sp>
+        <p:sp>
+          <p:nvSpPr>
+            <p:cNvPr id="10" name="TextBox 9"/>
+            <p:cNvSpPr txBox="1"/>
+            <p:nvPr/>
+          </p:nvSpPr>
+          <p:spPr>
+            <a:xfrm>
+              <a:off x="777240" y="3328415"/>
+              <a:ext cx="2331720" cy="585216"/>
+            </a:xfrm>
+            <a:prstGeom prst="rect">
+              <a:avLst/>
+            </a:prstGeom>
+            <a:noFill/>
+          </p:spPr>
+          <p:txBody>
+            <a:bodyPr wrap="square" anchor="ctr">
+              <a:spAutoFit/>
+            </a:bodyPr>
+            <a:lstStyle/>
+            <a:p>
+              <a:r>
+                <a:rPr sz="2200">
+                  <a:solidFill>
+                    <a:srgbClr val="FFFFFF"/>
+                  </a:solidFill>
+                </a:rPr>
+                <a:t>2. </a:t>
+              </a:r>
+              <a:r>
+                <a:rPr sz="2000">
+                  <a:solidFill>
+                    <a:schemeClr val="accent4"/>
+                  </a:solidFill>
+                  <a:latin typeface="Consolas"/>
+                </a:rPr>
+                <a:t>filter</a:t>
+              </a:r>
+            </a:p>
+          </p:txBody>
+        </p:sp>
+        <p:sp>
+          <p:nvSpPr>
+            <p:cNvPr id="11" name="TextBox 10"/>
+            <p:cNvSpPr txBox="1"/>
+            <p:nvPr/>
+          </p:nvSpPr>
+          <p:spPr>
+            <a:xfrm>
+              <a:off x="3200400" y="3328415"/>
+              <a:ext cx="8183879" cy="585216"/>
+            </a:xfrm>
+            <a:prstGeom prst="rect">
+              <a:avLst/>
+            </a:prstGeom>
+            <a:noFill/>
+          </p:spPr>
+          <p:txBody>
+            <a:bodyPr wrap="square" anchor="ctr">
+              <a:spAutoFit/>
+            </a:bodyPr>
+            <a:lstStyle/>
+            <a:p>
+              <a:r>
+                <a:rPr sz="2200">
+                  <a:solidFill>
+                    <a:srgbClr val="FFFFFF"/>
+                  </a:solidFill>
+                </a:rPr>
+                <a:t>La Débâcle · Le Docteur Pascal</a:t>
+              </a:r>
+            </a:p>
+          </p:txBody>
+        </p:sp>
+      </p:grpSp>
+      <p:grpSp>
+        <p:nvGrpSpPr>
+          <p:cNvPr id="21" name="Ligne 3"/>
+          <p:cNvGrpSpPr/>
+          <p:nvPr/>
+        </p:nvGrpSpPr>
+        <p:grpSpPr>
+          <a:xfrm>
+            <a:off x="640080" y="3986783"/>
+            <a:ext cx="10881360" cy="585216"/>
+            <a:chOff x="640080" y="3986783"/>
+            <a:chExt cx="10881360" cy="585216"/>
+          </a:xfrm>
+        </p:grpSpPr>
+        <p:sp>
+          <p:nvSpPr>
+            <p:cNvPr id="12" name="Rounded Rectangle 11"/>
+            <p:cNvSpPr/>
+            <p:nvPr/>
+          </p:nvSpPr>
+          <p:spPr>
+            <a:xfrm>
+              <a:off x="640080" y="3986783"/>
+              <a:ext cx="10881360" cy="585216"/>
+            </a:xfrm>
+            <a:prstGeom prst="roundRect">
+              <a:avLst>
+                <a:gd name="adj" fmla="val 15625"/>
+              </a:avLst>
+            </a:prstGeom>
+            <a:solidFill>
+              <a:srgbClr val="1D1F22"/>
+            </a:solidFill>
+            <a:ln>
+              <a:noFill/>
+            </a:ln>
+            <a:effectLst>
+              <a:outerShdw blurRad="50800" dist="38100" dir="2700000" algn="tl" rotWithShape="0">
+                <a:prstClr val="black">
+                  <a:alpha val="40000"/>
+                </a:prstClr>
+              </a:outerShdw>
+            </a:effectLst>
+          </p:spPr>
+          <p:style>
+            <a:lnRef idx="1">
+              <a:schemeClr val="accent1"/>
+            </a:lnRef>
+            <a:fillRef idx="3">
+              <a:schemeClr val="accent1"/>
+            </a:fillRef>
+            <a:effectRef idx="2">
+              <a:schemeClr val="accent1"/>
+            </a:effectRef>
+            <a:fontRef idx="minor">
+              <a:schemeClr val="lt1"/>
+            </a:fontRef>
+          </p:style>
+          <p:txBody>
+            <a:bodyPr rtlCol="0" anchor="ctr"/>
+            <a:lstStyle/>
+            <a:p>
+              <a:pPr algn="ctr"/>
+            </a:p>
+          </p:txBody>
+        </p:sp>
+        <p:sp>
+          <p:nvSpPr>
+            <p:cNvPr id="13" name="TextBox 12"/>
+            <p:cNvSpPr txBox="1"/>
+            <p:nvPr/>
+          </p:nvSpPr>
+          <p:spPr>
+            <a:xfrm>
+              <a:off x="777240" y="3986783"/>
+              <a:ext cx="2331720" cy="585216"/>
+            </a:xfrm>
+            <a:prstGeom prst="rect">
+              <a:avLst/>
+            </a:prstGeom>
+            <a:noFill/>
+          </p:spPr>
+          <p:txBody>
+            <a:bodyPr wrap="square" anchor="ctr">
+              <a:spAutoFit/>
+            </a:bodyPr>
+            <a:lstStyle/>
+            <a:p>
+              <a:r>
+                <a:rPr sz="2200">
+                  <a:solidFill>
+                    <a:srgbClr val="FFFFFF"/>
+                  </a:solidFill>
+                </a:rPr>
+                <a:t>3. </a:t>
+              </a:r>
+              <a:r>
+                <a:rPr sz="2000">
+                  <a:solidFill>
+                    <a:schemeClr val="accent4"/>
+                  </a:solidFill>
+                  <a:latin typeface="Consolas"/>
+                </a:rPr>
+                <a:t>map</a:t>
+              </a:r>
+            </a:p>
+          </p:txBody>
+        </p:sp>
+        <p:sp>
+          <p:nvSpPr>
+            <p:cNvPr id="14" name="TextBox 13"/>
+            <p:cNvSpPr txBox="1"/>
+            <p:nvPr/>
+          </p:nvSpPr>
+          <p:spPr>
+            <a:xfrm>
+              <a:off x="3200400" y="3986783"/>
+              <a:ext cx="8183879" cy="585216"/>
+            </a:xfrm>
+            <a:prstGeom prst="rect">
+              <a:avLst/>
+            </a:prstGeom>
+            <a:noFill/>
+          </p:spPr>
+          <p:txBody>
+            <a:bodyPr wrap="square" anchor="ctr">
+              <a:spAutoFit/>
+            </a:bodyPr>
+            <a:lstStyle/>
+            <a:p>
+              <a:r>
+                <a:rPr sz="2200">
+                  <a:solidFill>
+                    <a:srgbClr val="FFFFFF"/>
+                  </a:solidFill>
+                </a:rPr>
+                <a:t>LA DÉBÂCLE · LE DOCTEUR PASCAL</a:t>
+              </a:r>
+            </a:p>
+          </p:txBody>
+        </p:sp>
+      </p:grpSp>
+      <p:grpSp>
+        <p:nvGrpSpPr>
+          <p:cNvPr id="22" name="Ligne 4"/>
+          <p:cNvGrpSpPr/>
+          <p:nvPr/>
+        </p:nvGrpSpPr>
+        <p:grpSpPr>
+          <a:xfrm>
+            <a:off x="640080" y="4645151"/>
+            <a:ext cx="10881360" cy="585216"/>
+            <a:chOff x="640080" y="4645151"/>
+            <a:chExt cx="10881360" cy="585216"/>
+          </a:xfrm>
+        </p:grpSpPr>
+        <p:sp>
+          <p:nvSpPr>
+            <p:cNvPr id="15" name="Rounded Rectangle 14"/>
+            <p:cNvSpPr/>
+            <p:nvPr/>
+          </p:nvSpPr>
+          <p:spPr>
+            <a:xfrm>
+              <a:off x="640080" y="4645151"/>
+              <a:ext cx="10881360" cy="585216"/>
+            </a:xfrm>
+            <a:prstGeom prst="roundRect">
+              <a:avLst>
+                <a:gd name="adj" fmla="val 15625"/>
+              </a:avLst>
+            </a:prstGeom>
+            <a:solidFill>
+              <a:srgbClr val="1D1F22"/>
+            </a:solidFill>
+            <a:ln>
+              <a:noFill/>
+            </a:ln>
+            <a:effectLst>
+              <a:outerShdw blurRad="50800" dist="38100" dir="2700000" algn="tl" rotWithShape="0">
+                <a:prstClr val="black">
+                  <a:alpha val="40000"/>
+                </a:prstClr>
+              </a:outerShdw>
+            </a:effectLst>
+          </p:spPr>
+          <p:style>
+            <a:lnRef idx="1">
+              <a:schemeClr val="accent1"/>
+            </a:lnRef>
+            <a:fillRef idx="3">
+              <a:schemeClr val="accent1"/>
+            </a:fillRef>
+            <a:effectRef idx="2">
+              <a:schemeClr val="accent1"/>
+            </a:effectRef>
+            <a:fontRef idx="minor">
+              <a:schemeClr val="lt1"/>
+            </a:fontRef>
+          </p:style>
+          <p:txBody>
+            <a:bodyPr rtlCol="0" anchor="ctr"/>
+            <a:lstStyle/>
+            <a:p>
+              <a:pPr algn="ctr"/>
+            </a:p>
+          </p:txBody>
+        </p:sp>
+        <p:sp>
+          <p:nvSpPr>
+            <p:cNvPr id="16" name="TextBox 15"/>
+            <p:cNvSpPr txBox="1"/>
+            <p:nvPr/>
+          </p:nvSpPr>
+          <p:spPr>
+            <a:xfrm>
+              <a:off x="777240" y="4645151"/>
+              <a:ext cx="2331720" cy="585216"/>
+            </a:xfrm>
+            <a:prstGeom prst="rect">
+              <a:avLst/>
+            </a:prstGeom>
+            <a:noFill/>
+          </p:spPr>
+          <p:txBody>
+            <a:bodyPr wrap="square" anchor="ctr">
+              <a:spAutoFit/>
+            </a:bodyPr>
+            <a:lstStyle/>
+            <a:p>
+              <a:r>
+                <a:rPr sz="2200">
+                  <a:solidFill>
+                    <a:srgbClr val="FFFFFF"/>
+                  </a:solidFill>
+                </a:rPr>
+                <a:t>4. </a:t>
+              </a:r>
+              <a:r>
+                <a:rPr sz="2000">
+                  <a:solidFill>
+                    <a:schemeClr val="accent4"/>
+                  </a:solidFill>
+                  <a:latin typeface="Consolas"/>
+                </a:rPr>
+                <a:t>collect</a:t>
+              </a:r>
+            </a:p>
+          </p:txBody>
+        </p:sp>
+        <p:sp>
+          <p:nvSpPr>
+            <p:cNvPr id="17" name="TextBox 16"/>
+            <p:cNvSpPr txBox="1"/>
+            <p:nvPr/>
+          </p:nvSpPr>
+          <p:spPr>
+            <a:xfrm>
+              <a:off x="3200400" y="4645151"/>
+              <a:ext cx="8183879" cy="585216"/>
+            </a:xfrm>
+            <a:prstGeom prst="rect">
+              <a:avLst/>
+            </a:prstGeom>
+            <a:noFill/>
+          </p:spPr>
+          <p:txBody>
+            <a:bodyPr wrap="square" anchor="ctr">
+              <a:spAutoFit/>
+            </a:bodyPr>
+            <a:lstStyle/>
+            <a:p>
+              <a:r>
+                <a:rPr sz="2200">
+                  <a:solidFill>
+                    <a:srgbClr val="FFFFFF"/>
+                  </a:solidFill>
+                </a:rPr>
+                <a:t>"LA DÉBÂCLE, LE DOCTEUR PASCAL"</a:t>
+              </a:r>
+            </a:p>
+          </p:txBody>
+        </p:sp>
+      </p:grpSp>
+    </p:spTree>
+  </p:cSld>
+  <p:clrMapOvr>
+    <a:masterClrMapping/>
+  </p:clrMapOvr>
+  <p:timing>
+    <p:tnLst>
+      <p:par>
+        <p:cTn id="1" dur="indefinite" restart="never" nodeType="tmRoot">
+          <p:childTnLst>
+            <p:seq concurrent="1" nextAc="seek">
+              <p:cTn id="2" dur="indefinite" nodeType="mainSeq">
+                <p:childTnLst>
+                  <p:par>
+                    <p:cTn id="3" fill="hold">
+                      <p:stCondLst>
+                        <p:cond delay="indefinite"/>
+                      </p:stCondLst>
+                      <p:childTnLst>
+                        <p:par>
+                          <p:cTn id="4" fill="hold">
+                            <p:stCondLst>
+                              <p:cond delay="0"/>
+                            </p:stCondLst>
+                            <p:childTnLst>
+                              <p:par>
+                                <p:cTn id="5" presetID="22" presetClass="entr" presetSubtype="8" fill="hold" nodeType="clickEffect">
+                                  <p:stCondLst>
+                                    <p:cond delay="0"/>
+                                  </p:stCondLst>
+                                  <p:childTnLst>
+                                    <p:set>
+                                      <p:cBhvr>
+                                        <p:cTn id="6" dur="1" fill="hold">
+                                          <p:stCondLst>
+                                            <p:cond delay="0"/>
+                                          </p:stCondLst>
+                                        </p:cTn>
+                                        <p:tgtEl>
+                                          <p:spTgt spid="19"/>
+                                        </p:tgtEl>
+                                        <p:attrNameLst>
+                                          <p:attrName>style.visibility</p:attrName>
+                                        </p:attrNameLst>
+                                      </p:cBhvr>
+                                      <p:to>
+                                        <p:strVal val="visible"/>
+                                      </p:to>
+                                    </p:set>
+                                    <p:animEffect transition="in" filter="wipe(left)">
+                                      <p:cBhvr>
+                                        <p:cTn id="7" dur="500"/>
+                                        <p:tgtEl>
+                                          <p:spTgt spid="19"/>
+                                        </p:tgtEl>
+                                      </p:cBhvr>
+                                    </p:animEffect>
+                                  </p:childTnLst>
+                                </p:cTn>
+                              </p:par>
+                            </p:childTnLst>
+                          </p:cTn>
+                        </p:par>
+                      </p:childTnLst>
+                    </p:cTn>
+                  </p:par>
+                  <p:par>
+                    <p:cTn id="8" fill="hold">
+                      <p:stCondLst>
+                        <p:cond delay="indefinite"/>
+                      </p:stCondLst>
+                      <p:childTnLst>
+                        <p:par>
+                          <p:cTn id="9" fill="hold">
+                            <p:stCondLst>
+                              <p:cond delay="0"/>
+                            </p:stCondLst>
+                            <p:childTnLst>
+                              <p:par>
+                                <p:cTn id="10" presetID="22" presetClass="entr" presetSubtype="8" fill="hold" nodeType="clickEffect">
+                                  <p:stCondLst>
+                                    <p:cond delay="0"/>
+                                  </p:stCondLst>
+                                  <p:childTnLst>
+                                    <p:set>
+                                      <p:cBhvr>
+                                        <p:cTn id="11" dur="1" fill="hold">
+                                          <p:stCondLst>
+                                            <p:cond delay="0"/>
+                                          </p:stCondLst>
+                                        </p:cTn>
+                                        <p:tgtEl>
+                                          <p:spTgt spid="20"/>
+                                        </p:tgtEl>
+                                        <p:attrNameLst>
+                                          <p:attrName>style.visibility</p:attrName>
+                                        </p:attrNameLst>
+                                      </p:cBhvr>
+                                      <p:to>
+                                        <p:strVal val="visible"/>
+                                      </p:to>
+                                    </p:set>
+                                    <p:animEffect transition="in" filter="wipe(left)">
+                                      <p:cBhvr>
+                                        <p:cTn id="12" dur="500"/>
+                                        <p:tgtEl>
+                                          <p:spTgt spid="20"/>
+                                        </p:tgtEl>
+                                      </p:cBhvr>
+                                    </p:animEffect>
+                                  </p:childTnLst>
+                                </p:cTn>
+                              </p:par>
+                            </p:childTnLst>
+                          </p:cTn>
+                        </p:par>
+                      </p:childTnLst>
+                    </p:cTn>
+                  </p:par>
+                  <p:par>
+                    <p:cTn id="13" fill="hold">
+                      <p:stCondLst>
+                        <p:cond delay="indefinite"/>
+                      </p:stCondLst>
+                      <p:childTnLst>
+                        <p:par>
+                          <p:cTn id="14" fill="hold">
+                            <p:stCondLst>
+                              <p:cond delay="0"/>
+                            </p:stCondLst>
+                            <p:childTnLst>
+                              <p:par>
+                                <p:cTn id="15" presetID="22" presetClass="entr" presetSubtype="8" fill="hold" nodeType="clickEffect">
+                                  <p:stCondLst>
+                                    <p:cond delay="0"/>
+                                  </p:stCondLst>
+                                  <p:childTnLst>
+                                    <p:set>
+                                      <p:cBhvr>
+                                        <p:cTn id="16" dur="1" fill="hold">
+                                          <p:stCondLst>
+                                            <p:cond delay="0"/>
+                                          </p:stCondLst>
+                                        </p:cTn>
+                                        <p:tgtEl>
+                                          <p:spTgt spid="21"/>
+                                        </p:tgtEl>
+                                        <p:attrNameLst>
+                                          <p:attrName>style.visibility</p:attrName>
+                                        </p:attrNameLst>
+                                      </p:cBhvr>
+                                      <p:to>
+                                        <p:strVal val="visible"/>
+                                      </p:to>
+                                    </p:set>
+                                    <p:animEffect transition="in" filter="wipe(left)">
+                                      <p:cBhvr>
+                                        <p:cTn id="17" dur="500"/>
+                                        <p:tgtEl>
+                                          <p:spTgt spid="21"/>
+                                        </p:tgtEl>
+                                      </p:cBhvr>
+                                    </p:animEffect>
+                                  </p:childTnLst>
+                                </p:cTn>
+                              </p:par>
+                            </p:childTnLst>
+                          </p:cTn>
+                        </p:par>
+                      </p:childTnLst>
+                    </p:cTn>
+                  </p:par>
+                  <p:par>
+                    <p:cTn id="18" fill="hold">
+                      <p:stCondLst>
+                        <p:cond delay="indefinite"/>
+                      </p:stCondLst>
+                      <p:childTnLst>
+                        <p:par>
+                          <p:cTn id="19" fill="hold">
+                            <p:stCondLst>
+                              <p:cond delay="0"/>
+                            </p:stCondLst>
+                            <p:childTnLst>
+                              <p:par>
+                                <p:cTn id="20" presetID="22" presetClass="entr" presetSubtype="8" fill="hold" nodeType="clickEffect">
+                                  <p:stCondLst>
+                                    <p:cond delay="0"/>
+                                  </p:stCondLst>
+                                  <p:childTnLst>
+                                    <p:set>
+                                      <p:cBhvr>
+                                        <p:cTn id="21" dur="1" fill="hold">
+                                          <p:stCondLst>
+                                            <p:cond delay="0"/>
+                                          </p:stCondLst>
+                                        </p:cTn>
+                                        <p:tgtEl>
+                                          <p:spTgt spid="22"/>
+                                        </p:tgtEl>
+                                        <p:attrNameLst>
+                                          <p:attrName>style.visibility</p:attrName>
+                                        </p:attrNameLst>
+                                      </p:cBhvr>
+                                      <p:to>
+                                        <p:strVal val="visible"/>
+                                      </p:to>
+                                    </p:set>
+                                    <p:animEffect transition="in" filter="wipe(left)">
+                                      <p:cBhvr>
+                                        <p:cTn id="22" dur="500"/>
+                                        <p:tgtEl>
+                                          <p:spTgt spid="22"/>
+                                        </p:tgtEl>
+                                      </p:cBhvr>
+                                    </p:animEffect>
+                                  </p:childTnLst>
+                                </p:cTn>
+                              </p:par>
+                            </p:childTnLst>
+                          </p:cTn>
+                        </p:par>
+                      </p:childTnLst>
+                    </p:cTn>
+                  </p:par>
+                </p:childTnLst>
+              </p:cTn>
+              <p:prevCondLst>
+                <p:cond evt="onPrev" delay="0">
+                  <p:tgtEl>
+                    <p:sldTgt/>
+                  </p:tgtEl>
+                </p:cond>
+              </p:prevCondLst>
+              <p:nextCondLst>
+                <p:cond evt="onNext" delay="0">
+                  <p:tgtEl>
+                    <p:sldTgt/>
+                  </p:tgtEl>
+                </p:cond>
+              </p:nextCondLst>
+            </p:seq>
+          </p:childTnLst>
+        </p:cTn>
+      </p:par>
+    </p:tnLst>
+  </p:timing>
+</p:sld>
+</file>
+
+<file path=ppt/slides/slide19.xml><?xml version="1.0" encoding="utf-8"?>
 <p:sld xmlns:a="http://schemas.openxmlformats.org/drawingml/2006/main" xmlns:r="http://schemas.openxmlformats.org/officeDocument/2006/relationships" xmlns:p="http://schemas.openxmlformats.org/presentationml/2006/main">
   <p:cSld>
     <p:spTree>
@@ -13249,372 +15397,6 @@
   <p:clrMapOvr>
     <a:masterClrMapping/>
   </p:clrMapOvr>
-</p:sld>
-</file>
-
-<file path=ppt/slides/slide19.xml><?xml version="1.0" encoding="utf-8"?>
-<p:sld xmlns:a="http://schemas.openxmlformats.org/drawingml/2006/main" xmlns:r="http://schemas.openxmlformats.org/officeDocument/2006/relationships" xmlns:p="http://schemas.openxmlformats.org/presentationml/2006/main">
-  <p:cSld>
-    <p:spTree>
-      <p:nvGrpSpPr>
-        <p:cNvPr id="1" name=""/>
-        <p:cNvGrpSpPr/>
-        <p:nvPr/>
-      </p:nvGrpSpPr>
-      <p:grpSpPr>
-        <a:xfrm>
-          <a:off x="0" y="0"/>
-          <a:ext cx="0" cy="0"/>
-          <a:chOff x="0" y="0"/>
-          <a:chExt cx="0" cy="0"/>
-        </a:xfrm>
-      </p:grpSpPr>
-      <p:sp>
-        <p:nvSpPr>
-          <p:cNvPr id="2" name="Title 1"/>
-          <p:cNvSpPr>
-            <a:spLocks noGrp="1"/>
-          </p:cNvSpPr>
-          <p:nvPr>
-            <p:ph type="title"/>
-          </p:nvPr>
-        </p:nvSpPr>
-        <p:spPr/>
-        <p:txBody>
-          <a:bodyPr>
-            <a:noAutofit/>
-          </a:bodyPr>
-          <a:lstStyle/>
-          <a:p>
-            <a:r>
-              <a:rPr sz="4000"/>
-              <a:t>Vous les retrouverez au module FX</a:t>
-            </a:r>
-          </a:p>
-        </p:txBody>
-      </p:sp>
-      <p:sp>
-        <p:nvSpPr>
-          <p:cNvPr id="3" name="Content Placeholder 2"/>
-          <p:cNvSpPr>
-            <a:spLocks noGrp="1"/>
-          </p:cNvSpPr>
-          <p:nvPr>
-            <p:ph idx="1"/>
-          </p:nvPr>
-        </p:nvSpPr>
-        <p:spPr>
-          <a:xfrm>
-            <a:off x="640080" y="1371600"/>
-            <a:ext cx="10881360" cy="2225040"/>
-          </a:xfrm>
-        </p:spPr>
-        <p:txBody>
-          <a:bodyPr/>
-          <a:lstStyle/>
-          <a:p>
-            <a:pPr marL="0" indent="0">
-              <a:spcAft>
-                <a:spcPts val="1000"/>
-              </a:spcAft>
-              <a:buNone/>
-            </a:pPr>
-            <a:r>
-              <a:rPr sz="2800"/>
-              <a:t>Un bouton reçoit le comportement à déclencher au clic</a:t>
-            </a:r>
-          </a:p>
-          <a:p>
-            <a:pPr marL="0" indent="0">
-              <a:spcAft>
-                <a:spcPts val="1000"/>
-              </a:spcAft>
-              <a:buNone/>
-            </a:pPr>
-            <a:r>
-              <a:rPr sz="2800"/>
-              <a:t>Le type cible est </a:t>
-            </a:r>
-            <a:r>
-              <a:rPr sz="2400">
-                <a:solidFill>
-                  <a:schemeClr val="accent4"/>
-                </a:solidFill>
-                <a:latin typeface="Consolas"/>
-              </a:rPr>
-              <a:t>EventHandler</a:t>
-            </a:r>
-            <a:r>
-              <a:rPr sz="2800"/>
-              <a:t>, une interface fonctionnelle</a:t>
-            </a:r>
-          </a:p>
-          <a:p>
-            <a:pPr marL="0" indent="0">
-              <a:spcAft>
-                <a:spcPts val="1000"/>
-              </a:spcAft>
-              <a:buNone/>
-            </a:pPr>
-            <a:r>
-              <a:rPr sz="2800"/>
-              <a:t>Le module FX dira le reste</a:t>
-            </a:r>
-          </a:p>
-        </p:txBody>
-      </p:sp>
-      <p:sp>
-        <p:nvSpPr>
-          <p:cNvPr id="4" name="Code"/>
-          <p:cNvSpPr txBox="1"/>
-          <p:nvPr/>
-        </p:nvSpPr>
-        <p:spPr>
-          <a:xfrm>
-            <a:off x="2520950" y="3733799"/>
-            <a:ext cx="7150100" cy="548640"/>
-          </a:xfrm>
-          <a:prstGeom prst="roundRect">
-            <a:avLst>
-              <a:gd name="adj" fmla="val 16666"/>
-            </a:avLst>
-          </a:prstGeom>
-          <a:solidFill>
-            <a:srgbClr val="1D1F22"/>
-          </a:solidFill>
-          <a:effectLst>
-            <a:outerShdw blurRad="50800" dist="38100" dir="2700000" algn="tl" rotWithShape="0">
-              <a:prstClr val="black">
-                <a:alpha val="40000"/>
-              </a:prstClr>
-            </a:outerShdw>
-          </a:effectLst>
-        </p:spPr>
-        <p:txBody>
-          <a:bodyPr wrap="none" lIns="137160" tIns="91440" rIns="137160" bIns="91440"/>
-          <a:lstStyle/>
-          <a:p>
-            <a:pPr>
-              <a:lnSpc>
-                <a:spcPct val="100000"/>
-              </a:lnSpc>
-              <a:spcBef>
-                <a:spcPts val="0"/>
-              </a:spcBef>
-              <a:spcAft>
-                <a:spcPts val="0"/>
-              </a:spcAft>
-            </a:pPr>
-            <a:r>
-              <a:rPr sz="1800">
-                <a:solidFill>
-                  <a:srgbClr val="BCBEC4"/>
-                </a:solidFill>
-                <a:latin typeface="Consolas"/>
-              </a:rPr>
-              <a:t>bouton.</a:t>
-            </a:r>
-            <a:r>
-              <a:rPr sz="1800">
-                <a:solidFill>
-                  <a:srgbClr val="56A8F5"/>
-                </a:solidFill>
-                <a:latin typeface="Consolas"/>
-              </a:rPr>
-              <a:t>setOnAction</a:t>
-            </a:r>
-            <a:r>
-              <a:rPr sz="1800">
-                <a:solidFill>
-                  <a:srgbClr val="BCBEC4"/>
-                </a:solidFill>
-                <a:latin typeface="Consolas"/>
-              </a:rPr>
-              <a:t>(evenement -&gt; </a:t>
-            </a:r>
-            <a:r>
-              <a:rPr sz="1800">
-                <a:solidFill>
-                  <a:srgbClr val="56A8F5"/>
-                </a:solidFill>
-                <a:latin typeface="Consolas"/>
-              </a:rPr>
-              <a:t>afficherTotal</a:t>
-            </a:r>
-            <a:r>
-              <a:rPr sz="1800">
-                <a:solidFill>
-                  <a:srgbClr val="BCBEC4"/>
-                </a:solidFill>
-                <a:latin typeface="Consolas"/>
-              </a:rPr>
-              <a:t>());</a:t>
-            </a:r>
-          </a:p>
-        </p:txBody>
-      </p:sp>
-      <p:sp>
-        <p:nvSpPr>
-          <p:cNvPr id="6" name="Espace réservé du numéro de diapositive 2">
-            <a:extLst>
-              <a:ext uri="{FF2B5EF4-FFF2-40B4-BE49-F238E27FC236}">
-                <a16:creationId xmlns:a16="http://schemas.microsoft.com/office/drawing/2014/main" id="{ECBEBDD9-D9CC-2B70-9E8C-523CC2893F62}"/>
-              </a:ext>
-            </a:extLst>
-          </p:cNvPr>
-          <p:cNvSpPr>
-            <a:spLocks noGrp="1"/>
-          </p:cNvSpPr>
-          <p:nvPr>
-            <p:ph type="sldNum" sz="quarter" idx="4"/>
-          </p:nvPr>
-        </p:nvSpPr>
-        <p:spPr/>
-        <p:txBody>
-          <a:bodyPr/>
-          <a:lstStyle/>
-          <a:p>
-            <a:fld id="{33C783E2-4793-4F48-A271-51A73CC37D74}" type="slidenum">
-              <a:rPr lang="fr-FR" smtClean="0"/>
-              <a:t>19</a:t>
-            </a:fld>
-            <a:endParaRPr lang="fr-FR"/>
-          </a:p>
-        </p:txBody>
-      </p:sp>
-      <p:sp>
-        <p:nvSpPr>
-          <p:cNvPr id="5" name="Repere de section"/>
-          <p:cNvSpPr txBox="1"/>
-          <p:nvPr/>
-        </p:nvSpPr>
-        <p:spPr>
-          <a:xfrm>
-            <a:off x="6583680" y="6382512"/>
-            <a:ext cx="4480560" cy="320040"/>
-          </a:xfrm>
-          <a:prstGeom prst="rect">
-            <a:avLst/>
-          </a:prstGeom>
-          <a:noFill/>
-        </p:spPr>
-        <p:txBody>
-          <a:bodyPr wrap="none" tIns="0" bIns="0">
-            <a:spAutoFit/>
-          </a:bodyPr>
-          <a:lstStyle/>
-          <a:p>
-            <a:pPr algn="r"/>
-            <a:r>
-              <a:rPr sz="1100">
-                <a:solidFill>
-                  <a:srgbClr val="BCBEC4"/>
-                </a:solidFill>
-              </a:rPr>
-              <a:t>LAM · </a:t>
-            </a:r>
-            <a:r>
-              <a:rPr sz="1100" b="1">
-                <a:solidFill>
-                  <a:schemeClr val="accent4"/>
-                </a:solidFill>
-              </a:rPr>
-              <a:t>3. JDK et références</a:t>
-            </a:r>
-          </a:p>
-        </p:txBody>
-      </p:sp>
-    </p:spTree>
-  </p:cSld>
-  <p:clrMapOvr>
-    <a:masterClrMapping/>
-  </p:clrMapOvr>
-  <p:timing>
-    <p:tnLst>
-      <p:par>
-        <p:cTn id="1" dur="indefinite" restart="never" nodeType="tmRoot">
-          <p:childTnLst>
-            <p:seq concurrent="1" nextAc="seek">
-              <p:cTn id="2" dur="indefinite" nodeType="mainSeq">
-                <p:childTnLst>
-                  <p:par>
-                    <p:cTn id="3" fill="hold">
-                      <p:stCondLst>
-                        <p:cond delay="indefinite"/>
-                      </p:stCondLst>
-                      <p:childTnLst>
-                        <p:par>
-                          <p:cTn id="4" fill="hold">
-                            <p:stCondLst>
-                              <p:cond delay="0"/>
-                            </p:stCondLst>
-                            <p:childTnLst>
-                              <p:par>
-                                <p:cTn id="5" presetID="10" presetClass="entr" presetSubtype="0" fill="hold" grpId="0" nodeType="clickEffect">
-                                  <p:stCondLst>
-                                    <p:cond delay="0"/>
-                                  </p:stCondLst>
-                                  <p:childTnLst>
-                                    <p:set>
-                                      <p:cBhvr>
-                                        <p:cTn id="6" dur="1" fill="hold">
-                                          <p:stCondLst>
-                                            <p:cond delay="0"/>
-                                          </p:stCondLst>
-                                        </p:cTn>
-                                        <p:tgtEl>
-                                          <p:spTgt spid="4"/>
-                                        </p:tgtEl>
-                                        <p:attrNameLst>
-                                          <p:attrName>style.visibility</p:attrName>
-                                        </p:attrNameLst>
-                                      </p:cBhvr>
-                                      <p:to>
-                                        <p:strVal val="visible"/>
-                                      </p:to>
-                                    </p:set>
-                                    <p:animEffect transition="in" filter="fade">
-                                      <p:cBhvr>
-                                        <p:cTn id="7" dur="500"/>
-                                        <p:tgtEl>
-                                          <p:spTgt spid="4"/>
-                                        </p:tgtEl>
-                                      </p:cBhvr>
-                                    </p:animEffect>
-                                  </p:childTnLst>
-                                </p:cTn>
-                              </p:par>
-                            </p:childTnLst>
-                          </p:cTn>
-                        </p:par>
-                      </p:childTnLst>
-                    </p:cTn>
-                  </p:par>
-                </p:childTnLst>
-              </p:cTn>
-              <p:prevCondLst>
-                <p:cond evt="onPrev" delay="0">
-                  <p:tgtEl>
-                    <p:sldTgt/>
-                  </p:tgtEl>
-                </p:cond>
-              </p:prevCondLst>
-              <p:nextCondLst>
-                <p:cond evt="onNext" delay="0">
-                  <p:tgtEl>
-                    <p:sldTgt/>
-                  </p:tgtEl>
-                </p:cond>
-              </p:nextCondLst>
-            </p:seq>
-          </p:childTnLst>
-        </p:cTn>
-      </p:par>
-    </p:tnLst>
-    <p:bldLst>
-      <p:bldP spid="4" grpId="0" animBg="1"/>
-    </p:bldLst>
-  </p:timing>
 </p:sld>
 </file>
 
@@ -14248,6 +16030,372 @@
           <a:p>
             <a:r>
               <a:rPr sz="4000"/>
+              <a:t>Vous les retrouverez au module FX</a:t>
+            </a:r>
+          </a:p>
+        </p:txBody>
+      </p:sp>
+      <p:sp>
+        <p:nvSpPr>
+          <p:cNvPr id="3" name="Content Placeholder 2"/>
+          <p:cNvSpPr>
+            <a:spLocks noGrp="1"/>
+          </p:cNvSpPr>
+          <p:nvPr>
+            <p:ph idx="1"/>
+          </p:nvPr>
+        </p:nvSpPr>
+        <p:spPr>
+          <a:xfrm>
+            <a:off x="640080" y="1371600"/>
+            <a:ext cx="10881360" cy="2225040"/>
+          </a:xfrm>
+        </p:spPr>
+        <p:txBody>
+          <a:bodyPr/>
+          <a:lstStyle/>
+          <a:p>
+            <a:pPr marL="0" indent="0">
+              <a:spcAft>
+                <a:spcPts val="1000"/>
+              </a:spcAft>
+              <a:buNone/>
+            </a:pPr>
+            <a:r>
+              <a:rPr sz="2800"/>
+              <a:t>Un bouton reçoit le comportement à déclencher au clic</a:t>
+            </a:r>
+          </a:p>
+          <a:p>
+            <a:pPr marL="0" indent="0">
+              <a:spcAft>
+                <a:spcPts val="1000"/>
+              </a:spcAft>
+              <a:buNone/>
+            </a:pPr>
+            <a:r>
+              <a:rPr sz="2800"/>
+              <a:t>Le type cible est </a:t>
+            </a:r>
+            <a:r>
+              <a:rPr sz="2400">
+                <a:solidFill>
+                  <a:schemeClr val="accent4"/>
+                </a:solidFill>
+                <a:latin typeface="Consolas"/>
+              </a:rPr>
+              <a:t>EventHandler</a:t>
+            </a:r>
+            <a:r>
+              <a:rPr sz="2800"/>
+              <a:t>, une interface fonctionnelle</a:t>
+            </a:r>
+          </a:p>
+          <a:p>
+            <a:pPr marL="0" indent="0">
+              <a:spcAft>
+                <a:spcPts val="1000"/>
+              </a:spcAft>
+              <a:buNone/>
+            </a:pPr>
+            <a:r>
+              <a:rPr sz="2800"/>
+              <a:t>Le module FX dira le reste</a:t>
+            </a:r>
+          </a:p>
+        </p:txBody>
+      </p:sp>
+      <p:sp>
+        <p:nvSpPr>
+          <p:cNvPr id="4" name="Code"/>
+          <p:cNvSpPr txBox="1"/>
+          <p:nvPr/>
+        </p:nvSpPr>
+        <p:spPr>
+          <a:xfrm>
+            <a:off x="2520950" y="3733799"/>
+            <a:ext cx="7150100" cy="548640"/>
+          </a:xfrm>
+          <a:prstGeom prst="roundRect">
+            <a:avLst>
+              <a:gd name="adj" fmla="val 16666"/>
+            </a:avLst>
+          </a:prstGeom>
+          <a:solidFill>
+            <a:srgbClr val="1D1F22"/>
+          </a:solidFill>
+          <a:effectLst>
+            <a:outerShdw blurRad="50800" dist="38100" dir="2700000" algn="tl" rotWithShape="0">
+              <a:prstClr val="black">
+                <a:alpha val="40000"/>
+              </a:prstClr>
+            </a:outerShdw>
+          </a:effectLst>
+        </p:spPr>
+        <p:txBody>
+          <a:bodyPr wrap="none" lIns="137160" tIns="91440" rIns="137160" bIns="91440"/>
+          <a:lstStyle/>
+          <a:p>
+            <a:pPr>
+              <a:lnSpc>
+                <a:spcPct val="100000"/>
+              </a:lnSpc>
+              <a:spcBef>
+                <a:spcPts val="0"/>
+              </a:spcBef>
+              <a:spcAft>
+                <a:spcPts val="0"/>
+              </a:spcAft>
+            </a:pPr>
+            <a:r>
+              <a:rPr sz="1800">
+                <a:solidFill>
+                  <a:srgbClr val="BCBEC4"/>
+                </a:solidFill>
+                <a:latin typeface="Consolas"/>
+              </a:rPr>
+              <a:t>bouton.</a:t>
+            </a:r>
+            <a:r>
+              <a:rPr sz="1800">
+                <a:solidFill>
+                  <a:srgbClr val="56A8F5"/>
+                </a:solidFill>
+                <a:latin typeface="Consolas"/>
+              </a:rPr>
+              <a:t>setOnAction</a:t>
+            </a:r>
+            <a:r>
+              <a:rPr sz="1800">
+                <a:solidFill>
+                  <a:srgbClr val="BCBEC4"/>
+                </a:solidFill>
+                <a:latin typeface="Consolas"/>
+              </a:rPr>
+              <a:t>(evenement -&gt; </a:t>
+            </a:r>
+            <a:r>
+              <a:rPr sz="1800">
+                <a:solidFill>
+                  <a:srgbClr val="56A8F5"/>
+                </a:solidFill>
+                <a:latin typeface="Consolas"/>
+              </a:rPr>
+              <a:t>afficherTotal</a:t>
+            </a:r>
+            <a:r>
+              <a:rPr sz="1800">
+                <a:solidFill>
+                  <a:srgbClr val="BCBEC4"/>
+                </a:solidFill>
+                <a:latin typeface="Consolas"/>
+              </a:rPr>
+              <a:t>());</a:t>
+            </a:r>
+          </a:p>
+        </p:txBody>
+      </p:sp>
+      <p:sp>
+        <p:nvSpPr>
+          <p:cNvPr id="6" name="Espace réservé du numéro de diapositive 2">
+            <a:extLst>
+              <a:ext uri="{FF2B5EF4-FFF2-40B4-BE49-F238E27FC236}">
+                <a16:creationId xmlns:a16="http://schemas.microsoft.com/office/drawing/2014/main" id="{ECBEBDD9-D9CC-2B70-9E8C-523CC2893F62}"/>
+              </a:ext>
+            </a:extLst>
+          </p:cNvPr>
+          <p:cNvSpPr>
+            <a:spLocks noGrp="1"/>
+          </p:cNvSpPr>
+          <p:nvPr>
+            <p:ph type="sldNum" sz="quarter" idx="4"/>
+          </p:nvPr>
+        </p:nvSpPr>
+        <p:spPr/>
+        <p:txBody>
+          <a:bodyPr/>
+          <a:lstStyle/>
+          <a:p>
+            <a:fld id="{33C783E2-4793-4F48-A271-51A73CC37D74}" type="slidenum">
+              <a:rPr lang="fr-FR" smtClean="0"/>
+              <a:t>19</a:t>
+            </a:fld>
+            <a:endParaRPr lang="fr-FR"/>
+          </a:p>
+        </p:txBody>
+      </p:sp>
+      <p:sp>
+        <p:nvSpPr>
+          <p:cNvPr id="5" name="Repere de section"/>
+          <p:cNvSpPr txBox="1"/>
+          <p:nvPr/>
+        </p:nvSpPr>
+        <p:spPr>
+          <a:xfrm>
+            <a:off x="6583680" y="6382512"/>
+            <a:ext cx="4480560" cy="320040"/>
+          </a:xfrm>
+          <a:prstGeom prst="rect">
+            <a:avLst/>
+          </a:prstGeom>
+          <a:noFill/>
+        </p:spPr>
+        <p:txBody>
+          <a:bodyPr wrap="none" tIns="0" bIns="0">
+            <a:spAutoFit/>
+          </a:bodyPr>
+          <a:lstStyle/>
+          <a:p>
+            <a:pPr algn="r"/>
+            <a:r>
+              <a:rPr sz="1100">
+                <a:solidFill>
+                  <a:srgbClr val="BCBEC4"/>
+                </a:solidFill>
+              </a:rPr>
+              <a:t>LAM · </a:t>
+            </a:r>
+            <a:r>
+              <a:rPr sz="1100" b="1">
+                <a:solidFill>
+                  <a:schemeClr val="accent4"/>
+                </a:solidFill>
+              </a:rPr>
+              <a:t>3. JDK et références</a:t>
+            </a:r>
+          </a:p>
+        </p:txBody>
+      </p:sp>
+    </p:spTree>
+  </p:cSld>
+  <p:clrMapOvr>
+    <a:masterClrMapping/>
+  </p:clrMapOvr>
+  <p:timing>
+    <p:tnLst>
+      <p:par>
+        <p:cTn id="1" dur="indefinite" restart="never" nodeType="tmRoot">
+          <p:childTnLst>
+            <p:seq concurrent="1" nextAc="seek">
+              <p:cTn id="2" dur="indefinite" nodeType="mainSeq">
+                <p:childTnLst>
+                  <p:par>
+                    <p:cTn id="3" fill="hold">
+                      <p:stCondLst>
+                        <p:cond delay="indefinite"/>
+                      </p:stCondLst>
+                      <p:childTnLst>
+                        <p:par>
+                          <p:cTn id="4" fill="hold">
+                            <p:stCondLst>
+                              <p:cond delay="0"/>
+                            </p:stCondLst>
+                            <p:childTnLst>
+                              <p:par>
+                                <p:cTn id="5" presetID="10" presetClass="entr" presetSubtype="0" fill="hold" grpId="0" nodeType="clickEffect">
+                                  <p:stCondLst>
+                                    <p:cond delay="0"/>
+                                  </p:stCondLst>
+                                  <p:childTnLst>
+                                    <p:set>
+                                      <p:cBhvr>
+                                        <p:cTn id="6" dur="1" fill="hold">
+                                          <p:stCondLst>
+                                            <p:cond delay="0"/>
+                                          </p:stCondLst>
+                                        </p:cTn>
+                                        <p:tgtEl>
+                                          <p:spTgt spid="4"/>
+                                        </p:tgtEl>
+                                        <p:attrNameLst>
+                                          <p:attrName>style.visibility</p:attrName>
+                                        </p:attrNameLst>
+                                      </p:cBhvr>
+                                      <p:to>
+                                        <p:strVal val="visible"/>
+                                      </p:to>
+                                    </p:set>
+                                    <p:animEffect transition="in" filter="fade">
+                                      <p:cBhvr>
+                                        <p:cTn id="7" dur="500"/>
+                                        <p:tgtEl>
+                                          <p:spTgt spid="4"/>
+                                        </p:tgtEl>
+                                      </p:cBhvr>
+                                    </p:animEffect>
+                                  </p:childTnLst>
+                                </p:cTn>
+                              </p:par>
+                            </p:childTnLst>
+                          </p:cTn>
+                        </p:par>
+                      </p:childTnLst>
+                    </p:cTn>
+                  </p:par>
+                </p:childTnLst>
+              </p:cTn>
+              <p:prevCondLst>
+                <p:cond evt="onPrev" delay="0">
+                  <p:tgtEl>
+                    <p:sldTgt/>
+                  </p:tgtEl>
+                </p:cond>
+              </p:prevCondLst>
+              <p:nextCondLst>
+                <p:cond evt="onNext" delay="0">
+                  <p:tgtEl>
+                    <p:sldTgt/>
+                  </p:tgtEl>
+                </p:cond>
+              </p:nextCondLst>
+            </p:seq>
+          </p:childTnLst>
+        </p:cTn>
+      </p:par>
+    </p:tnLst>
+    <p:bldLst>
+      <p:bldP spid="4" grpId="0" animBg="1"/>
+    </p:bldLst>
+  </p:timing>
+</p:sld>
+</file>
+
+<file path=ppt/slides/slide21.xml><?xml version="1.0" encoding="utf-8"?>
+<p:sld xmlns:a="http://schemas.openxmlformats.org/drawingml/2006/main" xmlns:r="http://schemas.openxmlformats.org/officeDocument/2006/relationships" xmlns:p="http://schemas.openxmlformats.org/presentationml/2006/main">
+  <p:cSld>
+    <p:spTree>
+      <p:nvGrpSpPr>
+        <p:cNvPr id="1" name=""/>
+        <p:cNvGrpSpPr/>
+        <p:nvPr/>
+      </p:nvGrpSpPr>
+      <p:grpSpPr>
+        <a:xfrm>
+          <a:off x="0" y="0"/>
+          <a:ext cx="0" cy="0"/>
+          <a:chOff x="0" y="0"/>
+          <a:chExt cx="0" cy="0"/>
+        </a:xfrm>
+      </p:grpSpPr>
+      <p:sp>
+        <p:nvSpPr>
+          <p:cNvPr id="2" name="Title 1"/>
+          <p:cNvSpPr>
+            <a:spLocks noGrp="1"/>
+          </p:cNvSpPr>
+          <p:nvPr>
+            <p:ph type="title"/>
+          </p:nvPr>
+        </p:nvSpPr>
+        <p:spPr/>
+        <p:txBody>
+          <a:bodyPr>
+            <a:noAutofit/>
+          </a:bodyPr>
+          <a:lstStyle/>
+          <a:p>
+            <a:r>
+              <a:rPr sz="4000"/>
               <a:t>Le fil rouge</a:t>
             </a:r>
           </a:p>
@@ -17242,7 +19390,7 @@
             </a:pPr>
             <a:r>
               <a:rPr lang="nl-BE" sz="2800" dirty="0"/>
-              <a:t>Il y a une écriture encore plus courte que la classe anonyme: </a:t>
+              <a:t>Il y a une écriture encore plus courte que la classe anonyme : </a:t>
             </a:r>
             <a:r>
               <a:rPr lang="nl-BE" dirty="0"/>

</xml_diff>

<commit_message>
Remaniement initial du deck FX1_slides
</commit_message>
<xml_diff>
--- a/_slides/remanies/13. LAM_slides.pptx
+++ b/_slides/remanies/13. LAM_slides.pptx
@@ -5,10 +5,10 @@
     <p:sldMasterId id="2147483660" r:id="rId1"/>
   </p:sldMasterIdLst>
   <p:notesMasterIdLst>
-    <p:notesMasterId r:id="rId22"/>
+    <p:notesMasterId r:id="rId23"/>
   </p:notesMasterIdLst>
   <p:handoutMasterIdLst>
-    <p:handoutMasterId r:id="rId23"/>
+    <p:handoutMasterId r:id="rId24"/>
   </p:handoutMasterIdLst>
   <p:sldIdLst>
     <p:sldId id="568" r:id="rId2"/>
@@ -27,11 +27,11 @@
     <p:sldId id="579" r:id="rId15"/>
     <p:sldId id="580" r:id="rId16"/>
     <p:sldId id="581" r:id="rId17"/>
-    <p:sldId id="588" r:id="rId28"/>
-    <p:sldId id="589" r:id="rId29"/>
-    <p:sldId id="583" r:id="rId19"/>
-    <p:sldId id="584" r:id="rId20"/>
-    <p:sldId id="585" r:id="rId21"/>
+    <p:sldId id="588" r:id="rId18"/>
+    <p:sldId id="589" r:id="rId19"/>
+    <p:sldId id="583" r:id="rId20"/>
+    <p:sldId id="584" r:id="rId21"/>
+    <p:sldId id="585" r:id="rId22"/>
   </p:sldIdLst>
   <p:sldSz cx="12192000" cy="6858000"/>
   <p:notesSz cx="6858000" cy="9144000"/>
@@ -163,7 +163,8 @@
             <p14:sldId id="579"/>
             <p14:sldId id="580"/>
             <p14:sldId id="581"/>
-            <p14:sldId id="582"/>
+            <p14:sldId id="588"/>
+            <p14:sldId id="589"/>
             <p14:sldId id="583"/>
             <p14:sldId id="584"/>
             <p14:sldId id="585"/>
@@ -1737,6 +1738,110 @@
 </p:notes>
 </file>
 
+<file path=ppt/notesSlides/notesSlide17.xml><?xml version="1.0" encoding="utf-8"?>
+<p:notes xmlns:a="http://schemas.openxmlformats.org/drawingml/2006/main" xmlns:r="http://schemas.openxmlformats.org/officeDocument/2006/relationships" xmlns:p="http://schemas.openxmlformats.org/presentationml/2006/main">
+  <p:cSld>
+    <p:spTree>
+      <p:nvGrpSpPr>
+        <p:cNvPr id="1" name=""/>
+        <p:cNvGrpSpPr/>
+        <p:nvPr/>
+      </p:nvGrpSpPr>
+      <p:grpSpPr>
+        <a:xfrm>
+          <a:off x="0" y="0"/>
+          <a:ext cx="0" cy="0"/>
+          <a:chOff x="0" y="0"/>
+          <a:chExt cx="0" cy="0"/>
+        </a:xfrm>
+      </p:grpSpPr>
+      <p:sp>
+        <p:nvSpPr>
+          <p:cNvPr id="2" name="Slide Image Placeholder 1"/>
+          <p:cNvSpPr>
+            <a:spLocks noGrp="1" noRot="1" noChangeAspect="1"/>
+          </p:cNvSpPr>
+          <p:nvPr>
+            <p:ph type="sldImg" idx="2"/>
+          </p:nvPr>
+        </p:nvSpPr>
+        <p:spPr/>
+      </p:sp>
+      <p:sp>
+        <p:nvSpPr>
+          <p:cNvPr id="3" name="Notes Placeholder 2"/>
+          <p:cNvSpPr>
+            <a:spLocks noGrp="1"/>
+          </p:cNvSpPr>
+          <p:nvPr>
+            <p:ph type="body" sz="quarter" idx="3"/>
+          </p:nvPr>
+        </p:nvSpPr>
+        <p:spPr/>
+        <p:txBody>
+          <a:bodyPr/>
+          <a:lstStyle/>
+          <a:p>
+            <a:r>
+              <a:t>Slide facultative, que l'on peut sauter en classe. Elle montre où mènent les lambdas quand on les enchaîne.</a:t>
+            </a:r>
+          </a:p>
+          <a:p>
+            <a:r>
+              <a:t>Un stream n'est pas une collection : c'est un passage. Les éléments de la liste y entrent l'un après l'autre et traversent des étapes, chacune décrite par une lambda. Le code se lit de haut en bas, comme une recette.</a:t>
+            </a:r>
+          </a:p>
+          <a:p>
+            <a:r>
+              <a:t>Première étape, stream ouvre le flux sur les titres de la liste. Deuxième, filter reçoit un Predicate, le même genre d'objet que removeIf, et ne laisse passer que les titres qu'il accepte : ici, les titres longs. Troisième, map reçoit une Function et transforme chaque titre qui passe : ici, en majuscules. Le nombre d'éléments ne change pas, seule leur forme change. Dernière étape, collect rassemble ce qui sort du flux en un résultat ; Collectors.joining en fait une seule chaîne, avec le séparateur donné.</a:t>
+            </a:r>
+          </a:p>
+          <a:p>
+            <a:r>
+              <a:t>La différence avec removeIf est essentielle : removeIf retire des éléments de la liste elle-même, alors que le stream laisse titres intacte et produit un résultat neuf, ici une String. La slide suivante suit quatre titres à travers les étapes.</a:t>
+            </a:r>
+          </a:p>
+          <a:p>
+            <a:r>
+              <a:t>Pour un tableau d'entiers, Arrays.stream(tableau) ouvre le même enchaînement. Comme les éléments sont des int, mapToObj les transforme alors en objets, par exemple en chaînes avec String::valueOf, avant de les joindre. C'est de quoi répondre à la dernière question de LAM.3.</a:t>
+            </a:r>
+          </a:p>
+          <a:p>
+            <a:r>
+              <a:t>Le code complet, à exécuter : demos, classe </a:t>
+            </a:r>
+            <a:r>
+              <a:rPr>
+                <a:latin typeface="Consolas"/>
+              </a:rPr>
+              <a:t>demo.lam.slides.LesMethodesDeCOLSansClasse</a:t>
+            </a:r>
+            <a:r>
+              <a:t>.</a:t>
+            </a:r>
+          </a:p>
+        </p:txBody>
+      </p:sp>
+      <p:sp>
+        <p:nvSpPr>
+          <p:cNvPr id="4" name="Slide Number Placeholder 3"/>
+          <p:cNvSpPr>
+            <a:spLocks noGrp="1"/>
+          </p:cNvSpPr>
+          <p:nvPr>
+            <p:ph type="sldNum" sz="quarter" idx="5"/>
+          </p:nvPr>
+        </p:nvSpPr>
+        <p:spPr/>
+      </p:sp>
+    </p:spTree>
+  </p:cSld>
+  <p:clrMapOvr>
+    <a:masterClrMapping/>
+  </p:clrMapOvr>
+</p:notes>
+</file>
+
 <file path=ppt/notesSlides/notesSlide18.xml><?xml version="1.0" encoding="utf-8"?>
 <p:notes xmlns:a="http://schemas.openxmlformats.org/drawingml/2006/main" xmlns:r="http://schemas.openxmlformats.org/officeDocument/2006/relationships" xmlns:p="http://schemas.openxmlformats.org/presentationml/2006/main">
   <p:cSld>
@@ -1782,41 +1887,17 @@
           <a:lstStyle/>
           <a:p>
             <a:r>
-              <a:rPr>
-                <a:latin typeface="Consolas"/>
-              </a:rPr>
-              <a:t>LAM.3</a:t>
-            </a:r>
-            <a:r>
-              <a:t> répond à la question gardée depuis </a:t>
-            </a:r>
-            <a:r>
-              <a:rPr>
-                <a:latin typeface="Consolas"/>
-              </a:rPr>
-              <a:t>LAM.2</a:t>
-            </a:r>
-            <a:r>
-              <a:t> : votre interface </a:t>
-            </a:r>
-            <a:r>
-              <a:rPr>
-                <a:latin typeface="Consolas"/>
-              </a:rPr>
-              <a:t>Filtrage</a:t>
-            </a:r>
-            <a:r>
-              <a:t> avait déjà son équivalent dans le JDK. Remplacez-la, et constatez que rien d'autre ne change.</a:t>
-            </a:r>
-          </a:p>
-          <a:p>
-            <a:r>
-              <a:t>La seconde partie fait le dernier dépouillement de la slide 3.4 : trois critères écrits comme des méthodes statiques, chacune sur une ligne, puis passés par référence. Le test vérifie chaque critère seul avant le rapport. C'est ce que le nom permet, et que la lambda ne permet pas.</a:t>
-            </a:r>
-          </a:p>
-          <a:p>
-            <a:r>
-              <a:t>Les questions de fin ouvrent sur ce que le deck n'a pas montré : les autres formes de référence de méthode. Cherchez-les.</a:t>
+              <a:t>Les lignes apparaissent l'une après l'autre : faites deviner ce qui sort de chaque étape avant de cliquer.</a:t>
+            </a:r>
+          </a:p>
+          <a:p>
+            <a:r>
+              <a:t>Le flux part des quatre titres. filter ne laisse passer que ceux qui dépassent huit caractères : Nana et Germinal, qui en ont quatre et huit, s'arrêtent là. La limite est abaissée à 8 pour l'exemple : avec 20, il faudrait des titres trop longs pour tenir dans le tableau. map met chacun des deux survivants en majuscules : ils sont toujours deux, mais changés. collect, enfin, n'est plus une suite d'éléments : il les assemble en une seule String, séparés par une virgule et une espace.</a:t>
+            </a:r>
+          </a:p>
+          <a:p>
+            <a:r>
+              <a:t>Pendant tout ce trajet, la liste titres n'a pas bougé : elle contient toujours ses quatre titres, dans le même ordre. C'est la différence avec removeIf.</a:t>
             </a:r>
           </a:p>
         </p:txBody>
@@ -1886,35 +1967,41 @@
           <a:lstStyle/>
           <a:p>
             <a:r>
-              <a:t>Le module ITF citait </a:t>
-            </a:r>
-            <a:r>
               <a:rPr>
                 <a:latin typeface="Consolas"/>
               </a:rPr>
-              <a:t>EventHandler</a:t>
-            </a:r>
-            <a:r>
-              <a:t> parmi les interfaces fonctionnelles du JDK. Vous le retrouverez à chaque bouton du module FX : sa méthode </a:t>
+              <a:t>LAM.3</a:t>
+            </a:r>
+            <a:r>
+              <a:t> répond à la question gardée depuis </a:t>
             </a:r>
             <a:r>
               <a:rPr>
                 <a:latin typeface="Consolas"/>
               </a:rPr>
-              <a:t>handle</a:t>
-            </a:r>
-            <a:r>
-              <a:t> reçoit l'événement, et la lambda dit quoi faire quand il survient.</a:t>
-            </a:r>
-          </a:p>
-          <a:p>
-            <a:r>
-              <a:t>Sans lambda, chaque bouton demanderait une classe, anonyme ou non. Avec elle, l'interface graphique se lit ligne par ligne : tel bouton, tel effet. C'est ce qui rend le code JavaFX lisible, et c'est à l'examen que vous en aurez besoin : la question JavaFX demande d'écrire ces gestionnaires.</a:t>
-            </a:r>
-          </a:p>
-          <a:p>
-            <a:r>
-              <a:t>Une lambda est une valeur : un gestionnaire peut aussi se ranger dans un champ, pour être ajouté puis retiré plus tard. Le module FX le montrera.</a:t>
+              <a:t>LAM.2</a:t>
+            </a:r>
+            <a:r>
+              <a:t> : votre interface </a:t>
+            </a:r>
+            <a:r>
+              <a:rPr>
+                <a:latin typeface="Consolas"/>
+              </a:rPr>
+              <a:t>Filtrage</a:t>
+            </a:r>
+            <a:r>
+              <a:t> avait déjà son équivalent dans le JDK. Remplacez-la, et constatez que rien d'autre ne change.</a:t>
+            </a:r>
+          </a:p>
+          <a:p>
+            <a:r>
+              <a:t>La seconde partie fait le dernier dépouillement de la slide 3.4 : trois critères écrits comme des méthodes statiques, chacune sur une ligne, puis passés par référence. Le test vérifie chaque critère seul avant le rapport. C'est ce que le nom permet, et que la lambda ne permet pas.</a:t>
+            </a:r>
+          </a:p>
+          <a:p>
+            <a:r>
+              <a:t>Les questions de fin ouvrent sur ce que le deck n'a pas montré : les autres formes de référence de méthode. Cherchez-les.</a:t>
             </a:r>
           </a:p>
         </p:txBody>
@@ -2059,95 +2146,35 @@
           <a:lstStyle/>
           <a:p>
             <a:r>
+              <a:t>Le module ITF citait </a:t>
+            </a:r>
+            <a:r>
               <a:rPr>
                 <a:latin typeface="Consolas"/>
               </a:rPr>
-              <a:t>G.32</a:t>
-            </a:r>
-            <a:r>
-              <a:t> reprend la fabrique de </a:t>
+              <a:t>EventHandler</a:t>
+            </a:r>
+            <a:r>
+              <a:t> parmi les interfaces fonctionnelles du JDK. Vous le retrouverez à chaque bouton du module FX : sa méthode </a:t>
             </a:r>
             <a:r>
               <a:rPr>
                 <a:latin typeface="Consolas"/>
               </a:rPr>
-              <a:t>G.15</a:t>
-            </a:r>
-            <a:r>
-              <a:t>. Son </a:t>
-            </a:r>
-            <a:r>
-              <a:rPr>
-                <a:latin typeface="Consolas"/>
-              </a:rPr>
-              <a:t>switch</a:t>
-            </a:r>
-            <a:r>
-              <a:t> associe chaque type de jeu à la façon d'en créer un. L'incrément range ces associations dans une </a:t>
-            </a:r>
-            <a:r>
-              <a:rPr>
-                <a:latin typeface="Consolas"/>
-              </a:rPr>
-              <a:t>Map</a:t>
-            </a:r>
-            <a:r>
-              <a:t>, dont chaque valeur est un </a:t>
-            </a:r>
-            <a:r>
-              <a:rPr>
-                <a:latin typeface="Consolas"/>
-              </a:rPr>
-              <a:t>Supplier&lt;Jeu&gt;</a:t>
-            </a:r>
-            <a:r>
-              <a:t> : une lambda qui, à chaque appel, fabrique un jeu neuf. Ajouter un jeu revient alors à ajouter une ligne au catalogue.</a:t>
-            </a:r>
-          </a:p>
-          <a:p>
-            <a:r>
-              <a:t>L'incrément pose la question qui compte : pourquoi ranger la façon de fabriquer un jeu, et pas le jeu lui-même ? Répondez-y avant d'écrire la moindre ligne.</a:t>
-            </a:r>
-          </a:p>
-          <a:p>
-            <a:r>
-              <a:t>Relisez aussi </a:t>
-            </a:r>
-            <a:r>
-              <a:rPr>
-                <a:latin typeface="Consolas"/>
-              </a:rPr>
-              <a:t>G.17</a:t>
-            </a:r>
-            <a:r>
-              <a:t>. Sa question vous demandait quel nom porte une interface à une seule méthode, et ce que vous pourriez en faire au thème LAM. La réponse est sous vos yeux : </a:t>
-            </a:r>
-            <a:r>
-              <a:rPr>
-                <a:latin typeface="Consolas"/>
-              </a:rPr>
-              <a:t>StrategieNim</a:t>
-            </a:r>
-            <a:r>
-              <a:t> est fonctionnelle, et </a:t>
-            </a:r>
-            <a:r>
-              <a:rPr>
-                <a:latin typeface="Consolas"/>
-              </a:rPr>
-              <a:t>StrategieTimide</a:t>
-            </a:r>
-            <a:r>
-              <a:t> tiendrait en une lambda, </a:t>
-            </a:r>
-            <a:r>
-              <a:rPr>
-                <a:latin typeface="Consolas"/>
-              </a:rPr>
-              <a:t>(pile, regles) -&gt; 1</a:t>
-            </a:r>
-            <a:r>
-              <a:t>.</a:t>
+              <a:t>handle</a:t>
+            </a:r>
+            <a:r>
+              <a:t> reçoit l'événement, et la lambda dit quoi faire quand il survient.</a:t>
+            </a:r>
+          </a:p>
+          <a:p>
+            <a:r>
+              <a:t>Sans lambda, chaque bouton demanderait une classe, anonyme ou non. Avec elle, l'interface graphique se lit ligne par ligne : tel bouton, tel effet. C'est ce qui rend le code JavaFX lisible, et c'est à l'examen que vous en aurez besoin : la question JavaFX demande d'écrire ces gestionnaires.</a:t>
+            </a:r>
+          </a:p>
+          <a:p>
+            <a:r>
+              <a:t>Une lambda est une valeur : un gestionnaire peut aussi se ranger dans un champ, pour être ajouté puis retiré plus tard. Le module FX le montrera.</a:t>
             </a:r>
           </a:p>
         </p:txBody>
@@ -2173,7 +2200,7 @@
 </file>
 
 <file path=ppt/notesSlides/notesSlide21.xml><?xml version="1.0" encoding="utf-8"?>
-<p:notes xmlns:a="http://schemas.openxmlformats.org/drawingml/2006/main" xmlns:p="http://schemas.openxmlformats.org/presentationml/2006/main" xmlns:r="http://schemas.openxmlformats.org/officeDocument/2006/relationships">
+<p:notes xmlns:a="http://schemas.openxmlformats.org/drawingml/2006/main" xmlns:r="http://schemas.openxmlformats.org/officeDocument/2006/relationships" xmlns:p="http://schemas.openxmlformats.org/presentationml/2006/main">
   <p:cSld>
     <p:spTree>
       <p:nvGrpSpPr>
@@ -2193,7 +2220,7 @@
         <p:nvSpPr>
           <p:cNvPr id="2" name="Slide Image Placeholder 1"/>
           <p:cNvSpPr>
-            <a:spLocks noGrp="1"/>
+            <a:spLocks noGrp="1" noRot="1" noChangeAspect="1"/>
           </p:cNvSpPr>
           <p:nvPr>
             <p:ph type="sldImg" idx="2"/>
@@ -2208,7 +2235,7 @@
             <a:spLocks noGrp="1"/>
           </p:cNvSpPr>
           <p:nvPr>
-            <p:ph type="body" idx="3" sz="quarter"/>
+            <p:ph type="body" sz="quarter" idx="3"/>
           </p:nvPr>
         </p:nvSpPr>
         <p:spPr/>
@@ -2217,38 +2244,92 @@
           <a:lstStyle/>
           <a:p>
             <a:r>
-              <a:t>Slide facultative, que l'on peut sauter en classe. Elle montre où mènent les lambdas quand on les enchaîne.</a:t>
-            </a:r>
-          </a:p>
-          <a:p>
-            <a:r>
-              <a:t>Un stream n'est pas une collection : c'est un passage. Les éléments de la liste y entrent l'un après l'autre et traversent des étapes, chacune décrite par une lambda. Le code se lit de haut en bas, comme une recette.</a:t>
-            </a:r>
-          </a:p>
-          <a:p>
-            <a:r>
-              <a:t>Première étape, stream ouvre le flux sur les titres de la liste. Deuxième, filter reçoit un Predicate, le même genre d'objet que removeIf, et ne laisse passer que les titres qu'il accepte : ici, les titres longs. Troisième, map reçoit une Function et transforme chaque titre qui passe : ici, en majuscules. Le nombre d'éléments ne change pas, seule leur forme change. Dernière étape, collect rassemble ce qui sort du flux en un résultat ; Collectors.joining en fait une seule chaîne, avec le séparateur donné.</a:t>
-            </a:r>
-          </a:p>
-          <a:p>
-            <a:r>
-              <a:t>La différence avec removeIf est essentielle : removeIf retire des éléments de la liste elle-même, alors que le stream laisse titres intacte et produit un résultat neuf, ici une String. La slide suivante suit quatre titres à travers les étapes.</a:t>
-            </a:r>
-          </a:p>
-          <a:p>
-            <a:r>
-              <a:t>Pour un tableau d'entiers, Arrays.stream(tableau) ouvre le même enchaînement. Comme les éléments sont des int, mapToObj les transforme alors en objets, par exemple en chaînes avec String::valueOf, avant de les joindre. C'est de quoi répondre à la dernière question de LAM.3.</a:t>
-            </a:r>
-          </a:p>
-          <a:p>
-            <a:r>
-              <a:t>Le code complet, à exécuter : demos, classe </a:t>
-            </a:r>
-            <a:r>
               <a:rPr>
                 <a:latin typeface="Consolas"/>
               </a:rPr>
-              <a:t>demo.lam.slides.LesMethodesDeCOLSansClasse</a:t>
+              <a:t>G.32</a:t>
+            </a:r>
+            <a:r>
+              <a:t> reprend la fabrique de </a:t>
+            </a:r>
+            <a:r>
+              <a:rPr>
+                <a:latin typeface="Consolas"/>
+              </a:rPr>
+              <a:t>G.15</a:t>
+            </a:r>
+            <a:r>
+              <a:t>. Son </a:t>
+            </a:r>
+            <a:r>
+              <a:rPr>
+                <a:latin typeface="Consolas"/>
+              </a:rPr>
+              <a:t>switch</a:t>
+            </a:r>
+            <a:r>
+              <a:t> associe chaque type de jeu à la façon d'en créer un. L'incrément range ces associations dans une </a:t>
+            </a:r>
+            <a:r>
+              <a:rPr>
+                <a:latin typeface="Consolas"/>
+              </a:rPr>
+              <a:t>Map</a:t>
+            </a:r>
+            <a:r>
+              <a:t>, dont chaque valeur est un </a:t>
+            </a:r>
+            <a:r>
+              <a:rPr>
+                <a:latin typeface="Consolas"/>
+              </a:rPr>
+              <a:t>Supplier&lt;Jeu&gt;</a:t>
+            </a:r>
+            <a:r>
+              <a:t> : une lambda qui, à chaque appel, fabrique un jeu neuf. Ajouter un jeu revient alors à ajouter une ligne au catalogue.</a:t>
+            </a:r>
+          </a:p>
+          <a:p>
+            <a:r>
+              <a:t>L'incrément pose la question qui compte : pourquoi ranger la façon de fabriquer un jeu, et pas le jeu lui-même ? Répondez-y avant d'écrire la moindre ligne.</a:t>
+            </a:r>
+          </a:p>
+          <a:p>
+            <a:r>
+              <a:t>Relisez aussi </a:t>
+            </a:r>
+            <a:r>
+              <a:rPr>
+                <a:latin typeface="Consolas"/>
+              </a:rPr>
+              <a:t>G.17</a:t>
+            </a:r>
+            <a:r>
+              <a:t>. Sa question vous demandait quel nom porte une interface à une seule méthode, et ce que vous pourriez en faire au thème LAM. La réponse est sous vos yeux : </a:t>
+            </a:r>
+            <a:r>
+              <a:rPr>
+                <a:latin typeface="Consolas"/>
+              </a:rPr>
+              <a:t>StrategieNim</a:t>
+            </a:r>
+            <a:r>
+              <a:t> est fonctionnelle, et </a:t>
+            </a:r>
+            <a:r>
+              <a:rPr>
+                <a:latin typeface="Consolas"/>
+              </a:rPr>
+              <a:t>StrategieTimide</a:t>
+            </a:r>
+            <a:r>
+              <a:t> tiendrait en une lambda, </a:t>
+            </a:r>
+            <a:r>
+              <a:rPr>
+                <a:latin typeface="Consolas"/>
+              </a:rPr>
+              <a:t>(pile, regles) -&gt; 1</a:t>
             </a:r>
             <a:r>
               <a:t>.</a:t>
@@ -2263,87 +2344,7 @@
             <a:spLocks noGrp="1"/>
           </p:cNvSpPr>
           <p:nvPr>
-            <p:ph type="sldNum" idx="5" sz="quarter"/>
-          </p:nvPr>
-        </p:nvSpPr>
-        <p:spPr/>
-      </p:sp>
-    </p:spTree>
-  </p:cSld>
-  <p:clrMapOvr>
-    <a:masterClrMapping/>
-  </p:clrMapOvr>
-</p:notes>
-</file>
-
-<file path=ppt/notesSlides/notesSlide22.xml><?xml version="1.0" encoding="utf-8"?>
-<p:notes xmlns:a="http://schemas.openxmlformats.org/drawingml/2006/main" xmlns:p="http://schemas.openxmlformats.org/presentationml/2006/main" xmlns:r="http://schemas.openxmlformats.org/officeDocument/2006/relationships">
-  <p:cSld>
-    <p:spTree>
-      <p:nvGrpSpPr>
-        <p:cNvPr id="1" name=""/>
-        <p:cNvGrpSpPr/>
-        <p:nvPr/>
-      </p:nvGrpSpPr>
-      <p:grpSpPr>
-        <a:xfrm>
-          <a:off x="0" y="0"/>
-          <a:ext cx="0" cy="0"/>
-          <a:chOff x="0" y="0"/>
-          <a:chExt cx="0" cy="0"/>
-        </a:xfrm>
-      </p:grpSpPr>
-      <p:sp>
-        <p:nvSpPr>
-          <p:cNvPr id="2" name="Slide Image Placeholder 1"/>
-          <p:cNvSpPr>
-            <a:spLocks noGrp="1"/>
-          </p:cNvSpPr>
-          <p:nvPr>
-            <p:ph type="sldImg" idx="2"/>
-          </p:nvPr>
-        </p:nvSpPr>
-        <p:spPr/>
-      </p:sp>
-      <p:sp>
-        <p:nvSpPr>
-          <p:cNvPr id="3" name="Notes Placeholder 2"/>
-          <p:cNvSpPr>
-            <a:spLocks noGrp="1"/>
-          </p:cNvSpPr>
-          <p:nvPr>
-            <p:ph type="body" idx="3" sz="quarter"/>
-          </p:nvPr>
-        </p:nvSpPr>
-        <p:spPr/>
-        <p:txBody>
-          <a:bodyPr/>
-          <a:lstStyle/>
-          <a:p>
-            <a:r>
-              <a:t>Les lignes apparaissent l'une après l'autre : faites deviner ce qui sort de chaque étape avant de cliquer.</a:t>
-            </a:r>
-          </a:p>
-          <a:p>
-            <a:r>
-              <a:t>Le flux part des quatre titres. filter ne laisse passer que ceux qui dépassent huit caractères : Nana et Germinal, qui en ont quatre et huit, s'arrêtent là. La limite est abaissée à 8 pour l'exemple : avec 20, il faudrait des titres trop longs pour tenir dans le tableau. map met chacun des deux survivants en majuscules : ils sont toujours deux, mais changés. collect, enfin, n'est plus une suite d'éléments : il les assemble en une seule String, séparés par une virgule et une espace.</a:t>
-            </a:r>
-          </a:p>
-          <a:p>
-            <a:r>
-              <a:t>Pendant tout ce trajet, la liste titres n'a pas bougé : elle contient toujours ses quatre titres, dans le même ordre. C'est la différence avec removeIf.</a:t>
-            </a:r>
-          </a:p>
-        </p:txBody>
-      </p:sp>
-      <p:sp>
-        <p:nvSpPr>
-          <p:cNvPr id="4" name="Slide Number Placeholder 3"/>
-          <p:cNvSpPr>
-            <a:spLocks noGrp="1"/>
-          </p:cNvSpPr>
-          <p:nvPr>
-            <p:ph type="sldNum" idx="5" sz="quarter"/>
+            <p:ph type="sldNum" sz="quarter" idx="5"/>
           </p:nvPr>
         </p:nvSpPr>
         <p:spPr/>
@@ -6375,7 +6376,6 @@
           </a:p>
           <a:p>
             <a:r>
-              <a:rPr/>
               <a:t>Lambdas et références de méthodes</a:t>
             </a:r>
           </a:p>
@@ -12433,7 +12433,7 @@
 </file>
 
 <file path=ppt/slides/slide17.xml><?xml version="1.0" encoding="utf-8"?>
-<p:sld xmlns:a="http://schemas.openxmlformats.org/drawingml/2006/main" xmlns:p="http://schemas.openxmlformats.org/presentationml/2006/main" xmlns:r="http://schemas.openxmlformats.org/officeDocument/2006/relationships">
+<p:sld xmlns:a="http://schemas.openxmlformats.org/drawingml/2006/main" xmlns:r="http://schemas.openxmlformats.org/officeDocument/2006/relationships" xmlns:p="http://schemas.openxmlformats.org/presentationml/2006/main">
   <p:cSld>
     <p:spTree>
       <p:nvGrpSpPr>
@@ -12441,7 +12441,14 @@
         <p:cNvGrpSpPr/>
         <p:nvPr/>
       </p:nvGrpSpPr>
-      <p:grpSpPr/>
+      <p:grpSpPr>
+        <a:xfrm>
+          <a:off x="0" y="0"/>
+          <a:ext cx="0" cy="0"/>
+          <a:chOff x="0" y="0"/>
+          <a:chExt cx="0" cy="0"/>
+        </a:xfrm>
+      </p:grpSpPr>
       <p:sp>
         <p:nvSpPr>
           <p:cNvPr id="2" name="Title 1"/>
@@ -12586,7 +12593,7 @@
           </a:effectLst>
         </p:spPr>
         <p:txBody>
-          <a:bodyPr wrap="none" lIns="137160" rIns="137160" tIns="91440" bIns="91440"/>
+          <a:bodyPr wrap="none" lIns="137160" tIns="91440" rIns="137160" bIns="91440"/>
           <a:lstStyle/>
           <a:p>
             <a:pPr>
@@ -12607,16 +12614,16 @@
                 </a:solidFill>
                 <a:latin typeface="Consolas"/>
               </a:rPr>
-              <a:t>String</a:t>
+              <a:t>String longs = titres.</a:t>
             </a:r>
             <a:r>
               <a:rPr sz="1600">
                 <a:solidFill>
-                  <a:srgbClr val="BCBEC4"/>
-                </a:solidFill>
-                <a:latin typeface="Consolas"/>
-              </a:rPr>
-              <a:t> </a:t>
+                  <a:srgbClr val="56A8F5"/>
+                </a:solidFill>
+                <a:latin typeface="Consolas"/>
+              </a:rPr>
+              <a:t>stream</a:t>
             </a:r>
             <a:r>
               <a:rPr sz="1600">
@@ -12625,313 +12632,7 @@
                 </a:solidFill>
                 <a:latin typeface="Consolas"/>
               </a:rPr>
-              <a:t>longs</a:t>
-            </a:r>
-            <a:r>
-              <a:rPr sz="1600">
-                <a:solidFill>
-                  <a:srgbClr val="BCBEC4"/>
-                </a:solidFill>
-                <a:latin typeface="Consolas"/>
-              </a:rPr>
-              <a:t> </a:t>
-            </a:r>
-            <a:r>
-              <a:rPr sz="1600">
-                <a:solidFill>
-                  <a:srgbClr val="BCBEC4"/>
-                </a:solidFill>
-                <a:latin typeface="Consolas"/>
-              </a:rPr>
-              <a:t>=</a:t>
-            </a:r>
-            <a:r>
-              <a:rPr sz="1600">
-                <a:solidFill>
-                  <a:srgbClr val="BCBEC4"/>
-                </a:solidFill>
-                <a:latin typeface="Consolas"/>
-              </a:rPr>
-              <a:t> </a:t>
-            </a:r>
-            <a:r>
-              <a:rPr sz="1600">
-                <a:solidFill>
-                  <a:srgbClr val="BCBEC4"/>
-                </a:solidFill>
-                <a:latin typeface="Consolas"/>
-              </a:rPr>
-              <a:t>titres</a:t>
-            </a:r>
-            <a:r>
-              <a:rPr sz="1600">
-                <a:solidFill>
-                  <a:srgbClr val="BCBEC4"/>
-                </a:solidFill>
-                <a:latin typeface="Consolas"/>
-              </a:rPr>
-              <a:t>.</a:t>
-            </a:r>
-            <a:r>
-              <a:rPr sz="1600">
-                <a:solidFill>
-                  <a:srgbClr val="56A8F5"/>
-                </a:solidFill>
-                <a:latin typeface="Consolas"/>
-              </a:rPr>
-              <a:t>stream</a:t>
-            </a:r>
-            <a:r>
-              <a:rPr sz="1600">
-                <a:solidFill>
-                  <a:srgbClr val="BCBEC4"/>
-                </a:solidFill>
-                <a:latin typeface="Consolas"/>
-              </a:rPr>
-              <a:t>(</a:t>
-            </a:r>
-            <a:r>
-              <a:rPr sz="1600">
-                <a:solidFill>
-                  <a:srgbClr val="BCBEC4"/>
-                </a:solidFill>
-                <a:latin typeface="Consolas"/>
-              </a:rPr>
-              <a:t>)</a:t>
-            </a:r>
-            <a:r>
-              <a:rPr sz="1600">
-                <a:solidFill>
-                  <a:srgbClr val="BCBEC4"/>
-                </a:solidFill>
-                <a:latin typeface="Consolas"/>
-              </a:rPr>
-              <a:t> </a:t>
-            </a:r>
-            <a:r>
-              <a:rPr sz="1600">
-                <a:solidFill>
-                  <a:srgbClr val="BCBEC4"/>
-                </a:solidFill>
-                <a:latin typeface="Consolas"/>
-              </a:rPr>
-              <a:t> </a:t>
-            </a:r>
-            <a:r>
-              <a:rPr sz="1600">
-                <a:solidFill>
-                  <a:srgbClr val="BCBEC4"/>
-                </a:solidFill>
-                <a:latin typeface="Consolas"/>
-              </a:rPr>
-              <a:t> </a:t>
-            </a:r>
-            <a:r>
-              <a:rPr sz="1600">
-                <a:solidFill>
-                  <a:srgbClr val="BCBEC4"/>
-                </a:solidFill>
-                <a:latin typeface="Consolas"/>
-              </a:rPr>
-              <a:t> </a:t>
-            </a:r>
-            <a:r>
-              <a:rPr sz="1600">
-                <a:solidFill>
-                  <a:srgbClr val="BCBEC4"/>
-                </a:solidFill>
-                <a:latin typeface="Consolas"/>
-              </a:rPr>
-              <a:t> </a:t>
-            </a:r>
-            <a:r>
-              <a:rPr sz="1600">
-                <a:solidFill>
-                  <a:srgbClr val="BCBEC4"/>
-                </a:solidFill>
-                <a:latin typeface="Consolas"/>
-              </a:rPr>
-              <a:t> </a:t>
-            </a:r>
-            <a:r>
-              <a:rPr sz="1600">
-                <a:solidFill>
-                  <a:srgbClr val="BCBEC4"/>
-                </a:solidFill>
-                <a:latin typeface="Consolas"/>
-              </a:rPr>
-              <a:t> </a:t>
-            </a:r>
-            <a:r>
-              <a:rPr sz="1600">
-                <a:solidFill>
-                  <a:srgbClr val="BCBEC4"/>
-                </a:solidFill>
-                <a:latin typeface="Consolas"/>
-              </a:rPr>
-              <a:t> </a:t>
-            </a:r>
-            <a:r>
-              <a:rPr sz="1600">
-                <a:solidFill>
-                  <a:srgbClr val="BCBEC4"/>
-                </a:solidFill>
-                <a:latin typeface="Consolas"/>
-              </a:rPr>
-              <a:t> </a:t>
-            </a:r>
-            <a:r>
-              <a:rPr sz="1600">
-                <a:solidFill>
-                  <a:srgbClr val="BCBEC4"/>
-                </a:solidFill>
-                <a:latin typeface="Consolas"/>
-              </a:rPr>
-              <a:t> </a:t>
-            </a:r>
-            <a:r>
-              <a:rPr sz="1600">
-                <a:solidFill>
-                  <a:srgbClr val="BCBEC4"/>
-                </a:solidFill>
-                <a:latin typeface="Consolas"/>
-              </a:rPr>
-              <a:t> </a:t>
-            </a:r>
-            <a:r>
-              <a:rPr sz="1600">
-                <a:solidFill>
-                  <a:srgbClr val="BCBEC4"/>
-                </a:solidFill>
-                <a:latin typeface="Consolas"/>
-              </a:rPr>
-              <a:t> </a:t>
-            </a:r>
-            <a:r>
-              <a:rPr sz="1600">
-                <a:solidFill>
-                  <a:srgbClr val="BCBEC4"/>
-                </a:solidFill>
-                <a:latin typeface="Consolas"/>
-              </a:rPr>
-              <a:t> </a:t>
-            </a:r>
-            <a:r>
-              <a:rPr sz="1600">
-                <a:solidFill>
-                  <a:srgbClr val="BCBEC4"/>
-                </a:solidFill>
-                <a:latin typeface="Consolas"/>
-              </a:rPr>
-              <a:t> </a:t>
-            </a:r>
-            <a:r>
-              <a:rPr sz="1600">
-                <a:solidFill>
-                  <a:srgbClr val="BCBEC4"/>
-                </a:solidFill>
-                <a:latin typeface="Consolas"/>
-              </a:rPr>
-              <a:t> </a:t>
-            </a:r>
-            <a:r>
-              <a:rPr sz="1600">
-                <a:solidFill>
-                  <a:srgbClr val="BCBEC4"/>
-                </a:solidFill>
-                <a:latin typeface="Consolas"/>
-              </a:rPr>
-              <a:t> </a:t>
-            </a:r>
-            <a:r>
-              <a:rPr sz="1600">
-                <a:solidFill>
-                  <a:srgbClr val="BCBEC4"/>
-                </a:solidFill>
-                <a:latin typeface="Consolas"/>
-              </a:rPr>
-              <a:t> </a:t>
-            </a:r>
-            <a:r>
-              <a:rPr sz="1600">
-                <a:solidFill>
-                  <a:srgbClr val="BCBEC4"/>
-                </a:solidFill>
-                <a:latin typeface="Consolas"/>
-              </a:rPr>
-              <a:t> </a:t>
-            </a:r>
-            <a:r>
-              <a:rPr sz="1600">
-                <a:solidFill>
-                  <a:srgbClr val="BCBEC4"/>
-                </a:solidFill>
-                <a:latin typeface="Consolas"/>
-              </a:rPr>
-              <a:t> </a:t>
-            </a:r>
-            <a:r>
-              <a:rPr sz="1600">
-                <a:solidFill>
-                  <a:srgbClr val="BCBEC4"/>
-                </a:solidFill>
-                <a:latin typeface="Consolas"/>
-              </a:rPr>
-              <a:t> </a:t>
-            </a:r>
-            <a:r>
-              <a:rPr sz="1600">
-                <a:solidFill>
-                  <a:srgbClr val="BCBEC4"/>
-                </a:solidFill>
-                <a:latin typeface="Consolas"/>
-              </a:rPr>
-              <a:t> </a:t>
-            </a:r>
-            <a:r>
-              <a:rPr sz="1600">
-                <a:solidFill>
-                  <a:srgbClr val="BCBEC4"/>
-                </a:solidFill>
-                <a:latin typeface="Consolas"/>
-              </a:rPr>
-              <a:t> </a:t>
-            </a:r>
-            <a:r>
-              <a:rPr sz="1600">
-                <a:solidFill>
-                  <a:srgbClr val="BCBEC4"/>
-                </a:solidFill>
-                <a:latin typeface="Consolas"/>
-              </a:rPr>
-              <a:t> </a:t>
-            </a:r>
-            <a:r>
-              <a:rPr sz="1600">
-                <a:solidFill>
-                  <a:srgbClr val="BCBEC4"/>
-                </a:solidFill>
-                <a:latin typeface="Consolas"/>
-              </a:rPr>
-              <a:t> </a:t>
-            </a:r>
-            <a:r>
-              <a:rPr sz="1600">
-                <a:solidFill>
-                  <a:srgbClr val="BCBEC4"/>
-                </a:solidFill>
-                <a:latin typeface="Consolas"/>
-              </a:rPr>
-              <a:t> </a:t>
-            </a:r>
-            <a:r>
-              <a:rPr sz="1600">
-                <a:solidFill>
-                  <a:srgbClr val="BCBEC4"/>
-                </a:solidFill>
-                <a:latin typeface="Consolas"/>
-              </a:rPr>
-              <a:t> </a:t>
+              <a:t>()                          </a:t>
             </a:r>
             <a:r>
               <a:rPr sz="1600">
@@ -12962,16 +12663,16 @@
                 </a:solidFill>
                 <a:latin typeface="Consolas"/>
               </a:rPr>
-              <a:t> </a:t>
+              <a:t>        .</a:t>
             </a:r>
             <a:r>
               <a:rPr sz="1600">
                 <a:solidFill>
-                  <a:srgbClr val="BCBEC4"/>
-                </a:solidFill>
-                <a:latin typeface="Consolas"/>
-              </a:rPr>
-              <a:t> </a:t>
+                  <a:srgbClr val="56A8F5"/>
+                </a:solidFill>
+                <a:latin typeface="Consolas"/>
+              </a:rPr>
+              <a:t>filter</a:t>
             </a:r>
             <a:r>
               <a:rPr sz="1600">
@@ -12980,16 +12681,16 @@
                 </a:solidFill>
                 <a:latin typeface="Consolas"/>
               </a:rPr>
-              <a:t> </a:t>
+              <a:t>(titre -&gt; titre.</a:t>
             </a:r>
             <a:r>
               <a:rPr sz="1600">
                 <a:solidFill>
-                  <a:srgbClr val="BCBEC4"/>
-                </a:solidFill>
-                <a:latin typeface="Consolas"/>
-              </a:rPr>
-              <a:t> </a:t>
+                  <a:srgbClr val="56A8F5"/>
+                </a:solidFill>
+                <a:latin typeface="Consolas"/>
+              </a:rPr>
+              <a:t>length</a:t>
             </a:r>
             <a:r>
               <a:rPr sz="1600">
@@ -12998,214 +12699,7 @@
                 </a:solidFill>
                 <a:latin typeface="Consolas"/>
               </a:rPr>
-              <a:t> </a:t>
-            </a:r>
-            <a:r>
-              <a:rPr sz="1600">
-                <a:solidFill>
-                  <a:srgbClr val="BCBEC4"/>
-                </a:solidFill>
-                <a:latin typeface="Consolas"/>
-              </a:rPr>
-              <a:t> </a:t>
-            </a:r>
-            <a:r>
-              <a:rPr sz="1600">
-                <a:solidFill>
-                  <a:srgbClr val="BCBEC4"/>
-                </a:solidFill>
-                <a:latin typeface="Consolas"/>
-              </a:rPr>
-              <a:t> </a:t>
-            </a:r>
-            <a:r>
-              <a:rPr sz="1600">
-                <a:solidFill>
-                  <a:srgbClr val="BCBEC4"/>
-                </a:solidFill>
-                <a:latin typeface="Consolas"/>
-              </a:rPr>
-              <a:t> </a:t>
-            </a:r>
-            <a:r>
-              <a:rPr sz="1600">
-                <a:solidFill>
-                  <a:srgbClr val="BCBEC4"/>
-                </a:solidFill>
-                <a:latin typeface="Consolas"/>
-              </a:rPr>
-              <a:t>.</a:t>
-            </a:r>
-            <a:r>
-              <a:rPr sz="1600">
-                <a:solidFill>
-                  <a:srgbClr val="56A8F5"/>
-                </a:solidFill>
-                <a:latin typeface="Consolas"/>
-              </a:rPr>
-              <a:t>filter</a:t>
-            </a:r>
-            <a:r>
-              <a:rPr sz="1600">
-                <a:solidFill>
-                  <a:srgbClr val="BCBEC4"/>
-                </a:solidFill>
-                <a:latin typeface="Consolas"/>
-              </a:rPr>
-              <a:t>(</a:t>
-            </a:r>
-            <a:r>
-              <a:rPr sz="1600">
-                <a:solidFill>
-                  <a:srgbClr val="BCBEC4"/>
-                </a:solidFill>
-                <a:latin typeface="Consolas"/>
-              </a:rPr>
-              <a:t>titre</a:t>
-            </a:r>
-            <a:r>
-              <a:rPr sz="1600">
-                <a:solidFill>
-                  <a:srgbClr val="BCBEC4"/>
-                </a:solidFill>
-                <a:latin typeface="Consolas"/>
-              </a:rPr>
-              <a:t> </a:t>
-            </a:r>
-            <a:r>
-              <a:rPr sz="1600">
-                <a:solidFill>
-                  <a:srgbClr val="BCBEC4"/>
-                </a:solidFill>
-                <a:latin typeface="Consolas"/>
-              </a:rPr>
-              <a:t>-</a:t>
-            </a:r>
-            <a:r>
-              <a:rPr sz="1600">
-                <a:solidFill>
-                  <a:srgbClr val="BCBEC4"/>
-                </a:solidFill>
-                <a:latin typeface="Consolas"/>
-              </a:rPr>
-              <a:t>&gt;</a:t>
-            </a:r>
-            <a:r>
-              <a:rPr sz="1600">
-                <a:solidFill>
-                  <a:srgbClr val="BCBEC4"/>
-                </a:solidFill>
-                <a:latin typeface="Consolas"/>
-              </a:rPr>
-              <a:t> </a:t>
-            </a:r>
-            <a:r>
-              <a:rPr sz="1600">
-                <a:solidFill>
-                  <a:srgbClr val="BCBEC4"/>
-                </a:solidFill>
-                <a:latin typeface="Consolas"/>
-              </a:rPr>
-              <a:t>titre</a:t>
-            </a:r>
-            <a:r>
-              <a:rPr sz="1600">
-                <a:solidFill>
-                  <a:srgbClr val="BCBEC4"/>
-                </a:solidFill>
-                <a:latin typeface="Consolas"/>
-              </a:rPr>
-              <a:t>.</a:t>
-            </a:r>
-            <a:r>
-              <a:rPr sz="1600">
-                <a:solidFill>
-                  <a:srgbClr val="56A8F5"/>
-                </a:solidFill>
-                <a:latin typeface="Consolas"/>
-              </a:rPr>
-              <a:t>length</a:t>
-            </a:r>
-            <a:r>
-              <a:rPr sz="1600">
-                <a:solidFill>
-                  <a:srgbClr val="BCBEC4"/>
-                </a:solidFill>
-                <a:latin typeface="Consolas"/>
-              </a:rPr>
-              <a:t>(</a:t>
-            </a:r>
-            <a:r>
-              <a:rPr sz="1600">
-                <a:solidFill>
-                  <a:srgbClr val="BCBEC4"/>
-                </a:solidFill>
-                <a:latin typeface="Consolas"/>
-              </a:rPr>
-              <a:t>)</a:t>
-            </a:r>
-            <a:r>
-              <a:rPr sz="1600">
-                <a:solidFill>
-                  <a:srgbClr val="BCBEC4"/>
-                </a:solidFill>
-                <a:latin typeface="Consolas"/>
-              </a:rPr>
-              <a:t> </a:t>
-            </a:r>
-            <a:r>
-              <a:rPr sz="1600">
-                <a:solidFill>
-                  <a:srgbClr val="BCBEC4"/>
-                </a:solidFill>
-                <a:latin typeface="Consolas"/>
-              </a:rPr>
-              <a:t>&gt;</a:t>
-            </a:r>
-            <a:r>
-              <a:rPr sz="1600">
-                <a:solidFill>
-                  <a:srgbClr val="BCBEC4"/>
-                </a:solidFill>
-                <a:latin typeface="Consolas"/>
-              </a:rPr>
-              <a:t> </a:t>
-            </a:r>
-            <a:r>
-              <a:rPr sz="1600">
-                <a:solidFill>
-                  <a:srgbClr val="BCBEC4"/>
-                </a:solidFill>
-                <a:latin typeface="Consolas"/>
-              </a:rPr>
-              <a:t>LONGUEUR_MAX</a:t>
-            </a:r>
-            <a:r>
-              <a:rPr sz="1600">
-                <a:solidFill>
-                  <a:srgbClr val="BCBEC4"/>
-                </a:solidFill>
-                <a:latin typeface="Consolas"/>
-              </a:rPr>
-              <a:t>)</a:t>
-            </a:r>
-            <a:r>
-              <a:rPr sz="1600">
-                <a:solidFill>
-                  <a:srgbClr val="BCBEC4"/>
-                </a:solidFill>
-                <a:latin typeface="Consolas"/>
-              </a:rPr>
-              <a:t> </a:t>
-            </a:r>
-            <a:r>
-              <a:rPr sz="1600">
-                <a:solidFill>
-                  <a:srgbClr val="BCBEC4"/>
-                </a:solidFill>
-                <a:latin typeface="Consolas"/>
-              </a:rPr>
-              <a:t> </a:t>
+              <a:t>() &gt; LONGUEUR_MAX)  </a:t>
             </a:r>
             <a:r>
               <a:rPr sz="1600">
@@ -13236,16 +12730,16 @@
                 </a:solidFill>
                 <a:latin typeface="Consolas"/>
               </a:rPr>
-              <a:t> </a:t>
+              <a:t>        .</a:t>
             </a:r>
             <a:r>
               <a:rPr sz="1600">
                 <a:solidFill>
-                  <a:srgbClr val="BCBEC4"/>
-                </a:solidFill>
-                <a:latin typeface="Consolas"/>
-              </a:rPr>
-              <a:t> </a:t>
+                  <a:srgbClr val="56A8F5"/>
+                </a:solidFill>
+                <a:latin typeface="Consolas"/>
+              </a:rPr>
+              <a:t>map</a:t>
             </a:r>
             <a:r>
               <a:rPr sz="1600">
@@ -13254,16 +12748,16 @@
                 </a:solidFill>
                 <a:latin typeface="Consolas"/>
               </a:rPr>
-              <a:t> </a:t>
+              <a:t>(titre -&gt; titre.</a:t>
             </a:r>
             <a:r>
               <a:rPr sz="1600">
                 <a:solidFill>
-                  <a:srgbClr val="BCBEC4"/>
-                </a:solidFill>
-                <a:latin typeface="Consolas"/>
-              </a:rPr>
-              <a:t> </a:t>
+                  <a:srgbClr val="56A8F5"/>
+                </a:solidFill>
+                <a:latin typeface="Consolas"/>
+              </a:rPr>
+              <a:t>toUpperCase</a:t>
             </a:r>
             <a:r>
               <a:rPr sz="1600">
@@ -13272,295 +12766,7 @@
                 </a:solidFill>
                 <a:latin typeface="Consolas"/>
               </a:rPr>
-              <a:t> </a:t>
-            </a:r>
-            <a:r>
-              <a:rPr sz="1600">
-                <a:solidFill>
-                  <a:srgbClr val="BCBEC4"/>
-                </a:solidFill>
-                <a:latin typeface="Consolas"/>
-              </a:rPr>
-              <a:t> </a:t>
-            </a:r>
-            <a:r>
-              <a:rPr sz="1600">
-                <a:solidFill>
-                  <a:srgbClr val="BCBEC4"/>
-                </a:solidFill>
-                <a:latin typeface="Consolas"/>
-              </a:rPr>
-              <a:t> </a:t>
-            </a:r>
-            <a:r>
-              <a:rPr sz="1600">
-                <a:solidFill>
-                  <a:srgbClr val="BCBEC4"/>
-                </a:solidFill>
-                <a:latin typeface="Consolas"/>
-              </a:rPr>
-              <a:t> </a:t>
-            </a:r>
-            <a:r>
-              <a:rPr sz="1600">
-                <a:solidFill>
-                  <a:srgbClr val="BCBEC4"/>
-                </a:solidFill>
-                <a:latin typeface="Consolas"/>
-              </a:rPr>
-              <a:t>.</a:t>
-            </a:r>
-            <a:r>
-              <a:rPr sz="1600">
-                <a:solidFill>
-                  <a:srgbClr val="56A8F5"/>
-                </a:solidFill>
-                <a:latin typeface="Consolas"/>
-              </a:rPr>
-              <a:t>map</a:t>
-            </a:r>
-            <a:r>
-              <a:rPr sz="1600">
-                <a:solidFill>
-                  <a:srgbClr val="BCBEC4"/>
-                </a:solidFill>
-                <a:latin typeface="Consolas"/>
-              </a:rPr>
-              <a:t>(</a:t>
-            </a:r>
-            <a:r>
-              <a:rPr sz="1600">
-                <a:solidFill>
-                  <a:srgbClr val="BCBEC4"/>
-                </a:solidFill>
-                <a:latin typeface="Consolas"/>
-              </a:rPr>
-              <a:t>titre</a:t>
-            </a:r>
-            <a:r>
-              <a:rPr sz="1600">
-                <a:solidFill>
-                  <a:srgbClr val="BCBEC4"/>
-                </a:solidFill>
-                <a:latin typeface="Consolas"/>
-              </a:rPr>
-              <a:t> </a:t>
-            </a:r>
-            <a:r>
-              <a:rPr sz="1600">
-                <a:solidFill>
-                  <a:srgbClr val="BCBEC4"/>
-                </a:solidFill>
-                <a:latin typeface="Consolas"/>
-              </a:rPr>
-              <a:t>-</a:t>
-            </a:r>
-            <a:r>
-              <a:rPr sz="1600">
-                <a:solidFill>
-                  <a:srgbClr val="BCBEC4"/>
-                </a:solidFill>
-                <a:latin typeface="Consolas"/>
-              </a:rPr>
-              <a:t>&gt;</a:t>
-            </a:r>
-            <a:r>
-              <a:rPr sz="1600">
-                <a:solidFill>
-                  <a:srgbClr val="BCBEC4"/>
-                </a:solidFill>
-                <a:latin typeface="Consolas"/>
-              </a:rPr>
-              <a:t> </a:t>
-            </a:r>
-            <a:r>
-              <a:rPr sz="1600">
-                <a:solidFill>
-                  <a:srgbClr val="BCBEC4"/>
-                </a:solidFill>
-                <a:latin typeface="Consolas"/>
-              </a:rPr>
-              <a:t>titre</a:t>
-            </a:r>
-            <a:r>
-              <a:rPr sz="1600">
-                <a:solidFill>
-                  <a:srgbClr val="BCBEC4"/>
-                </a:solidFill>
-                <a:latin typeface="Consolas"/>
-              </a:rPr>
-              <a:t>.</a:t>
-            </a:r>
-            <a:r>
-              <a:rPr sz="1600">
-                <a:solidFill>
-                  <a:srgbClr val="56A8F5"/>
-                </a:solidFill>
-                <a:latin typeface="Consolas"/>
-              </a:rPr>
-              <a:t>toUpperCase</a:t>
-            </a:r>
-            <a:r>
-              <a:rPr sz="1600">
-                <a:solidFill>
-                  <a:srgbClr val="BCBEC4"/>
-                </a:solidFill>
-                <a:latin typeface="Consolas"/>
-              </a:rPr>
-              <a:t>(</a:t>
-            </a:r>
-            <a:r>
-              <a:rPr sz="1600">
-                <a:solidFill>
-                  <a:srgbClr val="BCBEC4"/>
-                </a:solidFill>
-                <a:latin typeface="Consolas"/>
-              </a:rPr>
-              <a:t>)</a:t>
-            </a:r>
-            <a:r>
-              <a:rPr sz="1600">
-                <a:solidFill>
-                  <a:srgbClr val="BCBEC4"/>
-                </a:solidFill>
-                <a:latin typeface="Consolas"/>
-              </a:rPr>
-              <a:t>)</a:t>
-            </a:r>
-            <a:r>
-              <a:rPr sz="1600">
-                <a:solidFill>
-                  <a:srgbClr val="BCBEC4"/>
-                </a:solidFill>
-                <a:latin typeface="Consolas"/>
-              </a:rPr>
-              <a:t> </a:t>
-            </a:r>
-            <a:r>
-              <a:rPr sz="1600">
-                <a:solidFill>
-                  <a:srgbClr val="BCBEC4"/>
-                </a:solidFill>
-                <a:latin typeface="Consolas"/>
-              </a:rPr>
-              <a:t> </a:t>
-            </a:r>
-            <a:r>
-              <a:rPr sz="1600">
-                <a:solidFill>
-                  <a:srgbClr val="BCBEC4"/>
-                </a:solidFill>
-                <a:latin typeface="Consolas"/>
-              </a:rPr>
-              <a:t> </a:t>
-            </a:r>
-            <a:r>
-              <a:rPr sz="1600">
-                <a:solidFill>
-                  <a:srgbClr val="BCBEC4"/>
-                </a:solidFill>
-                <a:latin typeface="Consolas"/>
-              </a:rPr>
-              <a:t> </a:t>
-            </a:r>
-            <a:r>
-              <a:rPr sz="1600">
-                <a:solidFill>
-                  <a:srgbClr val="BCBEC4"/>
-                </a:solidFill>
-                <a:latin typeface="Consolas"/>
-              </a:rPr>
-              <a:t> </a:t>
-            </a:r>
-            <a:r>
-              <a:rPr sz="1600">
-                <a:solidFill>
-                  <a:srgbClr val="BCBEC4"/>
-                </a:solidFill>
-                <a:latin typeface="Consolas"/>
-              </a:rPr>
-              <a:t> </a:t>
-            </a:r>
-            <a:r>
-              <a:rPr sz="1600">
-                <a:solidFill>
-                  <a:srgbClr val="BCBEC4"/>
-                </a:solidFill>
-                <a:latin typeface="Consolas"/>
-              </a:rPr>
-              <a:t> </a:t>
-            </a:r>
-            <a:r>
-              <a:rPr sz="1600">
-                <a:solidFill>
-                  <a:srgbClr val="BCBEC4"/>
-                </a:solidFill>
-                <a:latin typeface="Consolas"/>
-              </a:rPr>
-              <a:t> </a:t>
-            </a:r>
-            <a:r>
-              <a:rPr sz="1600">
-                <a:solidFill>
-                  <a:srgbClr val="BCBEC4"/>
-                </a:solidFill>
-                <a:latin typeface="Consolas"/>
-              </a:rPr>
-              <a:t> </a:t>
-            </a:r>
-            <a:r>
-              <a:rPr sz="1600">
-                <a:solidFill>
-                  <a:srgbClr val="BCBEC4"/>
-                </a:solidFill>
-                <a:latin typeface="Consolas"/>
-              </a:rPr>
-              <a:t> </a:t>
-            </a:r>
-            <a:r>
-              <a:rPr sz="1600">
-                <a:solidFill>
-                  <a:srgbClr val="BCBEC4"/>
-                </a:solidFill>
-                <a:latin typeface="Consolas"/>
-              </a:rPr>
-              <a:t> </a:t>
-            </a:r>
-            <a:r>
-              <a:rPr sz="1600">
-                <a:solidFill>
-                  <a:srgbClr val="BCBEC4"/>
-                </a:solidFill>
-                <a:latin typeface="Consolas"/>
-              </a:rPr>
-              <a:t> </a:t>
-            </a:r>
-            <a:r>
-              <a:rPr sz="1600">
-                <a:solidFill>
-                  <a:srgbClr val="BCBEC4"/>
-                </a:solidFill>
-                <a:latin typeface="Consolas"/>
-              </a:rPr>
-              <a:t> </a:t>
-            </a:r>
-            <a:r>
-              <a:rPr sz="1600">
-                <a:solidFill>
-                  <a:srgbClr val="BCBEC4"/>
-                </a:solidFill>
-                <a:latin typeface="Consolas"/>
-              </a:rPr>
-              <a:t> </a:t>
-            </a:r>
-            <a:r>
-              <a:rPr sz="1600">
-                <a:solidFill>
-                  <a:srgbClr val="BCBEC4"/>
-                </a:solidFill>
-                <a:latin typeface="Consolas"/>
-              </a:rPr>
-              <a:t> </a:t>
+              <a:t>())               </a:t>
             </a:r>
             <a:r>
               <a:rPr sz="1600">
@@ -13591,16 +12797,16 @@
                 </a:solidFill>
                 <a:latin typeface="Consolas"/>
               </a:rPr>
-              <a:t> </a:t>
+              <a:t>        .</a:t>
             </a:r>
             <a:r>
               <a:rPr sz="1600">
                 <a:solidFill>
-                  <a:srgbClr val="BCBEC4"/>
-                </a:solidFill>
-                <a:latin typeface="Consolas"/>
-              </a:rPr>
-              <a:t> </a:t>
+                  <a:srgbClr val="56A8F5"/>
+                </a:solidFill>
+                <a:latin typeface="Consolas"/>
+              </a:rPr>
+              <a:t>collect</a:t>
             </a:r>
             <a:r>
               <a:rPr sz="1600">
@@ -13609,16 +12815,16 @@
                 </a:solidFill>
                 <a:latin typeface="Consolas"/>
               </a:rPr>
-              <a:t> </a:t>
+              <a:t>(Collectors.</a:t>
             </a:r>
             <a:r>
               <a:rPr sz="1600">
                 <a:solidFill>
-                  <a:srgbClr val="BCBEC4"/>
-                </a:solidFill>
-                <a:latin typeface="Consolas"/>
-              </a:rPr>
-              <a:t> </a:t>
+                  <a:srgbClr val="56A8F5"/>
+                </a:solidFill>
+                <a:latin typeface="Consolas"/>
+              </a:rPr>
+              <a:t>joining</a:t>
             </a:r>
             <a:r>
               <a:rPr sz="1600">
@@ -13627,16 +12833,16 @@
                 </a:solidFill>
                 <a:latin typeface="Consolas"/>
               </a:rPr>
-              <a:t> </a:t>
+              <a:t>(</a:t>
             </a:r>
             <a:r>
               <a:rPr sz="1600">
                 <a:solidFill>
-                  <a:srgbClr val="BCBEC4"/>
-                </a:solidFill>
-                <a:latin typeface="Consolas"/>
-              </a:rPr>
-              <a:t> </a:t>
+                  <a:srgbClr val="6AAB73"/>
+                </a:solidFill>
+                <a:latin typeface="Consolas"/>
+              </a:rPr>
+              <a:t>", "</a:t>
             </a:r>
             <a:r>
               <a:rPr sz="1600">
@@ -13645,245 +12851,11 @@
                 </a:solidFill>
                 <a:latin typeface="Consolas"/>
               </a:rPr>
-              <a:t> </a:t>
+              <a:t>));              </a:t>
             </a:r>
             <a:r>
               <a:rPr sz="1600">
                 <a:solidFill>
-                  <a:srgbClr val="BCBEC4"/>
-                </a:solidFill>
-                <a:latin typeface="Consolas"/>
-              </a:rPr>
-              <a:t> </a:t>
-            </a:r>
-            <a:r>
-              <a:rPr sz="1600">
-                <a:solidFill>
-                  <a:srgbClr val="BCBEC4"/>
-                </a:solidFill>
-                <a:latin typeface="Consolas"/>
-              </a:rPr>
-              <a:t>.</a:t>
-            </a:r>
-            <a:r>
-              <a:rPr sz="1600">
-                <a:solidFill>
-                  <a:srgbClr val="56A8F5"/>
-                </a:solidFill>
-                <a:latin typeface="Consolas"/>
-              </a:rPr>
-              <a:t>collect</a:t>
-            </a:r>
-            <a:r>
-              <a:rPr sz="1600">
-                <a:solidFill>
-                  <a:srgbClr val="BCBEC4"/>
-                </a:solidFill>
-                <a:latin typeface="Consolas"/>
-              </a:rPr>
-              <a:t>(</a:t>
-            </a:r>
-            <a:r>
-              <a:rPr sz="1600">
-                <a:solidFill>
-                  <a:srgbClr val="BCBEC4"/>
-                </a:solidFill>
-                <a:latin typeface="Consolas"/>
-              </a:rPr>
-              <a:t>Collectors</a:t>
-            </a:r>
-            <a:r>
-              <a:rPr sz="1600">
-                <a:solidFill>
-                  <a:srgbClr val="BCBEC4"/>
-                </a:solidFill>
-                <a:latin typeface="Consolas"/>
-              </a:rPr>
-              <a:t>.</a:t>
-            </a:r>
-            <a:r>
-              <a:rPr sz="1600">
-                <a:solidFill>
-                  <a:srgbClr val="56A8F5"/>
-                </a:solidFill>
-                <a:latin typeface="Consolas"/>
-              </a:rPr>
-              <a:t>joining</a:t>
-            </a:r>
-            <a:r>
-              <a:rPr sz="1600">
-                <a:solidFill>
-                  <a:srgbClr val="BCBEC4"/>
-                </a:solidFill>
-                <a:latin typeface="Consolas"/>
-              </a:rPr>
-              <a:t>(</a:t>
-            </a:r>
-            <a:r>
-              <a:rPr sz="1600">
-                <a:solidFill>
-                  <a:srgbClr val="6AAB73"/>
-                </a:solidFill>
-                <a:latin typeface="Consolas"/>
-              </a:rPr>
-              <a:t>", "</a:t>
-            </a:r>
-            <a:r>
-              <a:rPr sz="1600">
-                <a:solidFill>
-                  <a:srgbClr val="BCBEC4"/>
-                </a:solidFill>
-                <a:latin typeface="Consolas"/>
-              </a:rPr>
-              <a:t>)</a:t>
-            </a:r>
-            <a:r>
-              <a:rPr sz="1600">
-                <a:solidFill>
-                  <a:srgbClr val="BCBEC4"/>
-                </a:solidFill>
-                <a:latin typeface="Consolas"/>
-              </a:rPr>
-              <a:t>)</a:t>
-            </a:r>
-            <a:r>
-              <a:rPr sz="1600">
-                <a:solidFill>
-                  <a:srgbClr val="BCBEC4"/>
-                </a:solidFill>
-                <a:latin typeface="Consolas"/>
-              </a:rPr>
-              <a:t>;</a:t>
-            </a:r>
-            <a:r>
-              <a:rPr sz="1600">
-                <a:solidFill>
-                  <a:srgbClr val="BCBEC4"/>
-                </a:solidFill>
-                <a:latin typeface="Consolas"/>
-              </a:rPr>
-              <a:t> </a:t>
-            </a:r>
-            <a:r>
-              <a:rPr sz="1600">
-                <a:solidFill>
-                  <a:srgbClr val="BCBEC4"/>
-                </a:solidFill>
-                <a:latin typeface="Consolas"/>
-              </a:rPr>
-              <a:t> </a:t>
-            </a:r>
-            <a:r>
-              <a:rPr sz="1600">
-                <a:solidFill>
-                  <a:srgbClr val="BCBEC4"/>
-                </a:solidFill>
-                <a:latin typeface="Consolas"/>
-              </a:rPr>
-              <a:t> </a:t>
-            </a:r>
-            <a:r>
-              <a:rPr sz="1600">
-                <a:solidFill>
-                  <a:srgbClr val="BCBEC4"/>
-                </a:solidFill>
-                <a:latin typeface="Consolas"/>
-              </a:rPr>
-              <a:t> </a:t>
-            </a:r>
-            <a:r>
-              <a:rPr sz="1600">
-                <a:solidFill>
-                  <a:srgbClr val="BCBEC4"/>
-                </a:solidFill>
-                <a:latin typeface="Consolas"/>
-              </a:rPr>
-              <a:t> </a:t>
-            </a:r>
-            <a:r>
-              <a:rPr sz="1600">
-                <a:solidFill>
-                  <a:srgbClr val="BCBEC4"/>
-                </a:solidFill>
-                <a:latin typeface="Consolas"/>
-              </a:rPr>
-              <a:t> </a:t>
-            </a:r>
-            <a:r>
-              <a:rPr sz="1600">
-                <a:solidFill>
-                  <a:srgbClr val="BCBEC4"/>
-                </a:solidFill>
-                <a:latin typeface="Consolas"/>
-              </a:rPr>
-              <a:t> </a:t>
-            </a:r>
-            <a:r>
-              <a:rPr sz="1600">
-                <a:solidFill>
-                  <a:srgbClr val="BCBEC4"/>
-                </a:solidFill>
-                <a:latin typeface="Consolas"/>
-              </a:rPr>
-              <a:t> </a:t>
-            </a:r>
-            <a:r>
-              <a:rPr sz="1600">
-                <a:solidFill>
-                  <a:srgbClr val="BCBEC4"/>
-                </a:solidFill>
-                <a:latin typeface="Consolas"/>
-              </a:rPr>
-              <a:t> </a:t>
-            </a:r>
-            <a:r>
-              <a:rPr sz="1600">
-                <a:solidFill>
-                  <a:srgbClr val="BCBEC4"/>
-                </a:solidFill>
-                <a:latin typeface="Consolas"/>
-              </a:rPr>
-              <a:t> </a:t>
-            </a:r>
-            <a:r>
-              <a:rPr sz="1600">
-                <a:solidFill>
-                  <a:srgbClr val="BCBEC4"/>
-                </a:solidFill>
-                <a:latin typeface="Consolas"/>
-              </a:rPr>
-              <a:t> </a:t>
-            </a:r>
-            <a:r>
-              <a:rPr sz="1600">
-                <a:solidFill>
-                  <a:srgbClr val="BCBEC4"/>
-                </a:solidFill>
-                <a:latin typeface="Consolas"/>
-              </a:rPr>
-              <a:t> </a:t>
-            </a:r>
-            <a:r>
-              <a:rPr sz="1600">
-                <a:solidFill>
-                  <a:srgbClr val="BCBEC4"/>
-                </a:solidFill>
-                <a:latin typeface="Consolas"/>
-              </a:rPr>
-              <a:t> </a:t>
-            </a:r>
-            <a:r>
-              <a:rPr sz="1600">
-                <a:solidFill>
-                  <a:srgbClr val="BCBEC4"/>
-                </a:solidFill>
-                <a:latin typeface="Consolas"/>
-              </a:rPr>
-              <a:t> </a:t>
-            </a:r>
-            <a:r>
-              <a:rPr sz="1600">
-                <a:solidFill>
                   <a:srgbClr val="7A7E85"/>
                 </a:solidFill>
                 <a:latin typeface="Consolas"/>
@@ -13895,7 +12867,7 @@
       </p:sp>
       <p:sp>
         <p:nvSpPr>
-          <p:cNvPr id="3" name="Espace réservé du numéro de diapositive 2">
+          <p:cNvPr id="6" name="Espace réservé du numéro de diapositive 2">
             <a:extLst>
               <a:ext uri="{FF2B5EF4-FFF2-40B4-BE49-F238E27FC236}">
                 <a16:creationId xmlns:a16="http://schemas.microsoft.com/office/drawing/2014/main" id="{ECBEBDD9-D9CC-2B70-9E8C-523CC2893F62}"/>
@@ -13916,7 +12888,7 @@
           <a:p>
             <a:fld id="{33C783E2-4793-4F48-A271-51A73CC37D74}" type="slidenum">
               <a:rPr lang="fr-FR" smtClean="0"/>
-              <a:t>2</a:t>
+              <a:t>17</a:t>
             </a:fld>
             <a:endParaRPr lang="fr-FR"/>
           </a:p>
@@ -14059,7 +13031,7 @@
 </file>
 
 <file path=ppt/slides/slide18.xml><?xml version="1.0" encoding="utf-8"?>
-<p:sld xmlns:a="http://schemas.openxmlformats.org/drawingml/2006/main" xmlns:p="http://schemas.openxmlformats.org/presentationml/2006/main" xmlns:r="http://schemas.openxmlformats.org/officeDocument/2006/relationships">
+<p:sld xmlns:a="http://schemas.openxmlformats.org/drawingml/2006/main" xmlns:r="http://schemas.openxmlformats.org/officeDocument/2006/relationships" xmlns:p="http://schemas.openxmlformats.org/presentationml/2006/main">
   <p:cSld>
     <p:spTree>
       <p:nvGrpSpPr>
@@ -14067,7 +13039,14 @@
         <p:cNvGrpSpPr/>
         <p:nvPr/>
       </p:nvGrpSpPr>
-      <p:grpSpPr/>
+      <p:grpSpPr>
+        <a:xfrm>
+          <a:off x="0" y="0"/>
+          <a:ext cx="0" cy="0"/>
+          <a:chOff x="0" y="0"/>
+          <a:chExt cx="0" cy="0"/>
+        </a:xfrm>
+      </p:grpSpPr>
       <p:sp>
         <p:nvSpPr>
           <p:cNvPr id="2" name="Title 1"/>
@@ -14150,7 +13129,7 @@
         </p:nvSpPr>
         <p:spPr>
           <a:xfrm>
-            <a:off x="777240" y="2011680"/>
+            <a:off x="777240" y="2271124"/>
             <a:ext cx="2331720" cy="585216"/>
           </a:xfrm>
           <a:prstGeom prst="rect">
@@ -14183,7 +13162,7 @@
         </p:nvSpPr>
         <p:spPr>
           <a:xfrm>
-            <a:off x="3200400" y="2011680"/>
+            <a:off x="3200400" y="2271124"/>
             <a:ext cx="8183879" cy="585216"/>
           </a:xfrm>
           <a:prstGeom prst="rect">
@@ -14210,7 +13189,7 @@
       </p:sp>
       <p:sp>
         <p:nvSpPr>
-          <p:cNvPr id="3" name="Espace réservé du numéro de diapositive 2">
+          <p:cNvPr id="23" name="Espace réservé du numéro de diapositive 2">
             <a:extLst>
               <a:ext uri="{FF2B5EF4-FFF2-40B4-BE49-F238E27FC236}">
                 <a16:creationId xmlns:a16="http://schemas.microsoft.com/office/drawing/2014/main" id="{ECBEBDD9-D9CC-2B70-9E8C-523CC2893F62}"/>
@@ -14231,7 +13210,7 @@
           <a:p>
             <a:fld id="{33C783E2-4793-4F48-A271-51A73CC37D74}" type="slidenum">
               <a:rPr lang="fr-FR" smtClean="0"/>
-              <a:t>2</a:t>
+              <a:t>18</a:t>
             </a:fld>
             <a:endParaRPr lang="fr-FR"/>
           </a:p>
@@ -14287,7 +13266,7 @@
         </p:nvGrpSpPr>
         <p:grpSpPr>
           <a:xfrm>
-            <a:off x="640080" y="2670048"/>
+            <a:off x="640080" y="2929492"/>
             <a:ext cx="10881360" cy="585216"/>
             <a:chOff x="640080" y="2670048"/>
             <a:chExt cx="10881360" cy="585216"/>
@@ -14342,6 +13321,7 @@
             <a:lstStyle/>
             <a:p>
               <a:pPr algn="ctr"/>
+              <a:endParaRPr/>
             </a:p>
           </p:txBody>
         </p:sp>
@@ -14429,7 +13409,7 @@
         </p:nvGrpSpPr>
         <p:grpSpPr>
           <a:xfrm>
-            <a:off x="640080" y="3328415"/>
+            <a:off x="640080" y="3587859"/>
             <a:ext cx="10881360" cy="585216"/>
             <a:chOff x="640080" y="3328415"/>
             <a:chExt cx="10881360" cy="585216"/>
@@ -14484,6 +13464,7 @@
             <a:lstStyle/>
             <a:p>
               <a:pPr algn="ctr"/>
+              <a:endParaRPr/>
             </a:p>
           </p:txBody>
         </p:sp>
@@ -14571,7 +13552,7 @@
         </p:nvGrpSpPr>
         <p:grpSpPr>
           <a:xfrm>
-            <a:off x="640080" y="3986783"/>
+            <a:off x="640080" y="4246227"/>
             <a:ext cx="10881360" cy="585216"/>
             <a:chOff x="640080" y="3986783"/>
             <a:chExt cx="10881360" cy="585216"/>
@@ -14626,6 +13607,7 @@
             <a:lstStyle/>
             <a:p>
               <a:pPr algn="ctr"/>
+              <a:endParaRPr/>
             </a:p>
           </p:txBody>
         </p:sp>
@@ -14713,7 +13695,7 @@
         </p:nvGrpSpPr>
         <p:grpSpPr>
           <a:xfrm>
-            <a:off x="640080" y="4645151"/>
+            <a:off x="640080" y="4904595"/>
             <a:ext cx="10881360" cy="585216"/>
             <a:chOff x="640080" y="4645151"/>
             <a:chExt cx="10881360" cy="585216"/>
@@ -14768,6 +13750,7 @@
             <a:lstStyle/>
             <a:p>
               <a:pPr algn="ctr"/>
+              <a:endParaRPr/>
             </a:p>
           </p:txBody>
         </p:sp>
@@ -14847,6 +13830,366 @@
           </p:txBody>
         </p:sp>
       </p:grpSp>
+      <p:sp>
+        <p:nvSpPr>
+          <p:cNvPr id="24" name="Code">
+            <a:extLst>
+              <a:ext uri="{FF2B5EF4-FFF2-40B4-BE49-F238E27FC236}">
+                <a16:creationId xmlns:a16="http://schemas.microsoft.com/office/drawing/2014/main" id="{3D53DE99-DA8A-0712-5767-420CE4CB1865}"/>
+              </a:ext>
+            </a:extLst>
+          </p:cNvPr>
+          <p:cNvSpPr txBox="1"/>
+          <p:nvPr/>
+        </p:nvSpPr>
+        <p:spPr>
+          <a:xfrm>
+            <a:off x="6914648" y="1734203"/>
+            <a:ext cx="4606792" cy="935845"/>
+          </a:xfrm>
+          <a:prstGeom prst="roundRect">
+            <a:avLst>
+              <a:gd name="adj" fmla="val 7317"/>
+            </a:avLst>
+          </a:prstGeom>
+          <a:solidFill>
+            <a:srgbClr val="1D1F22"/>
+          </a:solidFill>
+          <a:effectLst>
+            <a:outerShdw blurRad="50800" dist="38100" dir="2700000" algn="tl" rotWithShape="0">
+              <a:prstClr val="black">
+                <a:alpha val="40000"/>
+              </a:prstClr>
+            </a:outerShdw>
+          </a:effectLst>
+        </p:spPr>
+        <p:txBody>
+          <a:bodyPr wrap="none" lIns="137160" tIns="91440" rIns="137160" bIns="91440"/>
+          <a:lstStyle/>
+          <a:p>
+            <a:pPr>
+              <a:lnSpc>
+                <a:spcPct val="100000"/>
+              </a:lnSpc>
+              <a:spcBef>
+                <a:spcPts val="0"/>
+              </a:spcBef>
+              <a:spcAft>
+                <a:spcPts val="0"/>
+              </a:spcAft>
+            </a:pPr>
+            <a:r>
+              <a:rPr sz="1200" dirty="0">
+                <a:solidFill>
+                  <a:srgbClr val="BCBEC4"/>
+                </a:solidFill>
+                <a:latin typeface="Consolas"/>
+              </a:rPr>
+              <a:t>String longs = </a:t>
+            </a:r>
+            <a:r>
+              <a:rPr sz="1200" dirty="0" err="1">
+                <a:solidFill>
+                  <a:srgbClr val="BCBEC4"/>
+                </a:solidFill>
+                <a:latin typeface="Consolas"/>
+              </a:rPr>
+              <a:t>titres.</a:t>
+            </a:r>
+            <a:r>
+              <a:rPr sz="1200" dirty="0" err="1">
+                <a:solidFill>
+                  <a:srgbClr val="56A8F5"/>
+                </a:solidFill>
+                <a:latin typeface="Consolas"/>
+              </a:rPr>
+              <a:t>stream</a:t>
+            </a:r>
+            <a:r>
+              <a:rPr sz="1200" dirty="0">
+                <a:solidFill>
+                  <a:srgbClr val="BCBEC4"/>
+                </a:solidFill>
+                <a:latin typeface="Consolas"/>
+              </a:rPr>
+              <a:t>()</a:t>
+            </a:r>
+            <a:br>
+              <a:rPr lang="nl-BE" sz="1200" dirty="0">
+                <a:solidFill>
+                  <a:srgbClr val="BCBEC4"/>
+                </a:solidFill>
+                <a:latin typeface="Consolas"/>
+              </a:rPr>
+            </a:br>
+            <a:r>
+              <a:rPr lang="nl-BE" sz="1200" dirty="0">
+                <a:solidFill>
+                  <a:srgbClr val="BCBEC4"/>
+                </a:solidFill>
+                <a:latin typeface="Consolas"/>
+              </a:rPr>
+              <a:t>    </a:t>
+            </a:r>
+            <a:r>
+              <a:rPr sz="1200" dirty="0">
+                <a:solidFill>
+                  <a:srgbClr val="BCBEC4"/>
+                </a:solidFill>
+                <a:latin typeface="Consolas"/>
+              </a:rPr>
+              <a:t>.</a:t>
+            </a:r>
+            <a:r>
+              <a:rPr sz="1200" dirty="0">
+                <a:solidFill>
+                  <a:srgbClr val="56A8F5"/>
+                </a:solidFill>
+                <a:latin typeface="Consolas"/>
+              </a:rPr>
+              <a:t>filter</a:t>
+            </a:r>
+            <a:r>
+              <a:rPr sz="1200" dirty="0">
+                <a:solidFill>
+                  <a:srgbClr val="BCBEC4"/>
+                </a:solidFill>
+                <a:latin typeface="Consolas"/>
+              </a:rPr>
+              <a:t>(</a:t>
+            </a:r>
+            <a:r>
+              <a:rPr sz="1200" dirty="0" err="1">
+                <a:solidFill>
+                  <a:srgbClr val="BCBEC4"/>
+                </a:solidFill>
+                <a:latin typeface="Consolas"/>
+              </a:rPr>
+              <a:t>titre</a:t>
+            </a:r>
+            <a:r>
+              <a:rPr sz="1200" dirty="0">
+                <a:solidFill>
+                  <a:srgbClr val="BCBEC4"/>
+                </a:solidFill>
+                <a:latin typeface="Consolas"/>
+              </a:rPr>
+              <a:t> -&gt; </a:t>
+            </a:r>
+            <a:r>
+              <a:rPr sz="1200" dirty="0" err="1">
+                <a:solidFill>
+                  <a:srgbClr val="BCBEC4"/>
+                </a:solidFill>
+                <a:latin typeface="Consolas"/>
+              </a:rPr>
+              <a:t>titre.</a:t>
+            </a:r>
+            <a:r>
+              <a:rPr sz="1200" dirty="0" err="1">
+                <a:solidFill>
+                  <a:srgbClr val="56A8F5"/>
+                </a:solidFill>
+                <a:latin typeface="Consolas"/>
+              </a:rPr>
+              <a:t>length</a:t>
+            </a:r>
+            <a:r>
+              <a:rPr sz="1200" dirty="0">
+                <a:solidFill>
+                  <a:srgbClr val="BCBEC4"/>
+                </a:solidFill>
+                <a:latin typeface="Consolas"/>
+              </a:rPr>
+              <a:t>() &gt; LONGUEUR_MAX) </a:t>
+            </a:r>
+            <a:br>
+              <a:rPr lang="nl-BE" sz="1200" dirty="0">
+                <a:solidFill>
+                  <a:srgbClr val="BCBEC4"/>
+                </a:solidFill>
+                <a:latin typeface="Consolas"/>
+              </a:rPr>
+            </a:br>
+            <a:r>
+              <a:rPr lang="nl-BE" sz="1200" dirty="0">
+                <a:solidFill>
+                  <a:srgbClr val="BCBEC4"/>
+                </a:solidFill>
+                <a:latin typeface="Consolas"/>
+              </a:rPr>
+              <a:t>    </a:t>
+            </a:r>
+            <a:r>
+              <a:rPr sz="1200" dirty="0">
+                <a:solidFill>
+                  <a:srgbClr val="BCBEC4"/>
+                </a:solidFill>
+                <a:latin typeface="Consolas"/>
+              </a:rPr>
+              <a:t>.</a:t>
+            </a:r>
+            <a:r>
+              <a:rPr sz="1200" dirty="0">
+                <a:solidFill>
+                  <a:srgbClr val="56A8F5"/>
+                </a:solidFill>
+                <a:latin typeface="Consolas"/>
+              </a:rPr>
+              <a:t>map</a:t>
+            </a:r>
+            <a:r>
+              <a:rPr sz="1200" dirty="0">
+                <a:solidFill>
+                  <a:srgbClr val="BCBEC4"/>
+                </a:solidFill>
+                <a:latin typeface="Consolas"/>
+              </a:rPr>
+              <a:t>(</a:t>
+            </a:r>
+            <a:r>
+              <a:rPr sz="1200" dirty="0" err="1">
+                <a:solidFill>
+                  <a:srgbClr val="BCBEC4"/>
+                </a:solidFill>
+                <a:latin typeface="Consolas"/>
+              </a:rPr>
+              <a:t>titre</a:t>
+            </a:r>
+            <a:r>
+              <a:rPr sz="1200" dirty="0">
+                <a:solidFill>
+                  <a:srgbClr val="BCBEC4"/>
+                </a:solidFill>
+                <a:latin typeface="Consolas"/>
+              </a:rPr>
+              <a:t> -&gt; </a:t>
+            </a:r>
+            <a:r>
+              <a:rPr sz="1200" dirty="0" err="1">
+                <a:solidFill>
+                  <a:srgbClr val="BCBEC4"/>
+                </a:solidFill>
+                <a:latin typeface="Consolas"/>
+              </a:rPr>
+              <a:t>titre.</a:t>
+            </a:r>
+            <a:r>
+              <a:rPr sz="1200" dirty="0" err="1">
+                <a:solidFill>
+                  <a:srgbClr val="56A8F5"/>
+                </a:solidFill>
+                <a:latin typeface="Consolas"/>
+              </a:rPr>
+              <a:t>toUpperCase</a:t>
+            </a:r>
+            <a:r>
+              <a:rPr sz="1200" dirty="0">
+                <a:solidFill>
+                  <a:srgbClr val="BCBEC4"/>
+                </a:solidFill>
+                <a:latin typeface="Consolas"/>
+              </a:rPr>
+              <a:t>()) </a:t>
+            </a:r>
+            <a:br>
+              <a:rPr lang="nl-BE" sz="1200" dirty="0">
+                <a:solidFill>
+                  <a:srgbClr val="BCBEC4"/>
+                </a:solidFill>
+                <a:latin typeface="Consolas"/>
+              </a:rPr>
+            </a:br>
+            <a:r>
+              <a:rPr lang="nl-BE" sz="1200" dirty="0">
+                <a:solidFill>
+                  <a:srgbClr val="BCBEC4"/>
+                </a:solidFill>
+                <a:latin typeface="Consolas"/>
+              </a:rPr>
+              <a:t>    </a:t>
+            </a:r>
+            <a:r>
+              <a:rPr sz="1200" dirty="0">
+                <a:solidFill>
+                  <a:srgbClr val="BCBEC4"/>
+                </a:solidFill>
+                <a:latin typeface="Consolas"/>
+              </a:rPr>
+              <a:t>.</a:t>
+            </a:r>
+            <a:r>
+              <a:rPr sz="1200" dirty="0">
+                <a:solidFill>
+                  <a:srgbClr val="56A8F5"/>
+                </a:solidFill>
+                <a:latin typeface="Consolas"/>
+              </a:rPr>
+              <a:t>collect</a:t>
+            </a:r>
+            <a:r>
+              <a:rPr sz="1200" dirty="0">
+                <a:solidFill>
+                  <a:srgbClr val="BCBEC4"/>
+                </a:solidFill>
+                <a:latin typeface="Consolas"/>
+              </a:rPr>
+              <a:t>(</a:t>
+            </a:r>
+            <a:r>
+              <a:rPr sz="1200" dirty="0" err="1">
+                <a:solidFill>
+                  <a:srgbClr val="BCBEC4"/>
+                </a:solidFill>
+                <a:latin typeface="Consolas"/>
+              </a:rPr>
+              <a:t>Collectors.</a:t>
+            </a:r>
+            <a:r>
+              <a:rPr sz="1200" dirty="0" err="1">
+                <a:solidFill>
+                  <a:srgbClr val="56A8F5"/>
+                </a:solidFill>
+                <a:latin typeface="Consolas"/>
+              </a:rPr>
+              <a:t>joining</a:t>
+            </a:r>
+            <a:r>
+              <a:rPr sz="1200" dirty="0">
+                <a:solidFill>
+                  <a:srgbClr val="BCBEC4"/>
+                </a:solidFill>
+                <a:latin typeface="Consolas"/>
+              </a:rPr>
+              <a:t>(</a:t>
+            </a:r>
+            <a:r>
+              <a:rPr sz="1200" dirty="0">
+                <a:solidFill>
+                  <a:srgbClr val="6AAB73"/>
+                </a:solidFill>
+                <a:latin typeface="Consolas"/>
+              </a:rPr>
+              <a:t>", "</a:t>
+            </a:r>
+            <a:r>
+              <a:rPr sz="1200" dirty="0">
+                <a:solidFill>
+                  <a:srgbClr val="BCBEC4"/>
+                </a:solidFill>
+                <a:latin typeface="Consolas"/>
+              </a:rPr>
+              <a:t>));</a:t>
+            </a:r>
+            <a:endParaRPr sz="1200" dirty="0">
+              <a:solidFill>
+                <a:srgbClr val="7A7E85"/>
+              </a:solidFill>
+              <a:latin typeface="Consolas"/>
+            </a:endParaRPr>
+          </a:p>
+        </p:txBody>
+      </p:sp>
     </p:spTree>
   </p:cSld>
   <p:clrMapOvr>
@@ -14864,6 +14207,9 @@
                     <p:cTn id="3" fill="hold">
                       <p:stCondLst>
                         <p:cond delay="indefinite"/>
+                        <p:cond evt="onBegin" delay="0">
+                          <p:tn val="2"/>
+                        </p:cond>
                       </p:stCondLst>
                       <p:childTnLst>
                         <p:par>
@@ -14873,7 +14219,7 @@
                             </p:stCondLst>
                             <p:childTnLst>
                               <p:par>
-                                <p:cTn id="5" presetID="22" presetClass="entr" presetSubtype="8" fill="hold" nodeType="clickEffect">
+                                <p:cTn id="5" presetID="10" presetClass="entr" presetSubtype="0" fill="hold" grpId="0" nodeType="afterEffect">
                                   <p:stCondLst>
                                     <p:cond delay="0"/>
                                   </p:stCondLst>
@@ -14886,7 +14232,7 @@
                                           </p:stCondLst>
                                         </p:cTn>
                                         <p:tgtEl>
-                                          <p:spTgt spid="19"/>
+                                          <p:spTgt spid="24"/>
                                         </p:tgtEl>
                                         <p:attrNameLst>
                                           <p:attrName>style.visibility</p:attrName>
@@ -14896,11 +14242,11 @@
                                         <p:strVal val="visible"/>
                                       </p:to>
                                     </p:set>
-                                    <p:animEffect transition="in" filter="wipe(left)">
+                                    <p:animEffect transition="in" filter="fade">
                                       <p:cBhvr>
                                         <p:cTn id="7" dur="500"/>
                                         <p:tgtEl>
-                                          <p:spTgt spid="19"/>
+                                          <p:spTgt spid="24"/>
                                         </p:tgtEl>
                                       </p:cBhvr>
                                     </p:animEffect>
@@ -14939,7 +14285,7 @@
                                           </p:stCondLst>
                                         </p:cTn>
                                         <p:tgtEl>
-                                          <p:spTgt spid="20"/>
+                                          <p:spTgt spid="19"/>
                                         </p:tgtEl>
                                         <p:attrNameLst>
                                           <p:attrName>style.visibility</p:attrName>
@@ -14953,7 +14299,7 @@
                                       <p:cBhvr>
                                         <p:cTn id="12" dur="500"/>
                                         <p:tgtEl>
-                                          <p:spTgt spid="20"/>
+                                          <p:spTgt spid="19"/>
                                         </p:tgtEl>
                                       </p:cBhvr>
                                     </p:animEffect>
@@ -14992,7 +14338,7 @@
                                           </p:stCondLst>
                                         </p:cTn>
                                         <p:tgtEl>
-                                          <p:spTgt spid="21"/>
+                                          <p:spTgt spid="20"/>
                                         </p:tgtEl>
                                         <p:attrNameLst>
                                           <p:attrName>style.visibility</p:attrName>
@@ -15006,7 +14352,7 @@
                                       <p:cBhvr>
                                         <p:cTn id="17" dur="500"/>
                                         <p:tgtEl>
-                                          <p:spTgt spid="21"/>
+                                          <p:spTgt spid="20"/>
                                         </p:tgtEl>
                                       </p:cBhvr>
                                     </p:animEffect>
@@ -15045,6 +14391,59 @@
                                           </p:stCondLst>
                                         </p:cTn>
                                         <p:tgtEl>
+                                          <p:spTgt spid="21"/>
+                                        </p:tgtEl>
+                                        <p:attrNameLst>
+                                          <p:attrName>style.visibility</p:attrName>
+                                        </p:attrNameLst>
+                                      </p:cBhvr>
+                                      <p:to>
+                                        <p:strVal val="visible"/>
+                                      </p:to>
+                                    </p:set>
+                                    <p:animEffect transition="in" filter="wipe(left)">
+                                      <p:cBhvr>
+                                        <p:cTn id="22" dur="500"/>
+                                        <p:tgtEl>
+                                          <p:spTgt spid="21"/>
+                                        </p:tgtEl>
+                                      </p:cBhvr>
+                                    </p:animEffect>
+                                  </p:childTnLst>
+                                </p:cTn>
+                              </p:par>
+                            </p:childTnLst>
+                          </p:cTn>
+                        </p:par>
+                      </p:childTnLst>
+                    </p:cTn>
+                  </p:par>
+                  <p:par>
+                    <p:cTn id="23" fill="hold">
+                      <p:stCondLst>
+                        <p:cond delay="indefinite"/>
+                      </p:stCondLst>
+                      <p:childTnLst>
+                        <p:par>
+                          <p:cTn id="24" fill="hold">
+                            <p:stCondLst>
+                              <p:cond delay="0"/>
+                            </p:stCondLst>
+                            <p:childTnLst>
+                              <p:par>
+                                <p:cTn id="25" presetID="22" presetClass="entr" presetSubtype="8" fill="hold" nodeType="clickEffect">
+                                  <p:stCondLst>
+                                    <p:cond delay="0"/>
+                                  </p:stCondLst>
+                                  <p:childTnLst>
+                                    <p:set>
+                                      <p:cBhvr>
+                                        <p:cTn id="26" dur="1" fill="hold">
+                                          <p:stCondLst>
+                                            <p:cond delay="0"/>
+                                          </p:stCondLst>
+                                        </p:cTn>
+                                        <p:tgtEl>
                                           <p:spTgt spid="22"/>
                                         </p:tgtEl>
                                         <p:attrNameLst>
@@ -15057,7 +14456,7 @@
                                     </p:set>
                                     <p:animEffect transition="in" filter="wipe(left)">
                                       <p:cBhvr>
-                                        <p:cTn id="22" dur="500"/>
+                                        <p:cTn id="27" dur="500"/>
                                         <p:tgtEl>
                                           <p:spTgt spid="22"/>
                                         </p:tgtEl>
@@ -15093,6 +14492,9 @@
         </p:cTn>
       </p:par>
     </p:tnLst>
+    <p:bldLst>
+      <p:bldP spid="24" grpId="0" animBg="1"/>
+    </p:bldLst>
   </p:timing>
 </p:sld>
 </file>
@@ -15344,7 +14746,7 @@
           <a:p>
             <a:fld id="{33C783E2-4793-4F48-A271-51A73CC37D74}" type="slidenum">
               <a:rPr lang="fr-FR" smtClean="0"/>
-              <a:t>18</a:t>
+              <a:t>19</a:t>
             </a:fld>
             <a:endParaRPr lang="fr-FR"/>
           </a:p>
@@ -16218,7 +15620,7 @@
           <a:p>
             <a:fld id="{33C783E2-4793-4F48-A271-51A73CC37D74}" type="slidenum">
               <a:rPr lang="fr-FR" smtClean="0"/>
-              <a:t>19</a:t>
+              <a:t>20</a:t>
             </a:fld>
             <a:endParaRPr lang="fr-FR"/>
           </a:p>
@@ -16592,7 +15994,7 @@
           <a:p>
             <a:fld id="{33C783E2-4793-4F48-A271-51A73CC37D74}" type="slidenum">
               <a:rPr lang="fr-FR" smtClean="0"/>
-              <a:t>20</a:t>
+              <a:t>21</a:t>
             </a:fld>
             <a:endParaRPr lang="fr-FR"/>
           </a:p>

</xml_diff>